<commit_message>
chore: initialize git repository and update project documentation
</commit_message>
<xml_diff>
--- a/docs/SL_온라인PT_발표자료.pptx
+++ b/docs/SL_온라인PT_발표자료.pptx
@@ -4036,8 +4036,8 @@
         </p:nvSpPr>
         <p:spPr>
           <a:xfrm>
-            <a:off x="731520" y="2194560"/>
-            <a:ext cx="5029200" cy="4114800"/>
+            <a:off x="731520" y="2103120"/>
+            <a:ext cx="5029200" cy="457200"/>
           </a:xfrm>
           <a:prstGeom prst="rect">
             <a:avLst/>
@@ -4049,25 +4049,6 @@
             <a:spAutoFit/>
           </a:bodyPr>
           <a:lstStyle/>
-          <a:p>
-            <a:pPr algn="l">
-              <a:spcBef>
-                <a:spcPts val="0"/>
-              </a:spcBef>
-              <a:spcAft>
-                <a:spcPts val="1200"/>
-              </a:spcAft>
-              <a:defRPr sz="1600" b="1">
-                <a:solidFill>
-                  <a:srgbClr val="002B5C"/>
-                </a:solidFill>
-                <a:latin typeface="맑은 고딕"/>
-              </a:defRPr>
-            </a:pPr>
-            <a:r>
-              <a:t>단순히 SW 코딩 공부가 아닙니다.</a:t>
-            </a:r>
-          </a:p>
           <a:p>
             <a:pPr algn="l">
               <a:spcBef>
@@ -4076,148 +4057,15 @@
               <a:spcAft>
                 <a:spcPts val="400"/>
               </a:spcAft>
-              <a:defRPr sz="1300" b="0">
-                <a:solidFill>
-                  <a:srgbClr val="333344"/>
-                </a:solidFill>
-                <a:latin typeface="맑은 고딕"/>
-              </a:defRPr>
-            </a:pPr>
-            <a:r>
-              <a:t>차량 도어(HW)의 물리적 거동을 이해하지 못한 SW 제어는</a:t>
-            </a:r>
-          </a:p>
-          <a:p>
-            <a:pPr algn="l">
-              <a:spcBef>
-                <a:spcPts val="0"/>
-              </a:spcBef>
-              <a:spcAft>
-                <a:spcPts val="2000"/>
-              </a:spcAft>
-              <a:defRPr sz="1300" b="1">
-                <a:solidFill>
-                  <a:srgbClr val="E53335"/>
-                </a:solidFill>
-                <a:latin typeface="맑은 고딕"/>
-              </a:defRPr>
-            </a:pPr>
-            <a:r>
-              <a:t>치명적인 오작동으로 이어집니다.</a:t>
-            </a:r>
-          </a:p>
-          <a:p>
-            <a:pPr algn="l">
-              <a:spcBef>
-                <a:spcPts val="0"/>
-              </a:spcBef>
-              <a:spcAft>
-                <a:spcPts val="600"/>
-              </a:spcAft>
-              <a:defRPr sz="1300" b="0">
-                <a:solidFill>
-                  <a:srgbClr val="333344"/>
-                </a:solidFill>
-                <a:latin typeface="맑은 고딕"/>
-              </a:defRPr>
-            </a:pPr>
-            <a:r>
-              <a:t>⚠  센서 노이즈에 의한 모터 떨림</a:t>
-            </a:r>
-          </a:p>
-          <a:p>
-            <a:pPr algn="l">
-              <a:spcBef>
-                <a:spcPts val="0"/>
-              </a:spcBef>
-              <a:spcAft>
-                <a:spcPts val="1200"/>
-              </a:spcAft>
-              <a:defRPr sz="1100" b="0">
-                <a:solidFill>
-                  <a:srgbClr val="666677"/>
-                </a:solidFill>
-                <a:latin typeface="맑은 고딕"/>
-              </a:defRPr>
-            </a:pPr>
-            <a:r>
-              <a:t>    → 도어 락 모터의 불필요한 반복 작동 → HW 수명 저하</a:t>
-            </a:r>
-          </a:p>
-          <a:p>
-            <a:pPr algn="l">
-              <a:spcBef>
-                <a:spcPts val="0"/>
-              </a:spcBef>
-              <a:spcAft>
-                <a:spcPts val="600"/>
-              </a:spcAft>
-              <a:defRPr sz="1300" b="0">
-                <a:solidFill>
-                  <a:srgbClr val="333344"/>
-                </a:solidFill>
-                <a:latin typeface="맑은 고딕"/>
-              </a:defRPr>
-            </a:pPr>
-            <a:r>
-              <a:t>⚠  고장 시 방치 (No Fail-Safe)</a:t>
-            </a:r>
-          </a:p>
-          <a:p>
-            <a:pPr algn="l">
-              <a:spcBef>
-                <a:spcPts val="0"/>
-              </a:spcBef>
-              <a:spcAft>
-                <a:spcPts val="1200"/>
-              </a:spcAft>
-              <a:defRPr sz="1100" b="0">
-                <a:solidFill>
-                  <a:srgbClr val="666677"/>
-                </a:solidFill>
-                <a:latin typeface="맑은 고딕"/>
-              </a:defRPr>
-            </a:pPr>
-            <a:r>
-              <a:t>    → 센서 고장 인지 불가 → 안전 기능 무력화 → 승객 위험</a:t>
-            </a:r>
-          </a:p>
-          <a:p>
-            <a:pPr algn="l">
-              <a:spcBef>
-                <a:spcPts val="0"/>
-              </a:spcBef>
-              <a:spcAft>
-                <a:spcPts val="600"/>
-              </a:spcAft>
-              <a:defRPr sz="1300" b="0">
-                <a:solidFill>
-                  <a:srgbClr val="333344"/>
-                </a:solidFill>
-                <a:latin typeface="맑은 고딕"/>
-              </a:defRPr>
-            </a:pPr>
-            <a:r>
-              <a:t>⚠  경계값 떨림에 의한 오판단</a:t>
-            </a:r>
-          </a:p>
-          <a:p>
-            <a:pPr algn="l">
-              <a:spcBef>
-                <a:spcPts val="0"/>
-              </a:spcBef>
-              <a:spcAft>
-                <a:spcPts val="2000"/>
-              </a:spcAft>
-              <a:defRPr sz="1100" b="0">
-                <a:solidFill>
-                  <a:srgbClr val="666677"/>
-                </a:solidFill>
-                <a:latin typeface="맑은 고딕"/>
-              </a:defRPr>
-            </a:pPr>
-            <a:r>
-              <a:t>    → ON/OFF 반복 토글 → 운전자 혼란 + 시스템 불신</a:t>
+              <a:defRPr sz="1500" b="1">
+                <a:solidFill>
+                  <a:srgbClr val="002B5C"/>
+                </a:solidFill>
+                <a:latin typeface="맑은 고딕"/>
+              </a:defRPr>
+            </a:pPr>
+            <a:r>
+              <a:t>▎ 차일드 락의 기계적 특성과 SW 한계</a:t>
             </a:r>
           </a:p>
         </p:txBody>
@@ -4230,8 +4078,8 @@
         </p:nvSpPr>
         <p:spPr>
           <a:xfrm>
-            <a:off x="6400800" y="2194560"/>
-            <a:ext cx="5029200" cy="1280160"/>
+            <a:off x="731520" y="2651760"/>
+            <a:ext cx="5029200" cy="1371600"/>
           </a:xfrm>
           <a:prstGeom prst="roundRect">
             <a:avLst/>
@@ -4274,8 +4122,8 @@
         </p:nvSpPr>
         <p:spPr>
           <a:xfrm>
-            <a:off x="6675120" y="2286000"/>
-            <a:ext cx="4572000" cy="1097280"/>
+            <a:off x="1005840" y="2743200"/>
+            <a:ext cx="4572000" cy="1188720"/>
           </a:xfrm>
           <a:prstGeom prst="rect">
             <a:avLst/>
@@ -4293,9 +4141,9 @@
                 <a:spcPts val="0"/>
               </a:spcBef>
               <a:spcAft>
-                <a:spcPts val="600"/>
+                <a:spcPts val="800"/>
               </a:spcAft>
-              <a:defRPr sz="1400" b="1">
+              <a:defRPr sz="1300" b="1">
                 <a:solidFill>
                   <a:srgbClr val="0047AB"/>
                 </a:solidFill>
@@ -4303,7 +4151,7 @@
               </a:defRPr>
             </a:pPr>
             <a:r>
-              <a:t>🔧  HW 관점 문제</a:t>
+              <a:t>🔧  소형 DC 모터 + 기어 트레인의 물리적 한계</a:t>
             </a:r>
           </a:p>
           <a:p>
@@ -4322,97 +4170,7 @@
               </a:defRPr>
             </a:pPr>
             <a:r>
-              <a:t>도어 래치/모터의 기계적 마모, 관성 지연,</a:t>
-            </a:r>
-            <a:br/>
-            <a:r>
-              <a:t>온도에 의한 센서 출력 드리프트를 SW가 보상해야 함</a:t>
-            </a:r>
-          </a:p>
-        </p:txBody>
-      </p:sp>
-      <p:sp>
-        <p:nvSpPr>
-          <p:cNvPr id="10" name="Rounded Rectangle 9"/>
-          <p:cNvSpPr/>
-          <p:nvPr/>
-        </p:nvSpPr>
-        <p:spPr>
-          <a:xfrm>
-            <a:off x="6400800" y="3749039"/>
-            <a:ext cx="5029200" cy="1280160"/>
-          </a:xfrm>
-          <a:prstGeom prst="roundRect">
-            <a:avLst/>
-          </a:prstGeom>
-          <a:solidFill>
-            <a:srgbClr val="E8F2FF"/>
-          </a:solidFill>
-          <a:ln>
-            <a:noFill/>
-          </a:ln>
-          <a:effectLst/>
-        </p:spPr>
-        <p:style>
-          <a:lnRef idx="1">
-            <a:schemeClr val="accent1"/>
-          </a:lnRef>
-          <a:fillRef idx="3">
-            <a:schemeClr val="accent1"/>
-          </a:fillRef>
-          <a:effectRef idx="2">
-            <a:schemeClr val="accent1"/>
-          </a:effectRef>
-          <a:fontRef idx="minor">
-            <a:schemeClr val="lt1"/>
-          </a:fontRef>
-        </p:style>
-        <p:txBody>
-          <a:bodyPr rtlCol="0" anchor="ctr"/>
-          <a:lstStyle/>
-          <a:p>
-            <a:pPr algn="ctr"/>
-          </a:p>
-        </p:txBody>
-      </p:sp>
-      <p:sp>
-        <p:nvSpPr>
-          <p:cNvPr id="11" name="TextBox 10"/>
-          <p:cNvSpPr txBox="1"/>
-          <p:nvPr/>
-        </p:nvSpPr>
-        <p:spPr>
-          <a:xfrm>
-            <a:off x="6675120" y="3840480"/>
-            <a:ext cx="4572000" cy="1097280"/>
-          </a:xfrm>
-          <a:prstGeom prst="rect">
-            <a:avLst/>
-          </a:prstGeom>
-          <a:noFill/>
-        </p:spPr>
-        <p:txBody>
-          <a:bodyPr wrap="square">
-            <a:spAutoFit/>
-          </a:bodyPr>
-          <a:lstStyle/>
-          <a:p>
-            <a:pPr algn="l">
-              <a:spcBef>
-                <a:spcPts val="0"/>
-              </a:spcBef>
-              <a:spcAft>
-                <a:spcPts val="600"/>
-              </a:spcAft>
-              <a:defRPr sz="1400" b="1">
-                <a:solidFill>
-                  <a:srgbClr val="0047AB"/>
-                </a:solidFill>
-                <a:latin typeface="맑은 고딕"/>
-              </a:defRPr>
-            </a:pPr>
-            <a:r>
-              <a:t>💻  SW 관점 문제</a:t>
+              <a:t>• 응답 지연(Response Delay): 모터 구동 → 래치 체결까지 수십 ms 소요</a:t>
             </a:r>
           </a:p>
           <a:p>
@@ -4431,97 +4189,7 @@
               </a:defRPr>
             </a:pPr>
             <a:r>
-              <a:t>단순 if-else 로직으로는 경계값 떨림/센서 오류에</a:t>
-            </a:r>
-            <a:br/>
-            <a:r>
-              <a:t>대응 불가 → Hysteresis + Fail-Safe 설계 필수</a:t>
-            </a:r>
-          </a:p>
-        </p:txBody>
-      </p:sp>
-      <p:sp>
-        <p:nvSpPr>
-          <p:cNvPr id="12" name="Rounded Rectangle 11"/>
-          <p:cNvSpPr/>
-          <p:nvPr/>
-        </p:nvSpPr>
-        <p:spPr>
-          <a:xfrm>
-            <a:off x="6400800" y="5303520"/>
-            <a:ext cx="5029200" cy="1005840"/>
-          </a:xfrm>
-          <a:prstGeom prst="roundRect">
-            <a:avLst/>
-          </a:prstGeom>
-          <a:solidFill>
-            <a:srgbClr val="0047AB"/>
-          </a:solidFill>
-          <a:ln>
-            <a:noFill/>
-          </a:ln>
-          <a:effectLst/>
-        </p:spPr>
-        <p:style>
-          <a:lnRef idx="1">
-            <a:schemeClr val="accent1"/>
-          </a:lnRef>
-          <a:fillRef idx="3">
-            <a:schemeClr val="accent1"/>
-          </a:fillRef>
-          <a:effectRef idx="2">
-            <a:schemeClr val="accent1"/>
-          </a:effectRef>
-          <a:fontRef idx="minor">
-            <a:schemeClr val="lt1"/>
-          </a:fontRef>
-        </p:style>
-        <p:txBody>
-          <a:bodyPr rtlCol="0" anchor="ctr"/>
-          <a:lstStyle/>
-          <a:p>
-            <a:pPr algn="ctr"/>
-          </a:p>
-        </p:txBody>
-      </p:sp>
-      <p:sp>
-        <p:nvSpPr>
-          <p:cNvPr id="13" name="TextBox 12"/>
-          <p:cNvSpPr txBox="1"/>
-          <p:nvPr/>
-        </p:nvSpPr>
-        <p:spPr>
-          <a:xfrm>
-            <a:off x="6675120" y="5394960"/>
-            <a:ext cx="4572000" cy="822960"/>
-          </a:xfrm>
-          <a:prstGeom prst="rect">
-            <a:avLst/>
-          </a:prstGeom>
-          <a:noFill/>
-        </p:spPr>
-        <p:txBody>
-          <a:bodyPr wrap="square">
-            <a:spAutoFit/>
-          </a:bodyPr>
-          <a:lstStyle/>
-          <a:p>
-            <a:pPr algn="l">
-              <a:spcBef>
-                <a:spcPts val="0"/>
-              </a:spcBef>
-              <a:spcAft>
-                <a:spcPts val="600"/>
-              </a:spcAft>
-              <a:defRPr sz="1400" b="1">
-                <a:solidFill>
-                  <a:srgbClr val="FFFFFF"/>
-                </a:solidFill>
-                <a:latin typeface="맑은 고딕"/>
-              </a:defRPr>
-            </a:pPr>
-            <a:r>
-              <a:t>✅  해결 접근: 기계공학 + SW 융합</a:t>
+              <a:t>• 기어 백래시(Backlash): 기어 치합 유격으로 인한 위치 불확정 구간 존재</a:t>
             </a:r>
           </a:p>
           <a:p>
@@ -4534,13 +4202,242 @@
               </a:spcAft>
               <a:defRPr sz="1100" b="0">
                 <a:solidFill>
-                  <a:srgbClr val="CCE5FF"/>
-                </a:solidFill>
-                <a:latin typeface="맑은 고딕"/>
-              </a:defRPr>
-            </a:pPr>
-            <a:r>
-              <a:t>물리적 거동 이해 → 히스테리시스 설계 → ASIL-B Fail-Safe 구현</a:t>
+                  <a:srgbClr val="333344"/>
+                </a:solidFill>
+                <a:latin typeface="맑은 고딕"/>
+              </a:defRPr>
+            </a:pPr>
+            <a:r>
+              <a:t>• 관성 지연(Inertia): 모터 정지 명령 후에도 관성에 의해 회전 지속</a:t>
+            </a:r>
+          </a:p>
+        </p:txBody>
+      </p:sp>
+      <p:sp>
+        <p:nvSpPr>
+          <p:cNvPr id="10" name="Rounded Rectangle 9"/>
+          <p:cNvSpPr/>
+          <p:nvPr/>
+        </p:nvSpPr>
+        <p:spPr>
+          <a:xfrm>
+            <a:off x="731520" y="4206240"/>
+            <a:ext cx="5029200" cy="1463040"/>
+          </a:xfrm>
+          <a:prstGeom prst="roundRect">
+            <a:avLst/>
+          </a:prstGeom>
+          <a:solidFill>
+            <a:srgbClr val="FFECEC"/>
+          </a:solidFill>
+          <a:ln>
+            <a:noFill/>
+          </a:ln>
+          <a:effectLst/>
+        </p:spPr>
+        <p:style>
+          <a:lnRef idx="1">
+            <a:schemeClr val="accent1"/>
+          </a:lnRef>
+          <a:fillRef idx="3">
+            <a:schemeClr val="accent1"/>
+          </a:fillRef>
+          <a:effectRef idx="2">
+            <a:schemeClr val="accent1"/>
+          </a:effectRef>
+          <a:fontRef idx="minor">
+            <a:schemeClr val="lt1"/>
+          </a:fontRef>
+        </p:style>
+        <p:txBody>
+          <a:bodyPr rtlCol="0" anchor="ctr"/>
+          <a:lstStyle/>
+          <a:p>
+            <a:pPr algn="ctr"/>
+          </a:p>
+        </p:txBody>
+      </p:sp>
+      <p:sp>
+        <p:nvSpPr>
+          <p:cNvPr id="11" name="TextBox 10"/>
+          <p:cNvSpPr txBox="1"/>
+          <p:nvPr/>
+        </p:nvSpPr>
+        <p:spPr>
+          <a:xfrm>
+            <a:off x="1005840" y="4297680"/>
+            <a:ext cx="4572000" cy="1280160"/>
+          </a:xfrm>
+          <a:prstGeom prst="rect">
+            <a:avLst/>
+          </a:prstGeom>
+          <a:noFill/>
+        </p:spPr>
+        <p:txBody>
+          <a:bodyPr wrap="square">
+            <a:spAutoFit/>
+          </a:bodyPr>
+          <a:lstStyle/>
+          <a:p>
+            <a:pPr algn="l">
+              <a:spcBef>
+                <a:spcPts val="0"/>
+              </a:spcBef>
+              <a:spcAft>
+                <a:spcPts val="800"/>
+              </a:spcAft>
+              <a:defRPr sz="1300" b="1">
+                <a:solidFill>
+                  <a:srgbClr val="E53335"/>
+                </a:solidFill>
+                <a:latin typeface="맑은 고딕"/>
+              </a:defRPr>
+            </a:pPr>
+            <a:r>
+              <a:t>⚠  SW가 센서 노이즈를 그대로 전달하면?</a:t>
+            </a:r>
+          </a:p>
+          <a:p>
+            <a:pPr algn="l">
+              <a:spcBef>
+                <a:spcPts val="0"/>
+              </a:spcBef>
+              <a:spcAft>
+                <a:spcPts val="600"/>
+              </a:spcAft>
+              <a:defRPr sz="1200" b="0">
+                <a:solidFill>
+                  <a:srgbClr val="333344"/>
+                </a:solidFill>
+                <a:latin typeface="맑은 고딕"/>
+              </a:defRPr>
+            </a:pPr>
+            <a:r>
+              <a:t>센서 경계값 떨림 → 모터에 초당 수십 번 ON/OFF 명령</a:t>
+            </a:r>
+          </a:p>
+          <a:p>
+            <a:pPr algn="l">
+              <a:spcBef>
+                <a:spcPts val="0"/>
+              </a:spcBef>
+              <a:spcAft>
+                <a:spcPts val="600"/>
+              </a:spcAft>
+              <a:defRPr sz="1200" b="1">
+                <a:solidFill>
+                  <a:srgbClr val="E53335"/>
+                </a:solidFill>
+                <a:latin typeface="맑은 고딕"/>
+              </a:defRPr>
+            </a:pPr>
+            <a:r>
+              <a:t>👉 모터 소손(Burn-out) 및 기어 마모 → 치명적 HW 파손</a:t>
+            </a:r>
+          </a:p>
+          <a:p>
+            <a:pPr algn="l">
+              <a:spcBef>
+                <a:spcPts val="0"/>
+              </a:spcBef>
+              <a:spcAft>
+                <a:spcPts val="400"/>
+              </a:spcAft>
+              <a:defRPr sz="1200" b="1">
+                <a:solidFill>
+                  <a:srgbClr val="E53335"/>
+                </a:solidFill>
+                <a:latin typeface="맑은 고딕"/>
+              </a:defRPr>
+            </a:pPr>
+            <a:r>
+              <a:t>👉 래치 체결 불완전 → 차일드 락 기능 상실 → 승객 안전 위협</a:t>
+            </a:r>
+          </a:p>
+        </p:txBody>
+      </p:sp>
+      <p:sp>
+        <p:nvSpPr>
+          <p:cNvPr id="12" name="Rounded Rectangle 11"/>
+          <p:cNvSpPr/>
+          <p:nvPr/>
+        </p:nvSpPr>
+        <p:spPr>
+          <a:xfrm>
+            <a:off x="731520" y="5852160"/>
+            <a:ext cx="5029200" cy="548640"/>
+          </a:xfrm>
+          <a:prstGeom prst="roundRect">
+            <a:avLst/>
+          </a:prstGeom>
+          <a:solidFill>
+            <a:srgbClr val="0047AB"/>
+          </a:solidFill>
+          <a:ln>
+            <a:noFill/>
+          </a:ln>
+          <a:effectLst/>
+        </p:spPr>
+        <p:style>
+          <a:lnRef idx="1">
+            <a:schemeClr val="accent1"/>
+          </a:lnRef>
+          <a:fillRef idx="3">
+            <a:schemeClr val="accent1"/>
+          </a:fillRef>
+          <a:effectRef idx="2">
+            <a:schemeClr val="accent1"/>
+          </a:effectRef>
+          <a:fontRef idx="minor">
+            <a:schemeClr val="lt1"/>
+          </a:fontRef>
+        </p:style>
+        <p:txBody>
+          <a:bodyPr rtlCol="0" anchor="ctr"/>
+          <a:lstStyle/>
+          <a:p>
+            <a:pPr algn="ctr"/>
+          </a:p>
+        </p:txBody>
+      </p:sp>
+      <p:sp>
+        <p:nvSpPr>
+          <p:cNvPr id="13" name="TextBox 12"/>
+          <p:cNvSpPr txBox="1"/>
+          <p:nvPr/>
+        </p:nvSpPr>
+        <p:spPr>
+          <a:xfrm>
+            <a:off x="1005840" y="5897880"/>
+            <a:ext cx="4572000" cy="411480"/>
+          </a:xfrm>
+          <a:prstGeom prst="rect">
+            <a:avLst/>
+          </a:prstGeom>
+          <a:noFill/>
+        </p:spPr>
+        <p:txBody>
+          <a:bodyPr wrap="square">
+            <a:spAutoFit/>
+          </a:bodyPr>
+          <a:lstStyle/>
+          <a:p>
+            <a:pPr algn="l">
+              <a:spcBef>
+                <a:spcPts val="0"/>
+              </a:spcBef>
+              <a:spcAft>
+                <a:spcPts val="400"/>
+              </a:spcAft>
+              <a:defRPr sz="1200" b="1">
+                <a:solidFill>
+                  <a:srgbClr val="FFFFFF"/>
+                </a:solidFill>
+                <a:latin typeface="맑은 고딕"/>
+              </a:defRPr>
+            </a:pPr>
+            <a:r>
+              <a:t>✅  결론: 모터의 물리적 한계를 보호하는 SW 설계가 필수</a:t>
             </a:r>
           </a:p>
         </p:txBody>
@@ -4548,6 +4445,432 @@
       <p:sp>
         <p:nvSpPr>
           <p:cNvPr id="14" name="TextBox 13"/>
+          <p:cNvSpPr txBox="1"/>
+          <p:nvPr/>
+        </p:nvSpPr>
+        <p:spPr>
+          <a:xfrm>
+            <a:off x="6400800" y="2103120"/>
+            <a:ext cx="5029200" cy="457200"/>
+          </a:xfrm>
+          <a:prstGeom prst="rect">
+            <a:avLst/>
+          </a:prstGeom>
+          <a:noFill/>
+        </p:spPr>
+        <p:txBody>
+          <a:bodyPr wrap="square">
+            <a:spAutoFit/>
+          </a:bodyPr>
+          <a:lstStyle/>
+          <a:p>
+            <a:pPr algn="l">
+              <a:spcBef>
+                <a:spcPts val="0"/>
+              </a:spcBef>
+              <a:spcAft>
+                <a:spcPts val="400"/>
+              </a:spcAft>
+              <a:defRPr sz="1500" b="1">
+                <a:solidFill>
+                  <a:srgbClr val="002B5C"/>
+                </a:solidFill>
+                <a:latin typeface="맑은 고딕"/>
+              </a:defRPr>
+            </a:pPr>
+            <a:r>
+              <a:t>▎ SW 관점에서 정의한 3가지 핵심 문제</a:t>
+            </a:r>
+          </a:p>
+        </p:txBody>
+      </p:sp>
+      <p:sp>
+        <p:nvSpPr>
+          <p:cNvPr id="15" name="Rounded Rectangle 14"/>
+          <p:cNvSpPr/>
+          <p:nvPr/>
+        </p:nvSpPr>
+        <p:spPr>
+          <a:xfrm>
+            <a:off x="6400800" y="2651760"/>
+            <a:ext cx="5029200" cy="1143000"/>
+          </a:xfrm>
+          <a:prstGeom prst="roundRect">
+            <a:avLst/>
+          </a:prstGeom>
+          <a:solidFill>
+            <a:srgbClr val="FFF8E1"/>
+          </a:solidFill>
+          <a:ln>
+            <a:noFill/>
+          </a:ln>
+          <a:effectLst/>
+        </p:spPr>
+        <p:style>
+          <a:lnRef idx="1">
+            <a:schemeClr val="accent1"/>
+          </a:lnRef>
+          <a:fillRef idx="3">
+            <a:schemeClr val="accent1"/>
+          </a:fillRef>
+          <a:effectRef idx="2">
+            <a:schemeClr val="accent1"/>
+          </a:effectRef>
+          <a:fontRef idx="minor">
+            <a:schemeClr val="lt1"/>
+          </a:fontRef>
+        </p:style>
+        <p:txBody>
+          <a:bodyPr rtlCol="0" anchor="ctr"/>
+          <a:lstStyle/>
+          <a:p>
+            <a:pPr algn="ctr"/>
+          </a:p>
+        </p:txBody>
+      </p:sp>
+      <p:sp>
+        <p:nvSpPr>
+          <p:cNvPr id="16" name="TextBox 15"/>
+          <p:cNvSpPr txBox="1"/>
+          <p:nvPr/>
+        </p:nvSpPr>
+        <p:spPr>
+          <a:xfrm>
+            <a:off x="6675120" y="2697480"/>
+            <a:ext cx="4572000" cy="1051560"/>
+          </a:xfrm>
+          <a:prstGeom prst="rect">
+            <a:avLst/>
+          </a:prstGeom>
+          <a:noFill/>
+        </p:spPr>
+        <p:txBody>
+          <a:bodyPr wrap="square">
+            <a:spAutoFit/>
+          </a:bodyPr>
+          <a:lstStyle/>
+          <a:p>
+            <a:pPr algn="l">
+              <a:spcBef>
+                <a:spcPts val="0"/>
+              </a:spcBef>
+              <a:spcAft>
+                <a:spcPts val="400"/>
+              </a:spcAft>
+              <a:defRPr sz="1300" b="1">
+                <a:solidFill>
+                  <a:srgbClr val="FF6B35"/>
+                </a:solidFill>
+                <a:latin typeface="맑은 고딕"/>
+              </a:defRPr>
+            </a:pPr>
+            <a:r>
+              <a:t>①  경계값 떨림에 의한 오판단</a:t>
+            </a:r>
+          </a:p>
+          <a:p>
+            <a:pPr algn="l">
+              <a:spcBef>
+                <a:spcPts val="0"/>
+              </a:spcBef>
+              <a:spcAft>
+                <a:spcPts val="400"/>
+              </a:spcAft>
+              <a:defRPr sz="1000" b="0">
+                <a:solidFill>
+                  <a:srgbClr val="333344"/>
+                </a:solidFill>
+                <a:latin typeface="맑은 고딕"/>
+              </a:defRPr>
+            </a:pPr>
+            <a:r>
+              <a:t>단순 if-else 비교 → 센서 노이즈에 의한</a:t>
+            </a:r>
+            <a:br/>
+            <a:r>
+              <a:t>ON/OFF 반복 토글 → 모터 수명 저하</a:t>
+            </a:r>
+          </a:p>
+          <a:p>
+            <a:pPr algn="l">
+              <a:spcBef>
+                <a:spcPts val="0"/>
+              </a:spcBef>
+              <a:spcAft>
+                <a:spcPts val="400"/>
+              </a:spcAft>
+              <a:defRPr sz="1000" b="1">
+                <a:solidFill>
+                  <a:srgbClr val="FF6B35"/>
+                </a:solidFill>
+                <a:latin typeface="맑은 고딕"/>
+              </a:defRPr>
+            </a:pPr>
+            <a:r>
+              <a:t>→ 해결: 히스테리시스 밴드 (500ms/1000ms)</a:t>
+            </a:r>
+          </a:p>
+        </p:txBody>
+      </p:sp>
+      <p:sp>
+        <p:nvSpPr>
+          <p:cNvPr id="17" name="Rounded Rectangle 16"/>
+          <p:cNvSpPr/>
+          <p:nvPr/>
+        </p:nvSpPr>
+        <p:spPr>
+          <a:xfrm>
+            <a:off x="6400800" y="3931920"/>
+            <a:ext cx="5029200" cy="1143000"/>
+          </a:xfrm>
+          <a:prstGeom prst="roundRect">
+            <a:avLst/>
+          </a:prstGeom>
+          <a:solidFill>
+            <a:srgbClr val="FFECEC"/>
+          </a:solidFill>
+          <a:ln>
+            <a:noFill/>
+          </a:ln>
+          <a:effectLst/>
+        </p:spPr>
+        <p:style>
+          <a:lnRef idx="1">
+            <a:schemeClr val="accent1"/>
+          </a:lnRef>
+          <a:fillRef idx="3">
+            <a:schemeClr val="accent1"/>
+          </a:fillRef>
+          <a:effectRef idx="2">
+            <a:schemeClr val="accent1"/>
+          </a:effectRef>
+          <a:fontRef idx="minor">
+            <a:schemeClr val="lt1"/>
+          </a:fontRef>
+        </p:style>
+        <p:txBody>
+          <a:bodyPr rtlCol="0" anchor="ctr"/>
+          <a:lstStyle/>
+          <a:p>
+            <a:pPr algn="ctr"/>
+          </a:p>
+        </p:txBody>
+      </p:sp>
+      <p:sp>
+        <p:nvSpPr>
+          <p:cNvPr id="18" name="TextBox 17"/>
+          <p:cNvSpPr txBox="1"/>
+          <p:nvPr/>
+        </p:nvSpPr>
+        <p:spPr>
+          <a:xfrm>
+            <a:off x="6675120" y="3977640"/>
+            <a:ext cx="4572000" cy="1051560"/>
+          </a:xfrm>
+          <a:prstGeom prst="rect">
+            <a:avLst/>
+          </a:prstGeom>
+          <a:noFill/>
+        </p:spPr>
+        <p:txBody>
+          <a:bodyPr wrap="square">
+            <a:spAutoFit/>
+          </a:bodyPr>
+          <a:lstStyle/>
+          <a:p>
+            <a:pPr algn="l">
+              <a:spcBef>
+                <a:spcPts val="0"/>
+              </a:spcBef>
+              <a:spcAft>
+                <a:spcPts val="400"/>
+              </a:spcAft>
+              <a:defRPr sz="1300" b="1">
+                <a:solidFill>
+                  <a:srgbClr val="E53335"/>
+                </a:solidFill>
+                <a:latin typeface="맑은 고딕"/>
+              </a:defRPr>
+            </a:pPr>
+            <a:r>
+              <a:t>②  센서 고장 시 방치 (No Fail-Safe)</a:t>
+            </a:r>
+          </a:p>
+          <a:p>
+            <a:pPr algn="l">
+              <a:spcBef>
+                <a:spcPts val="0"/>
+              </a:spcBef>
+              <a:spcAft>
+                <a:spcPts val="400"/>
+              </a:spcAft>
+              <a:defRPr sz="1000" b="0">
+                <a:solidFill>
+                  <a:srgbClr val="333344"/>
+                </a:solidFill>
+                <a:latin typeface="맑은 고딕"/>
+              </a:defRPr>
+            </a:pPr>
+            <a:r>
+              <a:t>센서 고장 인지 불가 → 차일드 락 풀림 방치</a:t>
+            </a:r>
+            <a:br/>
+            <a:r>
+              <a:t>→ 아이가 문을 열고 도로로 추락 위험</a:t>
+            </a:r>
+          </a:p>
+          <a:p>
+            <a:pPr algn="l">
+              <a:spcBef>
+                <a:spcPts val="0"/>
+              </a:spcBef>
+              <a:spcAft>
+                <a:spcPts val="400"/>
+              </a:spcAft>
+              <a:defRPr sz="1000" b="1">
+                <a:solidFill>
+                  <a:srgbClr val="E53335"/>
+                </a:solidFill>
+                <a:latin typeface="맑은 고딕"/>
+              </a:defRPr>
+            </a:pPr>
+            <a:r>
+              <a:t>→ 해결: SAFE_LOCKED 강제 잠금 정책</a:t>
+            </a:r>
+          </a:p>
+        </p:txBody>
+      </p:sp>
+      <p:sp>
+        <p:nvSpPr>
+          <p:cNvPr id="19" name="Rounded Rectangle 18"/>
+          <p:cNvSpPr/>
+          <p:nvPr/>
+        </p:nvSpPr>
+        <p:spPr>
+          <a:xfrm>
+            <a:off x="6400800" y="5212079"/>
+            <a:ext cx="5029200" cy="1143000"/>
+          </a:xfrm>
+          <a:prstGeom prst="roundRect">
+            <a:avLst/>
+          </a:prstGeom>
+          <a:solidFill>
+            <a:srgbClr val="E8F2FF"/>
+          </a:solidFill>
+          <a:ln>
+            <a:noFill/>
+          </a:ln>
+          <a:effectLst/>
+        </p:spPr>
+        <p:style>
+          <a:lnRef idx="1">
+            <a:schemeClr val="accent1"/>
+          </a:lnRef>
+          <a:fillRef idx="3">
+            <a:schemeClr val="accent1"/>
+          </a:fillRef>
+          <a:effectRef idx="2">
+            <a:schemeClr val="accent1"/>
+          </a:effectRef>
+          <a:fontRef idx="minor">
+            <a:schemeClr val="lt1"/>
+          </a:fontRef>
+        </p:style>
+        <p:txBody>
+          <a:bodyPr rtlCol="0" anchor="ctr"/>
+          <a:lstStyle/>
+          <a:p>
+            <a:pPr algn="ctr"/>
+          </a:p>
+        </p:txBody>
+      </p:sp>
+      <p:sp>
+        <p:nvSpPr>
+          <p:cNvPr id="20" name="TextBox 19"/>
+          <p:cNvSpPr txBox="1"/>
+          <p:nvPr/>
+        </p:nvSpPr>
+        <p:spPr>
+          <a:xfrm>
+            <a:off x="6675120" y="5257799"/>
+            <a:ext cx="4572000" cy="1051560"/>
+          </a:xfrm>
+          <a:prstGeom prst="rect">
+            <a:avLst/>
+          </a:prstGeom>
+          <a:noFill/>
+        </p:spPr>
+        <p:txBody>
+          <a:bodyPr wrap="square">
+            <a:spAutoFit/>
+          </a:bodyPr>
+          <a:lstStyle/>
+          <a:p>
+            <a:pPr algn="l">
+              <a:spcBef>
+                <a:spcPts val="0"/>
+              </a:spcBef>
+              <a:spcAft>
+                <a:spcPts val="400"/>
+              </a:spcAft>
+              <a:defRPr sz="1300" b="1">
+                <a:solidFill>
+                  <a:srgbClr val="0047AB"/>
+                </a:solidFill>
+                <a:latin typeface="맑은 고딕"/>
+              </a:defRPr>
+            </a:pPr>
+            <a:r>
+              <a:t>③  HW-SW 통합 관점 부재</a:t>
+            </a:r>
+          </a:p>
+          <a:p>
+            <a:pPr algn="l">
+              <a:spcBef>
+                <a:spcPts val="0"/>
+              </a:spcBef>
+              <a:spcAft>
+                <a:spcPts val="400"/>
+              </a:spcAft>
+              <a:defRPr sz="1000" b="0">
+                <a:solidFill>
+                  <a:srgbClr val="333344"/>
+                </a:solidFill>
+                <a:latin typeface="맑은 고딕"/>
+              </a:defRPr>
+            </a:pPr>
+            <a:r>
+              <a:t>모터 응답 지연/관성을 무시한 SW 설계</a:t>
+            </a:r>
+            <a:br/>
+            <a:r>
+              <a:t>→ 기계적 피로 누적 → 시스템 신뢰도 하락</a:t>
+            </a:r>
+          </a:p>
+          <a:p>
+            <a:pPr algn="l">
+              <a:spcBef>
+                <a:spcPts val="0"/>
+              </a:spcBef>
+              <a:spcAft>
+                <a:spcPts val="400"/>
+              </a:spcAft>
+              <a:defRPr sz="1000" b="1">
+                <a:solidFill>
+                  <a:srgbClr val="0047AB"/>
+                </a:solidFill>
+                <a:latin typeface="맑은 고딕"/>
+              </a:defRPr>
+            </a:pPr>
+            <a:r>
+              <a:t>→ 해결: 기계공학 기반 타이머 설계</a:t>
+            </a:r>
+          </a:p>
+        </p:txBody>
+      </p:sp>
+      <p:sp>
+        <p:nvSpPr>
+          <p:cNvPr id="21" name="TextBox 20"/>
           <p:cNvSpPr txBox="1"/>
           <p:nvPr/>
         </p:nvSpPr>
@@ -4937,14 +5260,14 @@
               </a:defRPr>
             </a:pPr>
             <a:r>
-              <a:t>▎ 후방 접근 위험 판단 로직 (RearRiskEvaluation)</a:t>
+              <a:t>▎ 후방 접근 위험 판단 로직 플로우</a:t>
             </a:r>
           </a:p>
         </p:txBody>
       </p:sp>
       <p:pic>
         <p:nvPicPr>
-          <p:cNvPr id="9" name="Picture 8" descr="architecture_flow_1775563698920.png"/>
+          <p:cNvPr id="9" name="Picture 8" descr="f07_flowchart_1775564697082.png"/>
           <p:cNvPicPr>
             <a:picLocks noChangeAspect="1"/>
           </p:cNvPicPr>
@@ -4959,7 +5282,7 @@
         <p:spPr>
           <a:xfrm>
             <a:off x="731520" y="2651760"/>
-            <a:ext cx="5303520" cy="2011680"/>
+            <a:ext cx="5303520" cy="3657600"/>
           </a:xfrm>
           <a:prstGeom prst="rect">
             <a:avLst/>
@@ -4968,14 +5291,80 @@
       </p:pic>
       <p:sp>
         <p:nvSpPr>
-          <p:cNvPr id="10" name="Rounded Rectangle 9"/>
+          <p:cNvPr id="10" name="TextBox 9"/>
+          <p:cNvSpPr txBox="1"/>
+          <p:nvPr/>
+        </p:nvSpPr>
+        <p:spPr>
+          <a:xfrm>
+            <a:off x="6400800" y="2103120"/>
+            <a:ext cx="5029200" cy="457200"/>
+          </a:xfrm>
+          <a:prstGeom prst="rect">
+            <a:avLst/>
+          </a:prstGeom>
+          <a:noFill/>
+        </p:spPr>
+        <p:txBody>
+          <a:bodyPr wrap="square">
+            <a:spAutoFit/>
+          </a:bodyPr>
+          <a:lstStyle/>
+          <a:p>
+            <a:pPr algn="l">
+              <a:spcBef>
+                <a:spcPts val="0"/>
+              </a:spcBef>
+              <a:spcAft>
+                <a:spcPts val="400"/>
+              </a:spcAft>
+              <a:defRPr sz="1400" b="1">
+                <a:solidFill>
+                  <a:srgbClr val="002B5C"/>
+                </a:solidFill>
+                <a:latin typeface="맑은 고딕"/>
+              </a:defRPr>
+            </a:pPr>
+            <a:r>
+              <a:t>▎ 핵심: 히스테리시스(Hysteresis) — 왜 필요한가?</a:t>
+            </a:r>
+          </a:p>
+        </p:txBody>
+      </p:sp>
+      <p:pic>
+        <p:nvPicPr>
+          <p:cNvPr id="11" name="Picture 10" descr="hysteresis_graph_1775563734722.png"/>
+          <p:cNvPicPr>
+            <a:picLocks noChangeAspect="1"/>
+          </p:cNvPicPr>
+          <p:nvPr/>
+        </p:nvPicPr>
+        <p:blipFill>
+          <a:blip r:embed="rId3"/>
+          <a:stretch>
+            <a:fillRect/>
+          </a:stretch>
+        </p:blipFill>
+        <p:spPr>
+          <a:xfrm>
+            <a:off x="6400800" y="2606040"/>
+            <a:ext cx="5029200" cy="2011680"/>
+          </a:xfrm>
+          <a:prstGeom prst="rect">
+            <a:avLst/>
+          </a:prstGeom>
+        </p:spPr>
+      </p:pic>
+      <p:sp>
+        <p:nvSpPr>
+          <p:cNvPr id="12" name="Rounded Rectangle 11"/>
           <p:cNvSpPr/>
           <p:nvPr/>
         </p:nvSpPr>
         <p:spPr>
           <a:xfrm>
-            <a:off x="731520" y="4846320"/>
-            <a:ext cx="1645920" cy="822960"/>
+            <a:off x="6400800" y="4754880"/>
+            <a:ext cx="5029200" cy="1554480"/>
           </a:xfrm>
           <a:prstGeom prst="roundRect">
             <a:avLst/>
@@ -5012,14 +5401,14 @@
       </p:sp>
       <p:sp>
         <p:nvSpPr>
-          <p:cNvPr id="11" name="TextBox 10"/>
+          <p:cNvPr id="13" name="TextBox 12"/>
           <p:cNvSpPr txBox="1"/>
           <p:nvPr/>
         </p:nvSpPr>
         <p:spPr>
           <a:xfrm>
-            <a:off x="822960" y="4892040"/>
-            <a:ext cx="1463040" cy="731520"/>
+            <a:off x="6675120" y="4846320"/>
+            <a:ext cx="4572000" cy="1371600"/>
           </a:xfrm>
           <a:prstGeom prst="rect">
             <a:avLst/>
@@ -5031,6 +5420,25 @@
             <a:spAutoFit/>
           </a:bodyPr>
           <a:lstStyle/>
+          <a:p>
+            <a:pPr algn="l">
+              <a:spcBef>
+                <a:spcPts val="0"/>
+              </a:spcBef>
+              <a:spcAft>
+                <a:spcPts val="800"/>
+              </a:spcAft>
+              <a:defRPr sz="1300" b="1">
+                <a:solidFill>
+                  <a:srgbClr val="0047AB"/>
+                </a:solidFill>
+                <a:latin typeface="맑은 고딕"/>
+              </a:defRPr>
+            </a:pPr>
+            <a:r>
+              <a:t>🔧  HW 보호 관점의 히스테리시스 설계</a:t>
+            </a:r>
+          </a:p>
           <a:p>
             <a:pPr algn="l">
               <a:spcBef>
@@ -5041,13 +5449,13 @@
               </a:spcAft>
               <a:defRPr sz="1100" b="1">
                 <a:solidFill>
-                  <a:srgbClr val="0047AB"/>
-                </a:solidFill>
-                <a:latin typeface="맑은 고딕"/>
-              </a:defRPr>
-            </a:pPr>
-            <a:r>
-              <a:t>📏 거리</a:t>
+                  <a:srgbClr val="002B5C"/>
+                </a:solidFill>
+                <a:latin typeface="맑은 고딕"/>
+              </a:defRPr>
+            </a:pPr>
+            <a:r>
+              <a:t>확정 타이머 (500ms):</a:t>
             </a:r>
           </a:p>
           <a:p>
@@ -5058,15 +5466,15 @@
               <a:spcAft>
                 <a:spcPts val="100"/>
               </a:spcAft>
-              <a:defRPr sz="1600" b="1">
-                <a:solidFill>
-                  <a:srgbClr val="002B5C"/>
-                </a:solidFill>
-                <a:latin typeface="맑은 고딕"/>
-              </a:defRPr>
-            </a:pPr>
-            <a:r>
-              <a:t>≤ 3.0m</a:t>
+              <a:defRPr sz="1100" b="0">
+                <a:solidFill>
+                  <a:srgbClr val="333344"/>
+                </a:solidFill>
+                <a:latin typeface="맑은 고딕"/>
+              </a:defRPr>
+            </a:pPr>
+            <a:r>
+              <a:t>센서 값이 튀더라도 모터가 물리적으로 반응할 수 있는</a:t>
             </a:r>
           </a:p>
           <a:p>
@@ -5075,86 +5483,19 @@
                 <a:spcPts val="0"/>
               </a:spcBef>
               <a:spcAft>
-                <a:spcPts val="400"/>
+                <a:spcPts val="800"/>
               </a:spcAft>
-              <a:defRPr sz="900" b="0">
-                <a:solidFill>
-                  <a:srgbClr val="666677"/>
-                </a:solidFill>
-                <a:latin typeface="맑은 고딕"/>
-              </a:defRPr>
-            </a:pPr>
-            <a:r>
-              <a:t>근접 판단</a:t>
-            </a:r>
-          </a:p>
-        </p:txBody>
-      </p:sp>
-      <p:sp>
-        <p:nvSpPr>
-          <p:cNvPr id="12" name="Rounded Rectangle 11"/>
-          <p:cNvSpPr/>
-          <p:nvPr/>
-        </p:nvSpPr>
-        <p:spPr>
-          <a:xfrm>
-            <a:off x="2560320" y="4846320"/>
-            <a:ext cx="1645920" cy="822960"/>
-          </a:xfrm>
-          <a:prstGeom prst="roundRect">
-            <a:avLst/>
-          </a:prstGeom>
-          <a:solidFill>
-            <a:srgbClr val="E8F2FF"/>
-          </a:solidFill>
-          <a:ln>
-            <a:noFill/>
-          </a:ln>
-          <a:effectLst/>
-        </p:spPr>
-        <p:style>
-          <a:lnRef idx="1">
-            <a:schemeClr val="accent1"/>
-          </a:lnRef>
-          <a:fillRef idx="3">
-            <a:schemeClr val="accent1"/>
-          </a:fillRef>
-          <a:effectRef idx="2">
-            <a:schemeClr val="accent1"/>
-          </a:effectRef>
-          <a:fontRef idx="minor">
-            <a:schemeClr val="lt1"/>
-          </a:fontRef>
-        </p:style>
-        <p:txBody>
-          <a:bodyPr rtlCol="0" anchor="ctr"/>
-          <a:lstStyle/>
-          <a:p>
-            <a:pPr algn="ctr"/>
-          </a:p>
-        </p:txBody>
-      </p:sp>
-      <p:sp>
-        <p:nvSpPr>
-          <p:cNvPr id="13" name="TextBox 12"/>
-          <p:cNvSpPr txBox="1"/>
-          <p:nvPr/>
-        </p:nvSpPr>
-        <p:spPr>
-          <a:xfrm>
-            <a:off x="2651760" y="4892040"/>
-            <a:ext cx="1463040" cy="731520"/>
-          </a:xfrm>
-          <a:prstGeom prst="rect">
-            <a:avLst/>
-          </a:prstGeom>
-          <a:noFill/>
-        </p:spPr>
-        <p:txBody>
-          <a:bodyPr wrap="square">
-            <a:spAutoFit/>
-          </a:bodyPr>
-          <a:lstStyle/>
+              <a:defRPr sz="1100" b="0">
+                <a:solidFill>
+                  <a:srgbClr val="333344"/>
+                </a:solidFill>
+                <a:latin typeface="맑은 고딕"/>
+              </a:defRPr>
+            </a:pPr>
+            <a:r>
+              <a:t>충분한 안정화 시간을 SW가 확보 → 기계적 피로도 극적 감소</a:t>
+            </a:r>
+          </a:p>
           <a:p>
             <a:pPr algn="l">
               <a:spcBef>
@@ -5165,13 +5506,13 @@
               </a:spcAft>
               <a:defRPr sz="1100" b="1">
                 <a:solidFill>
-                  <a:srgbClr val="0047AB"/>
-                </a:solidFill>
-                <a:latin typeface="맑은 고딕"/>
-              </a:defRPr>
-            </a:pPr>
-            <a:r>
-              <a:t>🏎 속도</a:t>
+                  <a:srgbClr val="002B5C"/>
+                </a:solidFill>
+                <a:latin typeface="맑은 고딕"/>
+              </a:defRPr>
+            </a:pPr>
+            <a:r>
+              <a:t>해제 타이머 (1000ms):</a:t>
             </a:r>
           </a:p>
           <a:p>
@@ -5182,15 +5523,15 @@
               <a:spcAft>
                 <a:spcPts val="100"/>
               </a:spcAft>
-              <a:defRPr sz="1600" b="1">
-                <a:solidFill>
-                  <a:srgbClr val="002B5C"/>
-                </a:solidFill>
-                <a:latin typeface="맑은 고딕"/>
-              </a:defRPr>
-            </a:pPr>
-            <a:r>
-              <a:t>≥ 2.0m/s</a:t>
+              <a:defRPr sz="1100" b="0">
+                <a:solidFill>
+                  <a:srgbClr val="333344"/>
+                </a:solidFill>
+                <a:latin typeface="맑은 고딕"/>
+              </a:defRPr>
+            </a:pPr>
+            <a:r>
+              <a:t>안전한 상태가 1초 이상 지속되어야 해제 → 모터 반복 구동 방지</a:t>
             </a:r>
           </a:p>
           <a:p>
@@ -5201,92 +5542,6 @@
               <a:spcAft>
                 <a:spcPts val="400"/>
               </a:spcAft>
-              <a:defRPr sz="900" b="0">
-                <a:solidFill>
-                  <a:srgbClr val="666677"/>
-                </a:solidFill>
-                <a:latin typeface="맑은 고딕"/>
-              </a:defRPr>
-            </a:pPr>
-            <a:r>
-              <a:t>접근 속도</a:t>
-            </a:r>
-          </a:p>
-        </p:txBody>
-      </p:sp>
-      <p:sp>
-        <p:nvSpPr>
-          <p:cNvPr id="14" name="Rounded Rectangle 13"/>
-          <p:cNvSpPr/>
-          <p:nvPr/>
-        </p:nvSpPr>
-        <p:spPr>
-          <a:xfrm>
-            <a:off x="4389120" y="4846320"/>
-            <a:ext cx="1645920" cy="822960"/>
-          </a:xfrm>
-          <a:prstGeom prst="roundRect">
-            <a:avLst/>
-          </a:prstGeom>
-          <a:solidFill>
-            <a:srgbClr val="E8F2FF"/>
-          </a:solidFill>
-          <a:ln>
-            <a:noFill/>
-          </a:ln>
-          <a:effectLst/>
-        </p:spPr>
-        <p:style>
-          <a:lnRef idx="1">
-            <a:schemeClr val="accent1"/>
-          </a:lnRef>
-          <a:fillRef idx="3">
-            <a:schemeClr val="accent1"/>
-          </a:fillRef>
-          <a:effectRef idx="2">
-            <a:schemeClr val="accent1"/>
-          </a:effectRef>
-          <a:fontRef idx="minor">
-            <a:schemeClr val="lt1"/>
-          </a:fontRef>
-        </p:style>
-        <p:txBody>
-          <a:bodyPr rtlCol="0" anchor="ctr"/>
-          <a:lstStyle/>
-          <a:p>
-            <a:pPr algn="ctr"/>
-          </a:p>
-        </p:txBody>
-      </p:sp>
-      <p:sp>
-        <p:nvSpPr>
-          <p:cNvPr id="15" name="TextBox 14"/>
-          <p:cNvSpPr txBox="1"/>
-          <p:nvPr/>
-        </p:nvSpPr>
-        <p:spPr>
-          <a:xfrm>
-            <a:off x="4480560" y="4892040"/>
-            <a:ext cx="1463040" cy="731520"/>
-          </a:xfrm>
-          <a:prstGeom prst="rect">
-            <a:avLst/>
-          </a:prstGeom>
-          <a:noFill/>
-        </p:spPr>
-        <p:txBody>
-          <a:bodyPr wrap="square">
-            <a:spAutoFit/>
-          </a:bodyPr>
-          <a:lstStyle/>
-          <a:p>
-            <a:pPr algn="l">
-              <a:spcBef>
-                <a:spcPts val="0"/>
-              </a:spcBef>
-              <a:spcAft>
-                <a:spcPts val="200"/>
-              </a:spcAft>
               <a:defRPr sz="1100" b="1">
                 <a:solidFill>
                   <a:srgbClr val="0047AB"/>
@@ -5295,607 +5550,14 @@
               </a:defRPr>
             </a:pPr>
             <a:r>
-              <a:t>📡 신뢰도</a:t>
-            </a:r>
-          </a:p>
-          <a:p>
-            <a:pPr algn="l">
-              <a:spcBef>
-                <a:spcPts val="0"/>
-              </a:spcBef>
-              <a:spcAft>
-                <a:spcPts val="100"/>
-              </a:spcAft>
-              <a:defRPr sz="1600" b="1">
-                <a:solidFill>
-                  <a:srgbClr val="002B5C"/>
-                </a:solidFill>
-                <a:latin typeface="맑은 고딕"/>
-              </a:defRPr>
-            </a:pPr>
-            <a:r>
-              <a:t>≥ 70%</a:t>
-            </a:r>
-          </a:p>
-          <a:p>
-            <a:pPr algn="l">
-              <a:spcBef>
-                <a:spcPts val="0"/>
-              </a:spcBef>
-              <a:spcAft>
-                <a:spcPts val="400"/>
-              </a:spcAft>
-              <a:defRPr sz="900" b="0">
-                <a:solidFill>
-                  <a:srgbClr val="666677"/>
-                </a:solidFill>
-                <a:latin typeface="맑은 고딕"/>
-              </a:defRPr>
-            </a:pPr>
-            <a:r>
-              <a:t>센서 품질</a:t>
-            </a:r>
-          </a:p>
-        </p:txBody>
-      </p:sp>
-      <p:sp>
-        <p:nvSpPr>
-          <p:cNvPr id="16" name="TextBox 15"/>
-          <p:cNvSpPr txBox="1"/>
-          <p:nvPr/>
-        </p:nvSpPr>
-        <p:spPr>
-          <a:xfrm>
-            <a:off x="731520" y="5852160"/>
-            <a:ext cx="5303520" cy="548640"/>
-          </a:xfrm>
-          <a:prstGeom prst="rect">
-            <a:avLst/>
-          </a:prstGeom>
-          <a:noFill/>
-        </p:spPr>
-        <p:txBody>
-          <a:bodyPr wrap="square">
-            <a:spAutoFit/>
-          </a:bodyPr>
-          <a:lstStyle/>
-          <a:p>
-            <a:pPr algn="l">
-              <a:spcBef>
-                <a:spcPts val="0"/>
-              </a:spcBef>
-              <a:spcAft>
-                <a:spcPts val="400"/>
-              </a:spcAft>
-              <a:defRPr sz="1000" b="0">
-                <a:solidFill>
-                  <a:srgbClr val="666677"/>
-                </a:solidFill>
-                <a:latin typeface="맑은 고딕"/>
-              </a:defRPr>
-            </a:pPr>
-            <a:r>
-              <a:t>세 조건 동시 충족 + 500ms 지속 → Risk HIGH 확정  |  1000ms 안전 지속 → Risk 해제</a:t>
-            </a:r>
-          </a:p>
-        </p:txBody>
-      </p:sp>
-      <p:sp>
-        <p:nvSpPr>
-          <p:cNvPr id="17" name="TextBox 16"/>
-          <p:cNvSpPr txBox="1"/>
-          <p:nvPr/>
-        </p:nvSpPr>
-        <p:spPr>
-          <a:xfrm>
-            <a:off x="6400800" y="2103120"/>
-            <a:ext cx="5029200" cy="457200"/>
-          </a:xfrm>
-          <a:prstGeom prst="rect">
-            <a:avLst/>
-          </a:prstGeom>
-          <a:noFill/>
-        </p:spPr>
-        <p:txBody>
-          <a:bodyPr wrap="square">
-            <a:spAutoFit/>
-          </a:bodyPr>
-          <a:lstStyle/>
-          <a:p>
-            <a:pPr algn="l">
-              <a:spcBef>
-                <a:spcPts val="0"/>
-              </a:spcBef>
-              <a:spcAft>
-                <a:spcPts val="400"/>
-              </a:spcAft>
-              <a:defRPr sz="1400" b="1">
-                <a:solidFill>
-                  <a:srgbClr val="002B5C"/>
-                </a:solidFill>
-                <a:latin typeface="맑은 고딕"/>
-              </a:defRPr>
-            </a:pPr>
-            <a:r>
-              <a:t>▎ 핵심: 히스테리시스(Hysteresis) 로직</a:t>
-            </a:r>
-          </a:p>
-        </p:txBody>
-      </p:sp>
-      <p:pic>
-        <p:nvPicPr>
-          <p:cNvPr id="18" name="Picture 17" descr="hysteresis_graph_1775563734722.png"/>
-          <p:cNvPicPr>
-            <a:picLocks noChangeAspect="1"/>
-          </p:cNvPicPr>
-          <p:nvPr/>
-        </p:nvPicPr>
-        <p:blipFill>
-          <a:blip r:embed="rId3"/>
-          <a:stretch>
-            <a:fillRect/>
-          </a:stretch>
-        </p:blipFill>
-        <p:spPr>
-          <a:xfrm>
-            <a:off x="6400800" y="2606040"/>
-            <a:ext cx="5029200" cy="2377440"/>
-          </a:xfrm>
-          <a:prstGeom prst="rect">
-            <a:avLst/>
-          </a:prstGeom>
-        </p:spPr>
-      </p:pic>
-      <p:sp>
-        <p:nvSpPr>
-          <p:cNvPr id="19" name="Rounded Rectangle 18"/>
-          <p:cNvSpPr/>
-          <p:nvPr/>
-        </p:nvSpPr>
-        <p:spPr>
-          <a:xfrm>
-            <a:off x="6400800" y="5074920"/>
-            <a:ext cx="5029200" cy="1371600"/>
-          </a:xfrm>
-          <a:prstGeom prst="roundRect">
-            <a:avLst/>
-          </a:prstGeom>
-          <a:solidFill>
-            <a:srgbClr val="1E1E2E"/>
-          </a:solidFill>
-          <a:ln>
-            <a:noFill/>
-          </a:ln>
-          <a:effectLst/>
-        </p:spPr>
-        <p:style>
-          <a:lnRef idx="1">
-            <a:schemeClr val="accent1"/>
-          </a:lnRef>
-          <a:fillRef idx="3">
-            <a:schemeClr val="accent1"/>
-          </a:fillRef>
-          <a:effectRef idx="2">
-            <a:schemeClr val="accent1"/>
-          </a:effectRef>
-          <a:fontRef idx="minor">
-            <a:schemeClr val="lt1"/>
-          </a:fontRef>
-        </p:style>
-        <p:txBody>
-          <a:bodyPr rtlCol="0" anchor="ctr"/>
-          <a:lstStyle/>
-          <a:p>
-            <a:pPr algn="ctr"/>
-          </a:p>
-        </p:txBody>
-      </p:sp>
-      <p:sp>
-        <p:nvSpPr>
-          <p:cNvPr id="20" name="TextBox 19"/>
-          <p:cNvSpPr txBox="1"/>
-          <p:nvPr/>
-        </p:nvSpPr>
-        <p:spPr>
-          <a:xfrm>
-            <a:off x="6537960" y="5166360"/>
-            <a:ext cx="4754880" cy="1188720"/>
-          </a:xfrm>
-          <a:prstGeom prst="rect">
-            <a:avLst/>
-          </a:prstGeom>
-          <a:noFill/>
-        </p:spPr>
-        <p:txBody>
-          <a:bodyPr wrap="square">
-            <a:spAutoFit/>
-          </a:bodyPr>
-          <a:lstStyle/>
-          <a:p>
-            <a:pPr>
-              <a:spcBef>
-                <a:spcPts val="0"/>
-              </a:spcBef>
-              <a:spcAft>
-                <a:spcPts val="100"/>
-              </a:spcAft>
-              <a:defRPr sz="700">
-                <a:solidFill>
-                  <a:srgbClr val="569CD6"/>
-                </a:solidFill>
-                <a:latin typeface="Consolas"/>
-              </a:defRPr>
-            </a:pPr>
-            <a:r>
-              <a:t>static void updateHysteresis(</a:t>
-            </a:r>
-          </a:p>
-          <a:p>
-            <a:pPr>
-              <a:spcBef>
-                <a:spcPts val="0"/>
-              </a:spcBef>
-              <a:spcAft>
-                <a:spcPts val="100"/>
-              </a:spcAft>
-              <a:defRPr sz="700">
-                <a:solidFill>
-                  <a:srgbClr val="569CD6"/>
-                </a:solidFill>
-                <a:latin typeface="Consolas"/>
-              </a:defRPr>
-            </a:pPr>
-            <a:r>
-              <a:t>    F07_Context_t *ctx, bool rawThreat, uint32_t nowMs)</a:t>
-            </a:r>
-          </a:p>
-          <a:p>
-            <a:pPr>
-              <a:spcBef>
-                <a:spcPts val="0"/>
-              </a:spcBef>
-              <a:spcAft>
-                <a:spcPts val="100"/>
-              </a:spcAft>
-              <a:defRPr sz="700">
-                <a:solidFill>
-                  <a:srgbClr val="D4D4D4"/>
-                </a:solidFill>
-                <a:latin typeface="Consolas"/>
-              </a:defRPr>
-            </a:pPr>
-            <a:r>
-              <a:t>{</a:t>
-            </a:r>
-          </a:p>
-          <a:p>
-            <a:pPr>
-              <a:spcBef>
-                <a:spcPts val="0"/>
-              </a:spcBef>
-              <a:spcAft>
-                <a:spcPts val="100"/>
-              </a:spcAft>
-              <a:defRPr sz="700">
-                <a:solidFill>
-                  <a:srgbClr val="569CD6"/>
-                </a:solidFill>
-                <a:latin typeface="Consolas"/>
-              </a:defRPr>
-            </a:pPr>
-            <a:r>
-              <a:t>    if (rawThreat) {</a:t>
-            </a:r>
-          </a:p>
-          <a:p>
-            <a:pPr>
-              <a:spcBef>
-                <a:spcPts val="0"/>
-              </a:spcBef>
-              <a:spcAft>
-                <a:spcPts val="100"/>
-              </a:spcAft>
-              <a:defRPr sz="700">
-                <a:solidFill>
-                  <a:srgbClr val="D4D4D4"/>
-                </a:solidFill>
-                <a:latin typeface="Consolas"/>
-              </a:defRPr>
-            </a:pPr>
-            <a:r>
-              <a:t>        ctx-&gt;riskClearTimestampMs = nowMs;</a:t>
-            </a:r>
-          </a:p>
-          <a:p>
-            <a:pPr>
-              <a:spcBef>
-                <a:spcPts val="0"/>
-              </a:spcBef>
-              <a:spcAft>
-                <a:spcPts val="100"/>
-              </a:spcAft>
-              <a:defRPr sz="700">
-                <a:solidFill>
-                  <a:srgbClr val="569CD6"/>
-                </a:solidFill>
-                <a:latin typeface="Consolas"/>
-              </a:defRPr>
-            </a:pPr>
-            <a:r>
-              <a:t>        if (!ctx-&gt;isThreatOngoing) {</a:t>
-            </a:r>
-          </a:p>
-          <a:p>
-            <a:pPr>
-              <a:spcBef>
-                <a:spcPts val="0"/>
-              </a:spcBef>
-              <a:spcAft>
-                <a:spcPts val="100"/>
-              </a:spcAft>
-              <a:defRPr sz="700">
-                <a:solidFill>
-                  <a:srgbClr val="D4D4D4"/>
-                </a:solidFill>
-                <a:latin typeface="Consolas"/>
-              </a:defRPr>
-            </a:pPr>
-            <a:r>
-              <a:t>            ctx-&gt;isThreatOngoing = true;</a:t>
-            </a:r>
-          </a:p>
-          <a:p>
-            <a:pPr>
-              <a:spcBef>
-                <a:spcPts val="0"/>
-              </a:spcBef>
-              <a:spcAft>
-                <a:spcPts val="100"/>
-              </a:spcAft>
-              <a:defRPr sz="700">
-                <a:solidFill>
-                  <a:srgbClr val="D4D4D4"/>
-                </a:solidFill>
-                <a:latin typeface="Consolas"/>
-              </a:defRPr>
-            </a:pPr>
-            <a:r>
-              <a:t>            ctx-&gt;riskOnsetTimestampMs = nowMs;</a:t>
-            </a:r>
-          </a:p>
-          <a:p>
-            <a:pPr>
-              <a:spcBef>
-                <a:spcPts val="0"/>
-              </a:spcBef>
-              <a:spcAft>
-                <a:spcPts val="100"/>
-              </a:spcAft>
-              <a:defRPr sz="700">
-                <a:solidFill>
-                  <a:srgbClr val="D4D4D4"/>
-                </a:solidFill>
-                <a:latin typeface="Consolas"/>
-              </a:defRPr>
-            </a:pPr>
-            <a:r>
-              <a:t>        }</a:t>
-            </a:r>
-          </a:p>
-          <a:p>
-            <a:pPr>
-              <a:spcBef>
-                <a:spcPts val="0"/>
-              </a:spcBef>
-              <a:spcAft>
-                <a:spcPts val="100"/>
-              </a:spcAft>
-              <a:defRPr sz="700">
-                <a:solidFill>
-                  <a:srgbClr val="6A9955"/>
-                </a:solidFill>
-                <a:latin typeface="Consolas"/>
-              </a:defRPr>
-            </a:pPr>
-            <a:r>
-              <a:t>        /* Confirm HIGH after sustained threat */</a:t>
-            </a:r>
-          </a:p>
-          <a:p>
-            <a:pPr>
-              <a:spcBef>
-                <a:spcPts val="0"/>
-              </a:spcBef>
-              <a:spcAft>
-                <a:spcPts val="100"/>
-              </a:spcAft>
-              <a:defRPr sz="700">
-                <a:solidFill>
-                  <a:srgbClr val="569CD6"/>
-                </a:solidFill>
-                <a:latin typeface="Consolas"/>
-              </a:defRPr>
-            </a:pPr>
-            <a:r>
-              <a:t>        if ((nowMs - ctx-&gt;riskOnsetTimestampMs)</a:t>
-            </a:r>
-          </a:p>
-          <a:p>
-            <a:pPr>
-              <a:spcBef>
-                <a:spcPts val="0"/>
-              </a:spcBef>
-              <a:spcAft>
-                <a:spcPts val="100"/>
-              </a:spcAft>
-              <a:defRPr sz="700">
-                <a:solidFill>
-                  <a:srgbClr val="D4D4D4"/>
-                </a:solidFill>
-                <a:latin typeface="Consolas"/>
-              </a:defRPr>
-            </a:pPr>
-            <a:r>
-              <a:t>            &gt;= REAR_RISK_CONFIRM_DURATION_MS)</a:t>
-            </a:r>
-          </a:p>
-          <a:p>
-            <a:pPr>
-              <a:spcBef>
-                <a:spcPts val="0"/>
-              </a:spcBef>
-              <a:spcAft>
-                <a:spcPts val="100"/>
-              </a:spcAft>
-              <a:defRPr sz="700">
-                <a:solidFill>
-                  <a:srgbClr val="D4D4D4"/>
-                </a:solidFill>
-                <a:latin typeface="Consolas"/>
-              </a:defRPr>
-            </a:pPr>
-            <a:r>
-              <a:t>            ctx-&gt;isRiskHighActive = true;</a:t>
-            </a:r>
-          </a:p>
-          <a:p>
-            <a:pPr>
-              <a:spcBef>
-                <a:spcPts val="0"/>
-              </a:spcBef>
-              <a:spcAft>
-                <a:spcPts val="100"/>
-              </a:spcAft>
-              <a:defRPr sz="700">
-                <a:solidFill>
-                  <a:srgbClr val="569CD6"/>
-                </a:solidFill>
-                <a:latin typeface="Consolas"/>
-              </a:defRPr>
-            </a:pPr>
-            <a:r>
-              <a:t>    } else {</a:t>
-            </a:r>
-          </a:p>
-          <a:p>
-            <a:pPr>
-              <a:spcBef>
-                <a:spcPts val="0"/>
-              </a:spcBef>
-              <a:spcAft>
-                <a:spcPts val="100"/>
-              </a:spcAft>
-              <a:defRPr sz="700">
-                <a:solidFill>
-                  <a:srgbClr val="6A9955"/>
-                </a:solidFill>
-                <a:latin typeface="Consolas"/>
-              </a:defRPr>
-            </a:pPr>
-            <a:r>
-              <a:t>        /* Clear HIGH after sustained safe */</a:t>
-            </a:r>
-          </a:p>
-          <a:p>
-            <a:pPr>
-              <a:spcBef>
-                <a:spcPts val="0"/>
-              </a:spcBef>
-              <a:spcAft>
-                <a:spcPts val="100"/>
-              </a:spcAft>
-              <a:defRPr sz="700">
-                <a:solidFill>
-                  <a:srgbClr val="569CD6"/>
-                </a:solidFill>
-                <a:latin typeface="Consolas"/>
-              </a:defRPr>
-            </a:pPr>
-            <a:r>
-              <a:t>        if ((nowMs - ctx-&gt;riskClearTimestampMs)</a:t>
-            </a:r>
-          </a:p>
-          <a:p>
-            <a:pPr>
-              <a:spcBef>
-                <a:spcPts val="0"/>
-              </a:spcBef>
-              <a:spcAft>
-                <a:spcPts val="100"/>
-              </a:spcAft>
-              <a:defRPr sz="700">
-                <a:solidFill>
-                  <a:srgbClr val="D4D4D4"/>
-                </a:solidFill>
-                <a:latin typeface="Consolas"/>
-              </a:defRPr>
-            </a:pPr>
-            <a:r>
-              <a:t>            &gt;= REAR_RISK_CLEAR_DURATION_MS)</a:t>
-            </a:r>
-          </a:p>
-          <a:p>
-            <a:pPr>
-              <a:spcBef>
-                <a:spcPts val="0"/>
-              </a:spcBef>
-              <a:spcAft>
-                <a:spcPts val="100"/>
-              </a:spcAft>
-              <a:defRPr sz="700">
-                <a:solidFill>
-                  <a:srgbClr val="D4D4D4"/>
-                </a:solidFill>
-                <a:latin typeface="Consolas"/>
-              </a:defRPr>
-            </a:pPr>
-            <a:r>
-              <a:t>            ctx-&gt;isRiskHighActive = false;</a:t>
-            </a:r>
-          </a:p>
-          <a:p>
-            <a:pPr>
-              <a:spcBef>
-                <a:spcPts val="0"/>
-              </a:spcBef>
-              <a:spcAft>
-                <a:spcPts val="100"/>
-              </a:spcAft>
-              <a:defRPr sz="700">
-                <a:solidFill>
-                  <a:srgbClr val="D4D4D4"/>
-                </a:solidFill>
-                <a:latin typeface="Consolas"/>
-              </a:defRPr>
-            </a:pPr>
-            <a:r>
-              <a:t>    }</a:t>
-            </a:r>
-          </a:p>
-          <a:p>
-            <a:pPr>
-              <a:spcBef>
-                <a:spcPts val="0"/>
-              </a:spcBef>
-              <a:spcAft>
-                <a:spcPts val="100"/>
-              </a:spcAft>
-              <a:defRPr sz="700">
-                <a:solidFill>
-                  <a:srgbClr val="D4D4D4"/>
-                </a:solidFill>
-                <a:latin typeface="Consolas"/>
-              </a:defRPr>
-            </a:pPr>
-            <a:r>
-              <a:t>}</a:t>
-            </a:r>
-          </a:p>
-        </p:txBody>
-      </p:sp>
-      <p:sp>
-        <p:nvSpPr>
-          <p:cNvPr id="21" name="TextBox 20"/>
+              <a:t>→ 기어 마모/모터 소손 위험 원천 차단</a:t>
+            </a:r>
+          </a:p>
+        </p:txBody>
+      </p:sp>
+      <p:sp>
+        <p:nvSpPr>
+          <p:cNvPr id="14" name="TextBox 13"/>
           <p:cNvSpPr txBox="1"/>
           <p:nvPr/>
         </p:nvSpPr>
@@ -6257,7 +5919,7 @@
         <p:spPr>
           <a:xfrm>
             <a:off x="731520" y="2103120"/>
-            <a:ext cx="5029200" cy="457200"/>
+            <a:ext cx="5303520" cy="457200"/>
           </a:xfrm>
           <a:prstGeom prst="rect">
             <a:avLst/>
@@ -6285,21 +5947,230 @@
               </a:defRPr>
             </a:pPr>
             <a:r>
-              <a:t>▎ 보호 액션 실행 흐름 (ProtectionController)</a:t>
-            </a:r>
-          </a:p>
-        </p:txBody>
-      </p:sp>
-      <p:sp>
-        <p:nvSpPr>
-          <p:cNvPr id="9" name="Rounded Rectangle 8"/>
+              <a:t>▎ 보호 액션 판단 플로우 (ProtectionController)</a:t>
+            </a:r>
+          </a:p>
+        </p:txBody>
+      </p:sp>
+      <p:pic>
+        <p:nvPicPr>
+          <p:cNvPr id="9" name="Picture 8" descr="f08_failsafe_flow_1775564713956.png"/>
+          <p:cNvPicPr>
+            <a:picLocks noChangeAspect="1"/>
+          </p:cNvPicPr>
+          <p:nvPr/>
+        </p:nvPicPr>
+        <p:blipFill>
+          <a:blip r:embed="rId2"/>
+          <a:stretch>
+            <a:fillRect/>
+          </a:stretch>
+        </p:blipFill>
+        <p:spPr>
+          <a:xfrm>
+            <a:off x="731520" y="2651760"/>
+            <a:ext cx="5303520" cy="3657600"/>
+          </a:xfrm>
+          <a:prstGeom prst="rect">
+            <a:avLst/>
+          </a:prstGeom>
+        </p:spPr>
+      </p:pic>
+      <p:sp>
+        <p:nvSpPr>
+          <p:cNvPr id="10" name="TextBox 9"/>
+          <p:cNvSpPr txBox="1"/>
+          <p:nvPr/>
+        </p:nvSpPr>
+        <p:spPr>
+          <a:xfrm>
+            <a:off x="6400800" y="2103120"/>
+            <a:ext cx="5029200" cy="457200"/>
+          </a:xfrm>
+          <a:prstGeom prst="rect">
+            <a:avLst/>
+          </a:prstGeom>
+          <a:noFill/>
+        </p:spPr>
+        <p:txBody>
+          <a:bodyPr wrap="square">
+            <a:spAutoFit/>
+          </a:bodyPr>
+          <a:lstStyle/>
+          <a:p>
+            <a:pPr algn="l">
+              <a:spcBef>
+                <a:spcPts val="0"/>
+              </a:spcBef>
+              <a:spcAft>
+                <a:spcPts val="400"/>
+              </a:spcAft>
+              <a:defRPr sz="1400" b="1">
+                <a:solidFill>
+                  <a:srgbClr val="002B5C"/>
+                </a:solidFill>
+                <a:latin typeface="맑은 고딕"/>
+              </a:defRPr>
+            </a:pPr>
+            <a:r>
+              <a:t>▎ SAFE_LOCKED 정책 — 물리적으로 가장 안전한 상태</a:t>
+            </a:r>
+          </a:p>
+        </p:txBody>
+      </p:sp>
+      <p:sp>
+        <p:nvSpPr>
+          <p:cNvPr id="11" name="Rounded Rectangle 10"/>
           <p:cNvSpPr/>
           <p:nvPr/>
         </p:nvSpPr>
         <p:spPr>
           <a:xfrm>
-            <a:off x="731520" y="2651760"/>
-            <a:ext cx="5029200" cy="1188720"/>
+            <a:off x="6400800" y="2651760"/>
+            <a:ext cx="5029200" cy="1371600"/>
+          </a:xfrm>
+          <a:prstGeom prst="roundRect">
+            <a:avLst/>
+          </a:prstGeom>
+          <a:solidFill>
+            <a:srgbClr val="FFECEC"/>
+          </a:solidFill>
+          <a:ln>
+            <a:noFill/>
+          </a:ln>
+          <a:effectLst/>
+        </p:spPr>
+        <p:style>
+          <a:lnRef idx="1">
+            <a:schemeClr val="accent1"/>
+          </a:lnRef>
+          <a:fillRef idx="3">
+            <a:schemeClr val="accent1"/>
+          </a:fillRef>
+          <a:effectRef idx="2">
+            <a:schemeClr val="accent1"/>
+          </a:effectRef>
+          <a:fontRef idx="minor">
+            <a:schemeClr val="lt1"/>
+          </a:fontRef>
+        </p:style>
+        <p:txBody>
+          <a:bodyPr rtlCol="0" anchor="ctr"/>
+          <a:lstStyle/>
+          <a:p>
+            <a:pPr algn="ctr"/>
+          </a:p>
+        </p:txBody>
+      </p:sp>
+      <p:sp>
+        <p:nvSpPr>
+          <p:cNvPr id="12" name="TextBox 11"/>
+          <p:cNvSpPr txBox="1"/>
+          <p:nvPr/>
+        </p:nvSpPr>
+        <p:spPr>
+          <a:xfrm>
+            <a:off x="6675120" y="2743200"/>
+            <a:ext cx="4572000" cy="1188720"/>
+          </a:xfrm>
+          <a:prstGeom prst="rect">
+            <a:avLst/>
+          </a:prstGeom>
+          <a:noFill/>
+        </p:spPr>
+        <p:txBody>
+          <a:bodyPr wrap="square">
+            <a:spAutoFit/>
+          </a:bodyPr>
+          <a:lstStyle/>
+          <a:p>
+            <a:pPr algn="l">
+              <a:spcBef>
+                <a:spcPts val="0"/>
+              </a:spcBef>
+              <a:spcAft>
+                <a:spcPts val="1000"/>
+              </a:spcAft>
+              <a:defRPr sz="1400" b="1">
+                <a:solidFill>
+                  <a:srgbClr val="E53335"/>
+                </a:solidFill>
+                <a:latin typeface="맑은 고딕"/>
+              </a:defRPr>
+            </a:pPr>
+            <a:r>
+              <a:t>⚠  센서 고장 시 차일드 락이 풀려버리면?</a:t>
+            </a:r>
+          </a:p>
+          <a:p>
+            <a:pPr algn="l">
+              <a:spcBef>
+                <a:spcPts val="0"/>
+              </a:spcBef>
+              <a:spcAft>
+                <a:spcPts val="200"/>
+              </a:spcAft>
+              <a:defRPr sz="1200" b="0">
+                <a:solidFill>
+                  <a:srgbClr val="333344"/>
+                </a:solidFill>
+                <a:latin typeface="맑은 고딕"/>
+              </a:defRPr>
+            </a:pPr>
+            <a:r>
+              <a:t>아이가 후방 차량 접근을 모른 채 문을 열고</a:t>
+            </a:r>
+          </a:p>
+          <a:p>
+            <a:pPr algn="l">
+              <a:spcBef>
+                <a:spcPts val="0"/>
+              </a:spcBef>
+              <a:spcAft>
+                <a:spcPts val="800"/>
+              </a:spcAft>
+              <a:defRPr sz="1200" b="1">
+                <a:solidFill>
+                  <a:srgbClr val="E53335"/>
+                </a:solidFill>
+                <a:latin typeface="맑은 고딕"/>
+              </a:defRPr>
+            </a:pPr>
+            <a:r>
+              <a:t>도로로 떨어질 수 있는 치명적 사고 발생 가능</a:t>
+            </a:r>
+          </a:p>
+          <a:p>
+            <a:pPr algn="l">
+              <a:spcBef>
+                <a:spcPts val="0"/>
+              </a:spcBef>
+              <a:spcAft>
+                <a:spcPts val="400"/>
+              </a:spcAft>
+              <a:defRPr sz="1200" b="1">
+                <a:solidFill>
+                  <a:srgbClr val="002B5C"/>
+                </a:solidFill>
+                <a:latin typeface="맑은 고딕"/>
+              </a:defRPr>
+            </a:pPr>
+            <a:r>
+              <a:t>→ 따라서 고장 시 "무조건 잠금 유지"가 기계적으로 가장 안전</a:t>
+            </a:r>
+          </a:p>
+        </p:txBody>
+      </p:sp>
+      <p:sp>
+        <p:nvSpPr>
+          <p:cNvPr id="13" name="Rounded Rectangle 12"/>
+          <p:cNvSpPr/>
+          <p:nvPr/>
+        </p:nvSpPr>
+        <p:spPr>
+          <a:xfrm>
+            <a:off x="6400800" y="4206240"/>
+            <a:ext cx="5029200" cy="1463040"/>
           </a:xfrm>
           <a:prstGeom prst="roundRect">
             <a:avLst/>
@@ -6336,14 +6207,14 @@
       </p:sp>
       <p:sp>
         <p:nvSpPr>
-          <p:cNvPr id="10" name="TextBox 9"/>
+          <p:cNvPr id="14" name="TextBox 13"/>
           <p:cNvSpPr txBox="1"/>
           <p:nvPr/>
         </p:nvSpPr>
         <p:spPr>
           <a:xfrm>
-            <a:off x="1005840" y="2743200"/>
-            <a:ext cx="4572000" cy="1005840"/>
+            <a:off x="6675120" y="4297680"/>
+            <a:ext cx="4572000" cy="1280160"/>
           </a:xfrm>
           <a:prstGeom prst="rect">
             <a:avLst/>
@@ -6361,55 +6232,17 @@
                 <a:spcPts val="0"/>
               </a:spcBef>
               <a:spcAft>
-                <a:spcPts val="600"/>
+                <a:spcPts val="800"/>
               </a:spcAft>
               <a:defRPr sz="1300" b="1">
                 <a:solidFill>
-                  <a:srgbClr val="E53335"/>
-                </a:solidFill>
-                <a:latin typeface="맑은 고딕"/>
-              </a:defRPr>
-            </a:pPr>
-            <a:r>
-              <a:t>🔴  Risk HIGH  →  즉시 보호 액션</a:t>
-            </a:r>
-          </a:p>
-          <a:p>
-            <a:pPr algn="l">
-              <a:spcBef>
-                <a:spcPts val="0"/>
-              </a:spcBef>
-              <a:spcAft>
-                <a:spcPts val="200"/>
-              </a:spcAft>
-              <a:defRPr sz="1100" b="0">
-                <a:solidFill>
-                  <a:srgbClr val="333344"/>
-                </a:solidFill>
-                <a:latin typeface="맑은 고딕"/>
-              </a:defRPr>
-            </a:pPr>
-            <a:r>
-              <a:t>• 도어 차일드락 강제 ON (targetCLState = CL_STATE_ON)</a:t>
-            </a:r>
-          </a:p>
-          <a:p>
-            <a:pPr algn="l">
-              <a:spcBef>
-                <a:spcPts val="0"/>
-              </a:spcBef>
-              <a:spcAft>
-                <a:spcPts val="200"/>
-              </a:spcAft>
-              <a:defRPr sz="1100" b="0">
-                <a:solidFill>
-                  <a:srgbClr val="333344"/>
-                </a:solidFill>
-                <a:latin typeface="맑은 고딕"/>
-              </a:defRPr>
-            </a:pPr>
-            <a:r>
-              <a:t>• 경고음 발생 + HMI 경고 메시지 표시</a:t>
+                  <a:srgbClr val="0047AB"/>
+                </a:solidFill>
+                <a:latin typeface="맑은 고딕"/>
+              </a:defRPr>
+            </a:pPr>
+            <a:r>
+              <a:t>🛡  Defensive Programming 방어 로직</a:t>
             </a:r>
           </a:p>
           <a:p>
@@ -6428,131 +6261,7 @@
               </a:defRPr>
             </a:pPr>
             <a:r>
-              <a:t>• 이벤트 로그 기록 (eventLog = true)</a:t>
-            </a:r>
-          </a:p>
-        </p:txBody>
-      </p:sp>
-      <p:sp>
-        <p:nvSpPr>
-          <p:cNvPr id="11" name="Rounded Rectangle 10"/>
-          <p:cNvSpPr/>
-          <p:nvPr/>
-        </p:nvSpPr>
-        <p:spPr>
-          <a:xfrm>
-            <a:off x="731520" y="4023360"/>
-            <a:ext cx="5029200" cy="1188720"/>
-          </a:xfrm>
-          <a:prstGeom prst="roundRect">
-            <a:avLst/>
-          </a:prstGeom>
-          <a:solidFill>
-            <a:srgbClr val="FFF0E0"/>
-          </a:solidFill>
-          <a:ln>
-            <a:noFill/>
-          </a:ln>
-          <a:effectLst/>
-        </p:spPr>
-        <p:style>
-          <a:lnRef idx="1">
-            <a:schemeClr val="accent1"/>
-          </a:lnRef>
-          <a:fillRef idx="3">
-            <a:schemeClr val="accent1"/>
-          </a:fillRef>
-          <a:effectRef idx="2">
-            <a:schemeClr val="accent1"/>
-          </a:effectRef>
-          <a:fontRef idx="minor">
-            <a:schemeClr val="lt1"/>
-          </a:fontRef>
-        </p:style>
-        <p:txBody>
-          <a:bodyPr rtlCol="0" anchor="ctr"/>
-          <a:lstStyle/>
-          <a:p>
-            <a:pPr algn="ctr"/>
-          </a:p>
-        </p:txBody>
-      </p:sp>
-      <p:sp>
-        <p:nvSpPr>
-          <p:cNvPr id="12" name="TextBox 11"/>
-          <p:cNvSpPr txBox="1"/>
-          <p:nvPr/>
-        </p:nvSpPr>
-        <p:spPr>
-          <a:xfrm>
-            <a:off x="1005840" y="4114800"/>
-            <a:ext cx="4572000" cy="1005840"/>
-          </a:xfrm>
-          <a:prstGeom prst="rect">
-            <a:avLst/>
-          </a:prstGeom>
-          <a:noFill/>
-        </p:spPr>
-        <p:txBody>
-          <a:bodyPr wrap="square">
-            <a:spAutoFit/>
-          </a:bodyPr>
-          <a:lstStyle/>
-          <a:p>
-            <a:pPr algn="l">
-              <a:spcBef>
-                <a:spcPts val="0"/>
-              </a:spcBef>
-              <a:spcAft>
-                <a:spcPts val="600"/>
-              </a:spcAft>
-              <a:defRPr sz="1300" b="1">
-                <a:solidFill>
-                  <a:srgbClr val="FF6B35"/>
-                </a:solidFill>
-                <a:latin typeface="맑은 고딕"/>
-              </a:defRPr>
-            </a:pPr>
-            <a:r>
-              <a:t>🟠  Sensor FAULT  →  SAFE_LOCKED 정책 (SDD 5.2.3)</a:t>
-            </a:r>
-          </a:p>
-          <a:p>
-            <a:pPr algn="l">
-              <a:spcBef>
-                <a:spcPts val="0"/>
-              </a:spcBef>
-              <a:spcAft>
-                <a:spcPts val="200"/>
-              </a:spcAft>
-              <a:defRPr sz="1100" b="0">
-                <a:solidFill>
-                  <a:srgbClr val="333344"/>
-                </a:solidFill>
-                <a:latin typeface="맑은 고딕"/>
-              </a:defRPr>
-            </a:pPr>
-            <a:r>
-              <a:t>• 센서 고장 시 즉시 CL ON 유지 / 강제 활성화</a:t>
-            </a:r>
-          </a:p>
-          <a:p>
-            <a:pPr algn="l">
-              <a:spcBef>
-                <a:spcPts val="0"/>
-              </a:spcBef>
-              <a:spcAft>
-                <a:spcPts val="200"/>
-              </a:spcAft>
-              <a:defRPr sz="1100" b="0">
-                <a:solidFill>
-                  <a:srgbClr val="333344"/>
-                </a:solidFill>
-                <a:latin typeface="맑은 고딕"/>
-              </a:defRPr>
-            </a:pPr>
-            <a:r>
-              <a:t>• 운전자 필수 알림 (warningSound = true)</a:t>
+              <a:t>① FAULT 플래그 감지 → 즉시 CL ON 강제 유지</a:t>
             </a:r>
           </a:p>
           <a:p>
@@ -6571,93 +6280,7 @@
               </a:defRPr>
             </a:pPr>
             <a:r>
-              <a:t>• DTC 저장 및 FAULT_FLAG_REAR_SENSOR 세트</a:t>
-            </a:r>
-          </a:p>
-        </p:txBody>
-      </p:sp>
-      <p:sp>
-        <p:nvSpPr>
-          <p:cNvPr id="13" name="Rounded Rectangle 12"/>
-          <p:cNvSpPr/>
-          <p:nvPr/>
-        </p:nvSpPr>
-        <p:spPr>
-          <a:xfrm>
-            <a:off x="731520" y="5394960"/>
-            <a:ext cx="5029200" cy="822960"/>
-          </a:xfrm>
-          <a:prstGeom prst="roundRect">
-            <a:avLst/>
-          </a:prstGeom>
-          <a:solidFill>
-            <a:srgbClr val="E0F7E5"/>
-          </a:solidFill>
-          <a:ln>
-            <a:noFill/>
-          </a:ln>
-          <a:effectLst/>
-        </p:spPr>
-        <p:style>
-          <a:lnRef idx="1">
-            <a:schemeClr val="accent1"/>
-          </a:lnRef>
-          <a:fillRef idx="3">
-            <a:schemeClr val="accent1"/>
-          </a:fillRef>
-          <a:effectRef idx="2">
-            <a:schemeClr val="accent1"/>
-          </a:effectRef>
-          <a:fontRef idx="minor">
-            <a:schemeClr val="lt1"/>
-          </a:fontRef>
-        </p:style>
-        <p:txBody>
-          <a:bodyPr rtlCol="0" anchor="ctr"/>
-          <a:lstStyle/>
-          <a:p>
-            <a:pPr algn="ctr"/>
-          </a:p>
-        </p:txBody>
-      </p:sp>
-      <p:sp>
-        <p:nvSpPr>
-          <p:cNvPr id="14" name="TextBox 13"/>
-          <p:cNvSpPr txBox="1"/>
-          <p:nvPr/>
-        </p:nvSpPr>
-        <p:spPr>
-          <a:xfrm>
-            <a:off x="1005840" y="5486400"/>
-            <a:ext cx="4572000" cy="640080"/>
-          </a:xfrm>
-          <a:prstGeom prst="rect">
-            <a:avLst/>
-          </a:prstGeom>
-          <a:noFill/>
-        </p:spPr>
-        <p:txBody>
-          <a:bodyPr wrap="square">
-            <a:spAutoFit/>
-          </a:bodyPr>
-          <a:lstStyle/>
-          <a:p>
-            <a:pPr algn="l">
-              <a:spcBef>
-                <a:spcPts val="0"/>
-              </a:spcBef>
-              <a:spcAft>
-                <a:spcPts val="600"/>
-              </a:spcAft>
-              <a:defRPr sz="1300" b="1">
-                <a:solidFill>
-                  <a:srgbClr val="00C853"/>
-                </a:solidFill>
-                <a:latin typeface="맑은 고딕"/>
-              </a:defRPr>
-            </a:pPr>
-            <a:r>
-              <a:t>🟢  Risk LOW/NONE  →  현재 상태 유지</a:t>
+              <a:t>② 모터를 "잠금 위치"로 구동 → 래치 체결 확보</a:t>
             </a:r>
           </a:p>
           <a:p>
@@ -6676,32 +6299,9 @@
               </a:defRPr>
             </a:pPr>
             <a:r>
-              <a:t>• 경고 해제, 정상 운전 모드 유지</a:t>
-            </a:r>
-          </a:p>
-        </p:txBody>
-      </p:sp>
-      <p:sp>
-        <p:nvSpPr>
-          <p:cNvPr id="15" name="TextBox 14"/>
-          <p:cNvSpPr txBox="1"/>
-          <p:nvPr/>
-        </p:nvSpPr>
-        <p:spPr>
-          <a:xfrm>
-            <a:off x="6400800" y="2103120"/>
-            <a:ext cx="5029200" cy="457200"/>
-          </a:xfrm>
-          <a:prstGeom prst="rect">
-            <a:avLst/>
-          </a:prstGeom>
-          <a:noFill/>
-        </p:spPr>
-        <p:txBody>
-          <a:bodyPr wrap="square">
-            <a:spAutoFit/>
-          </a:bodyPr>
-          <a:lstStyle/>
+              <a:t>③ HMI 경고음 + 메시지로 운전자 즉시 인지</a:t>
+            </a:r>
+          </a:p>
           <a:p>
             <a:pPr algn="l">
               <a:spcBef>
@@ -6710,38 +6310,59 @@
               <a:spcAft>
                 <a:spcPts val="400"/>
               </a:spcAft>
-              <a:defRPr sz="1400" b="1">
-                <a:solidFill>
-                  <a:srgbClr val="002B5C"/>
-                </a:solidFill>
-                <a:latin typeface="맑은 고딕"/>
-              </a:defRPr>
-            </a:pPr>
-            <a:r>
-              <a:t>▎ Defensive Programming + Fail-Safe 코드</a:t>
-            </a:r>
-          </a:p>
-        </p:txBody>
-      </p:sp>
-      <p:sp>
-        <p:nvSpPr>
-          <p:cNvPr id="16" name="Rounded Rectangle 15"/>
+              <a:defRPr sz="1100" b="0">
+                <a:solidFill>
+                  <a:srgbClr val="333344"/>
+                </a:solidFill>
+                <a:latin typeface="맑은 고딕"/>
+              </a:defRPr>
+            </a:pPr>
+            <a:r>
+              <a:t>④ 이벤트 로그/DTC 저장 → 사후 분석 대비</a:t>
+            </a:r>
+          </a:p>
+          <a:p>
+            <a:pPr algn="l">
+              <a:spcBef>
+                <a:spcPts val="0"/>
+              </a:spcBef>
+              <a:spcAft>
+                <a:spcPts val="400"/>
+              </a:spcAft>
+              <a:defRPr sz="1100" b="1">
+                <a:solidFill>
+                  <a:srgbClr val="0047AB"/>
+                </a:solidFill>
+                <a:latin typeface="맑은 고딕"/>
+              </a:defRPr>
+            </a:pPr>
+            <a:r>
+              <a:t>→ 통신 단절/센서 고장 시에도 승객 안전 100% 확보</a:t>
+            </a:r>
+          </a:p>
+        </p:txBody>
+      </p:sp>
+      <p:sp>
+        <p:nvSpPr>
+          <p:cNvPr id="15" name="Rounded Rectangle 14"/>
           <p:cNvSpPr/>
           <p:nvPr/>
         </p:nvSpPr>
         <p:spPr>
           <a:xfrm>
-            <a:off x="6400800" y="2606040"/>
-            <a:ext cx="5029200" cy="2926080"/>
+            <a:off x="6400800" y="5852160"/>
+            <a:ext cx="1554480" cy="640080"/>
           </a:xfrm>
           <a:prstGeom prst="roundRect">
             <a:avLst/>
           </a:prstGeom>
           <a:solidFill>
-            <a:srgbClr val="1E1E2E"/>
+            <a:srgbClr val="FFFFFF"/>
           </a:solidFill>
-          <a:ln>
-            <a:noFill/>
+          <a:ln w="12700">
+            <a:solidFill>
+              <a:srgbClr val="CCE5FF"/>
+            </a:solidFill>
           </a:ln>
           <a:effectLst/>
         </p:spPr>
@@ -6769,620 +6390,14 @@
       </p:sp>
       <p:sp>
         <p:nvSpPr>
-          <p:cNvPr id="17" name="TextBox 16"/>
+          <p:cNvPr id="16" name="TextBox 15"/>
           <p:cNvSpPr txBox="1"/>
           <p:nvPr/>
         </p:nvSpPr>
         <p:spPr>
           <a:xfrm>
-            <a:off x="6537960" y="2697480"/>
-            <a:ext cx="4754880" cy="2743200"/>
-          </a:xfrm>
-          <a:prstGeom prst="rect">
-            <a:avLst/>
-          </a:prstGeom>
-          <a:noFill/>
-        </p:spPr>
-        <p:txBody>
-          <a:bodyPr wrap="square">
-            <a:spAutoFit/>
-          </a:bodyPr>
-          <a:lstStyle/>
-          <a:p>
-            <a:pPr>
-              <a:spcBef>
-                <a:spcPts val="0"/>
-              </a:spcBef>
-              <a:spcAft>
-                <a:spcPts val="100"/>
-              </a:spcAft>
-              <a:defRPr sz="800">
-                <a:solidFill>
-                  <a:srgbClr val="569CD6"/>
-                </a:solidFill>
-                <a:latin typeface="Consolas"/>
-              </a:defRPr>
-            </a:pPr>
-            <a:r>
-              <a:t>void F08_RearRiskProtectionController_Run(</a:t>
-            </a:r>
-          </a:p>
-          <a:p>
-            <a:pPr>
-              <a:spcBef>
-                <a:spcPts val="0"/>
-              </a:spcBef>
-              <a:spcAft>
-                <a:spcPts val="100"/>
-              </a:spcAft>
-              <a:defRPr sz="800">
-                <a:solidFill>
-                  <a:srgbClr val="569CD6"/>
-                </a:solidFill>
-                <a:latin typeface="Consolas"/>
-              </a:defRPr>
-            </a:pPr>
-            <a:r>
-              <a:t>    const RearRiskProtectionInput_t *input,</a:t>
-            </a:r>
-          </a:p>
-          <a:p>
-            <a:pPr>
-              <a:spcBef>
-                <a:spcPts val="0"/>
-              </a:spcBef>
-              <a:spcAft>
-                <a:spcPts val="100"/>
-              </a:spcAft>
-              <a:defRPr sz="800">
-                <a:solidFill>
-                  <a:srgbClr val="D4D4D4"/>
-                </a:solidFill>
-                <a:latin typeface="Consolas"/>
-              </a:defRPr>
-            </a:pPr>
-            <a:r>
-              <a:t>    RearRiskProtectionOutput_t     *output)</a:t>
-            </a:r>
-          </a:p>
-          <a:p>
-            <a:pPr>
-              <a:spcBef>
-                <a:spcPts val="0"/>
-              </a:spcBef>
-              <a:spcAft>
-                <a:spcPts val="100"/>
-              </a:spcAft>
-              <a:defRPr sz="800">
-                <a:solidFill>
-                  <a:srgbClr val="D4D4D4"/>
-                </a:solidFill>
-                <a:latin typeface="Consolas"/>
-              </a:defRPr>
-            </a:pPr>
-            <a:r>
-              <a:t>{</a:t>
-            </a:r>
-          </a:p>
-          <a:p>
-            <a:pPr>
-              <a:spcBef>
-                <a:spcPts val="0"/>
-              </a:spcBef>
-              <a:spcAft>
-                <a:spcPts val="100"/>
-              </a:spcAft>
-              <a:defRPr sz="800">
-                <a:solidFill>
-                  <a:srgbClr val="6A9955"/>
-                </a:solidFill>
-                <a:latin typeface="Consolas"/>
-              </a:defRPr>
-            </a:pPr>
-            <a:r>
-              <a:t>    /* Defensive: NULL pointer guard */</a:t>
-            </a:r>
-          </a:p>
-          <a:p>
-            <a:pPr>
-              <a:spcBef>
-                <a:spcPts val="0"/>
-              </a:spcBef>
-              <a:spcAft>
-                <a:spcPts val="100"/>
-              </a:spcAft>
-              <a:defRPr sz="800">
-                <a:solidFill>
-                  <a:srgbClr val="569CD6"/>
-                </a:solidFill>
-                <a:latin typeface="Consolas"/>
-              </a:defRPr>
-            </a:pPr>
-            <a:r>
-              <a:t>    if ((input == NULL) || (output == NULL))</a:t>
-            </a:r>
-          </a:p>
-          <a:p>
-            <a:pPr>
-              <a:spcBef>
-                <a:spcPts val="0"/>
-              </a:spcBef>
-              <a:spcAft>
-                <a:spcPts val="100"/>
-              </a:spcAft>
-              <a:defRPr sz="800">
-                <a:solidFill>
-                  <a:srgbClr val="569CD6"/>
-                </a:solidFill>
-                <a:latin typeface="Consolas"/>
-              </a:defRPr>
-            </a:pPr>
-            <a:r>
-              <a:t>        return;</a:t>
-            </a:r>
-          </a:p>
-          <a:p>
-            <a:pPr>
-              <a:spcBef>
-                <a:spcPts val="0"/>
-              </a:spcBef>
-              <a:spcAft>
-                <a:spcPts val="100"/>
-              </a:spcAft>
-              <a:defRPr sz="800">
-                <a:solidFill>
-                  <a:srgbClr val="D4D4D4"/>
-                </a:solidFill>
-                <a:latin typeface="Consolas"/>
-              </a:defRPr>
-            </a:pPr>
-          </a:p>
-          <a:p>
-            <a:pPr>
-              <a:spcBef>
-                <a:spcPts val="0"/>
-              </a:spcBef>
-              <a:spcAft>
-                <a:spcPts val="100"/>
-              </a:spcAft>
-              <a:defRPr sz="800">
-                <a:solidFill>
-                  <a:srgbClr val="D4D4D4"/>
-                </a:solidFill>
-                <a:latin typeface="Consolas"/>
-              </a:defRPr>
-            </a:pPr>
-            <a:r>
-              <a:t>    initNeutralOutput(input-&gt;currentCLState, output);</a:t>
-            </a:r>
-          </a:p>
-          <a:p>
-            <a:pPr>
-              <a:spcBef>
-                <a:spcPts val="0"/>
-              </a:spcBef>
-              <a:spcAft>
-                <a:spcPts val="100"/>
-              </a:spcAft>
-              <a:defRPr sz="800">
-                <a:solidFill>
-                  <a:srgbClr val="D4D4D4"/>
-                </a:solidFill>
-                <a:latin typeface="Consolas"/>
-              </a:defRPr>
-            </a:pPr>
-          </a:p>
-          <a:p>
-            <a:pPr>
-              <a:spcBef>
-                <a:spcPts val="0"/>
-              </a:spcBef>
-              <a:spcAft>
-                <a:spcPts val="100"/>
-              </a:spcAft>
-              <a:defRPr sz="800">
-                <a:solidFill>
-                  <a:srgbClr val="6A9955"/>
-                </a:solidFill>
-                <a:latin typeface="Consolas"/>
-              </a:defRPr>
-            </a:pPr>
-            <a:r>
-              <a:t>    /* IGN OFF → feature inactive */</a:t>
-            </a:r>
-          </a:p>
-          <a:p>
-            <a:pPr>
-              <a:spcBef>
-                <a:spcPts val="0"/>
-              </a:spcBef>
-              <a:spcAft>
-                <a:spcPts val="100"/>
-              </a:spcAft>
-              <a:defRPr sz="800">
-                <a:solidFill>
-                  <a:srgbClr val="569CD6"/>
-                </a:solidFill>
-                <a:latin typeface="Consolas"/>
-              </a:defRPr>
-            </a:pPr>
-            <a:r>
-              <a:t>    if (input-&gt;ignitionState != IGN_STATE_ON)</a:t>
-            </a:r>
-          </a:p>
-          <a:p>
-            <a:pPr>
-              <a:spcBef>
-                <a:spcPts val="0"/>
-              </a:spcBef>
-              <a:spcAft>
-                <a:spcPts val="100"/>
-              </a:spcAft>
-              <a:defRPr sz="800">
-                <a:solidFill>
-                  <a:srgbClr val="569CD6"/>
-                </a:solidFill>
-                <a:latin typeface="Consolas"/>
-              </a:defRPr>
-            </a:pPr>
-            <a:r>
-              <a:t>        return;</a:t>
-            </a:r>
-          </a:p>
-          <a:p>
-            <a:pPr>
-              <a:spcBef>
-                <a:spcPts val="0"/>
-              </a:spcBef>
-              <a:spcAft>
-                <a:spcPts val="100"/>
-              </a:spcAft>
-              <a:defRPr sz="800">
-                <a:solidFill>
-                  <a:srgbClr val="D4D4D4"/>
-                </a:solidFill>
-                <a:latin typeface="Consolas"/>
-              </a:defRPr>
-            </a:pPr>
-          </a:p>
-          <a:p>
-            <a:pPr>
-              <a:spcBef>
-                <a:spcPts val="0"/>
-              </a:spcBef>
-              <a:spcAft>
-                <a:spcPts val="100"/>
-              </a:spcAft>
-              <a:defRPr sz="800">
-                <a:solidFill>
-                  <a:srgbClr val="6A9955"/>
-                </a:solidFill>
-                <a:latin typeface="Consolas"/>
-              </a:defRPr>
-            </a:pPr>
-            <a:r>
-              <a:t>    /* FAULT: SAFE_LOCKED policy (SDD 5.2.3) */</a:t>
-            </a:r>
-          </a:p>
-          <a:p>
-            <a:pPr>
-              <a:spcBef>
-                <a:spcPts val="0"/>
-              </a:spcBef>
-              <a:spcAft>
-                <a:spcPts val="100"/>
-              </a:spcAft>
-              <a:defRPr sz="800">
-                <a:solidFill>
-                  <a:srgbClr val="569CD6"/>
-                </a:solidFill>
-                <a:latin typeface="Consolas"/>
-              </a:defRPr>
-            </a:pPr>
-            <a:r>
-              <a:t>    if (!input-&gt;riskValid) {</a:t>
-            </a:r>
-          </a:p>
-          <a:p>
-            <a:pPr>
-              <a:spcBef>
-                <a:spcPts val="0"/>
-              </a:spcBef>
-              <a:spcAft>
-                <a:spcPts val="100"/>
-              </a:spcAft>
-              <a:defRPr sz="800">
-                <a:solidFill>
-                  <a:srgbClr val="DCDCAA"/>
-                </a:solidFill>
-                <a:latin typeface="Consolas"/>
-              </a:defRPr>
-            </a:pPr>
-            <a:r>
-              <a:t>        output-&gt;targetCLState = CL_STATE_ON;</a:t>
-            </a:r>
-          </a:p>
-          <a:p>
-            <a:pPr>
-              <a:spcBef>
-                <a:spcPts val="0"/>
-              </a:spcBef>
-              <a:spcAft>
-                <a:spcPts val="100"/>
-              </a:spcAft>
-              <a:defRPr sz="800">
-                <a:solidFill>
-                  <a:srgbClr val="D4D4D4"/>
-                </a:solidFill>
-                <a:latin typeface="Consolas"/>
-              </a:defRPr>
-            </a:pPr>
-            <a:r>
-              <a:t>        output-&gt;warningSound  = true;</a:t>
-            </a:r>
-          </a:p>
-          <a:p>
-            <a:pPr>
-              <a:spcBef>
-                <a:spcPts val="0"/>
-              </a:spcBef>
-              <a:spcAft>
-                <a:spcPts val="100"/>
-              </a:spcAft>
-              <a:defRPr sz="800">
-                <a:solidFill>
-                  <a:srgbClr val="D4D4D4"/>
-                </a:solidFill>
-                <a:latin typeface="Consolas"/>
-              </a:defRPr>
-            </a:pPr>
-            <a:r>
-              <a:t>        output-&gt;eventLog      = true;</a:t>
-            </a:r>
-          </a:p>
-          <a:p>
-            <a:pPr>
-              <a:spcBef>
-                <a:spcPts val="0"/>
-              </a:spcBef>
-              <a:spcAft>
-                <a:spcPts val="100"/>
-              </a:spcAft>
-              <a:defRPr sz="800">
-                <a:solidFill>
-                  <a:srgbClr val="569CD6"/>
-                </a:solidFill>
-                <a:latin typeface="Consolas"/>
-              </a:defRPr>
-            </a:pPr>
-            <a:r>
-              <a:t>        return;</a:t>
-            </a:r>
-          </a:p>
-          <a:p>
-            <a:pPr>
-              <a:spcBef>
-                <a:spcPts val="0"/>
-              </a:spcBef>
-              <a:spcAft>
-                <a:spcPts val="100"/>
-              </a:spcAft>
-              <a:defRPr sz="800">
-                <a:solidFill>
-                  <a:srgbClr val="D4D4D4"/>
-                </a:solidFill>
-                <a:latin typeface="Consolas"/>
-              </a:defRPr>
-            </a:pPr>
-            <a:r>
-              <a:t>    }</a:t>
-            </a:r>
-          </a:p>
-          <a:p>
-            <a:pPr>
-              <a:spcBef>
-                <a:spcPts val="0"/>
-              </a:spcBef>
-              <a:spcAft>
-                <a:spcPts val="100"/>
-              </a:spcAft>
-              <a:defRPr sz="800">
-                <a:solidFill>
-                  <a:srgbClr val="D4D4D4"/>
-                </a:solidFill>
-                <a:latin typeface="Consolas"/>
-              </a:defRPr>
-            </a:pPr>
-          </a:p>
-          <a:p>
-            <a:pPr>
-              <a:spcBef>
-                <a:spcPts val="0"/>
-              </a:spcBef>
-              <a:spcAft>
-                <a:spcPts val="100"/>
-              </a:spcAft>
-              <a:defRPr sz="800">
-                <a:solidFill>
-                  <a:srgbClr val="6A9955"/>
-                </a:solidFill>
-                <a:latin typeface="Consolas"/>
-              </a:defRPr>
-            </a:pPr>
-            <a:r>
-              <a:t>    /* Risk HIGH: protective action */</a:t>
-            </a:r>
-          </a:p>
-          <a:p>
-            <a:pPr>
-              <a:spcBef>
-                <a:spcPts val="0"/>
-              </a:spcBef>
-              <a:spcAft>
-                <a:spcPts val="100"/>
-              </a:spcAft>
-              <a:defRPr sz="800">
-                <a:solidFill>
-                  <a:srgbClr val="569CD6"/>
-                </a:solidFill>
-                <a:latin typeface="Consolas"/>
-              </a:defRPr>
-            </a:pPr>
-            <a:r>
-              <a:t>    if (input-&gt;riskHigh) {</a:t>
-            </a:r>
-          </a:p>
-          <a:p>
-            <a:pPr>
-              <a:spcBef>
-                <a:spcPts val="0"/>
-              </a:spcBef>
-              <a:spcAft>
-                <a:spcPts val="100"/>
-              </a:spcAft>
-              <a:defRPr sz="800">
-                <a:solidFill>
-                  <a:srgbClr val="DCDCAA"/>
-                </a:solidFill>
-                <a:latin typeface="Consolas"/>
-              </a:defRPr>
-            </a:pPr>
-            <a:r>
-              <a:t>        output-&gt;targetCLState = CL_STATE_ON;</a:t>
-            </a:r>
-          </a:p>
-          <a:p>
-            <a:pPr>
-              <a:spcBef>
-                <a:spcPts val="0"/>
-              </a:spcBef>
-              <a:spcAft>
-                <a:spcPts val="100"/>
-              </a:spcAft>
-              <a:defRPr sz="800">
-                <a:solidFill>
-                  <a:srgbClr val="D4D4D4"/>
-                </a:solidFill>
-                <a:latin typeface="Consolas"/>
-              </a:defRPr>
-            </a:pPr>
-            <a:r>
-              <a:t>        output-&gt;warningSound  = true;</a:t>
-            </a:r>
-          </a:p>
-          <a:p>
-            <a:pPr>
-              <a:spcBef>
-                <a:spcPts val="0"/>
-              </a:spcBef>
-              <a:spcAft>
-                <a:spcPts val="100"/>
-              </a:spcAft>
-              <a:defRPr sz="800">
-                <a:solidFill>
-                  <a:srgbClr val="D4D4D4"/>
-                </a:solidFill>
-                <a:latin typeface="Consolas"/>
-              </a:defRPr>
-            </a:pPr>
-            <a:r>
-              <a:t>        output-&gt;eventLog      = true;</a:t>
-            </a:r>
-          </a:p>
-          <a:p>
-            <a:pPr>
-              <a:spcBef>
-                <a:spcPts val="0"/>
-              </a:spcBef>
-              <a:spcAft>
-                <a:spcPts val="100"/>
-              </a:spcAft>
-              <a:defRPr sz="800">
-                <a:solidFill>
-                  <a:srgbClr val="D4D4D4"/>
-                </a:solidFill>
-                <a:latin typeface="Consolas"/>
-              </a:defRPr>
-            </a:pPr>
-            <a:r>
-              <a:t>    }</a:t>
-            </a:r>
-          </a:p>
-          <a:p>
-            <a:pPr>
-              <a:spcBef>
-                <a:spcPts val="0"/>
-              </a:spcBef>
-              <a:spcAft>
-                <a:spcPts val="100"/>
-              </a:spcAft>
-              <a:defRPr sz="800">
-                <a:solidFill>
-                  <a:srgbClr val="D4D4D4"/>
-                </a:solidFill>
-                <a:latin typeface="Consolas"/>
-              </a:defRPr>
-            </a:pPr>
-            <a:r>
-              <a:t>}</a:t>
-            </a:r>
-          </a:p>
-        </p:txBody>
-      </p:sp>
-      <p:sp>
-        <p:nvSpPr>
-          <p:cNvPr id="18" name="Rounded Rectangle 17"/>
-          <p:cNvSpPr/>
-          <p:nvPr/>
-        </p:nvSpPr>
-        <p:spPr>
-          <a:xfrm>
-            <a:off x="6400800" y="5669280"/>
-            <a:ext cx="1554480" cy="777240"/>
-          </a:xfrm>
-          <a:prstGeom prst="roundRect">
-            <a:avLst/>
-          </a:prstGeom>
-          <a:solidFill>
-            <a:srgbClr val="E8F2FF"/>
-          </a:solidFill>
-          <a:ln>
-            <a:noFill/>
-          </a:ln>
-          <a:effectLst/>
-        </p:spPr>
-        <p:style>
-          <a:lnRef idx="1">
-            <a:schemeClr val="accent1"/>
-          </a:lnRef>
-          <a:fillRef idx="3">
-            <a:schemeClr val="accent1"/>
-          </a:fillRef>
-          <a:effectRef idx="2">
-            <a:schemeClr val="accent1"/>
-          </a:effectRef>
-          <a:fontRef idx="minor">
-            <a:schemeClr val="lt1"/>
-          </a:fontRef>
-        </p:style>
-        <p:txBody>
-          <a:bodyPr rtlCol="0" anchor="ctr"/>
-          <a:lstStyle/>
-          <a:p>
-            <a:pPr algn="ctr"/>
-          </a:p>
-        </p:txBody>
-      </p:sp>
-      <p:sp>
-        <p:nvSpPr>
-          <p:cNvPr id="19" name="TextBox 18"/>
-          <p:cNvSpPr txBox="1"/>
-          <p:nvPr/>
-        </p:nvSpPr>
-        <p:spPr>
-          <a:xfrm>
-            <a:off x="6492240" y="5715000"/>
-            <a:ext cx="1371600" cy="640080"/>
+            <a:off x="6492240" y="5870448"/>
+            <a:ext cx="1371600" cy="548640"/>
           </a:xfrm>
           <a:prstGeom prst="rect">
             <a:avLst/>
@@ -7429,34 +6444,36 @@
               </a:defRPr>
             </a:pPr>
             <a:r>
-              <a:t>Rule 21.3 동적 메모리 금지</a:t>
+              <a:t>동적 메모리 금지</a:t>
             </a:r>
             <a:br/>
             <a:r>
-              <a:t>Rule 15.5 단일 return 패턴</a:t>
-            </a:r>
-          </a:p>
-        </p:txBody>
-      </p:sp>
-      <p:sp>
-        <p:nvSpPr>
-          <p:cNvPr id="20" name="Rounded Rectangle 19"/>
+              <a:t>Defensive 코딩 규칙</a:t>
+            </a:r>
+          </a:p>
+        </p:txBody>
+      </p:sp>
+      <p:sp>
+        <p:nvSpPr>
+          <p:cNvPr id="17" name="Rounded Rectangle 16"/>
           <p:cNvSpPr/>
           <p:nvPr/>
         </p:nvSpPr>
         <p:spPr>
           <a:xfrm>
-            <a:off x="8138160" y="5669280"/>
-            <a:ext cx="1554480" cy="777240"/>
+            <a:off x="8138160" y="5852160"/>
+            <a:ext cx="1554480" cy="640080"/>
           </a:xfrm>
           <a:prstGeom prst="roundRect">
             <a:avLst/>
           </a:prstGeom>
           <a:solidFill>
-            <a:srgbClr val="E8F2FF"/>
+            <a:srgbClr val="FFFFFF"/>
           </a:solidFill>
-          <a:ln>
-            <a:noFill/>
+          <a:ln w="12700">
+            <a:solidFill>
+              <a:srgbClr val="CCE5FF"/>
+            </a:solidFill>
           </a:ln>
           <a:effectLst/>
         </p:spPr>
@@ -7484,14 +6501,14 @@
       </p:sp>
       <p:sp>
         <p:nvSpPr>
-          <p:cNvPr id="21" name="TextBox 20"/>
+          <p:cNvPr id="18" name="TextBox 17"/>
           <p:cNvSpPr txBox="1"/>
           <p:nvPr/>
         </p:nvSpPr>
         <p:spPr>
           <a:xfrm>
-            <a:off x="8229600" y="5715000"/>
-            <a:ext cx="1371600" cy="640080"/>
+            <a:off x="8229600" y="5870448"/>
+            <a:ext cx="1371600" cy="548640"/>
           </a:xfrm>
           <a:prstGeom prst="rect">
             <a:avLst/>
@@ -7538,34 +6555,36 @@
               </a:defRPr>
             </a:pPr>
             <a:r>
-              <a:t>ASIL-B 등급 SW 개발</a:t>
+              <a:t>ASIL-B 등급</a:t>
             </a:r>
             <a:br/>
             <a:r>
-              <a:t>Defensive Programming 적용</a:t>
-            </a:r>
-          </a:p>
-        </p:txBody>
-      </p:sp>
-      <p:sp>
-        <p:nvSpPr>
-          <p:cNvPr id="22" name="Rounded Rectangle 21"/>
+              <a:t>Fail-Safe 설계 원칙</a:t>
+            </a:r>
+          </a:p>
+        </p:txBody>
+      </p:sp>
+      <p:sp>
+        <p:nvSpPr>
+          <p:cNvPr id="19" name="Rounded Rectangle 18"/>
           <p:cNvSpPr/>
           <p:nvPr/>
         </p:nvSpPr>
         <p:spPr>
           <a:xfrm>
-            <a:off x="9875520" y="5669280"/>
-            <a:ext cx="1554480" cy="777240"/>
+            <a:off x="9875520" y="5852160"/>
+            <a:ext cx="1554480" cy="640080"/>
           </a:xfrm>
           <a:prstGeom prst="roundRect">
             <a:avLst/>
           </a:prstGeom>
           <a:solidFill>
-            <a:srgbClr val="E8F2FF"/>
+            <a:srgbClr val="FFFFFF"/>
           </a:solidFill>
-          <a:ln>
-            <a:noFill/>
+          <a:ln w="12700">
+            <a:solidFill>
+              <a:srgbClr val="CCE5FF"/>
+            </a:solidFill>
           </a:ln>
           <a:effectLst/>
         </p:spPr>
@@ -7593,14 +6612,14 @@
       </p:sp>
       <p:sp>
         <p:nvSpPr>
-          <p:cNvPr id="23" name="TextBox 22"/>
+          <p:cNvPr id="20" name="TextBox 19"/>
           <p:cNvSpPr txBox="1"/>
           <p:nvPr/>
         </p:nvSpPr>
         <p:spPr>
           <a:xfrm>
-            <a:off x="9966960" y="5715000"/>
-            <a:ext cx="1371600" cy="640080"/>
+            <a:off x="9966960" y="5870448"/>
+            <a:ext cx="1371600" cy="548640"/>
           </a:xfrm>
           <a:prstGeom prst="rect">
             <a:avLst/>
@@ -7647,7 +6666,7 @@
               </a:defRPr>
             </a:pPr>
             <a:r>
-              <a:t>요구사항 ↔ 코드 추적성</a:t>
+              <a:t>요구사항↔코드 추적</a:t>
             </a:r>
             <a:br/>
             <a:r>
@@ -7658,7 +6677,7 @@
       </p:sp>
       <p:sp>
         <p:nvSpPr>
-          <p:cNvPr id="24" name="TextBox 23"/>
+          <p:cNvPr id="21" name="TextBox 20"/>
           <p:cNvSpPr txBox="1"/>
           <p:nvPr/>
         </p:nvSpPr>
@@ -7957,40 +6976,102 @@
           </a:p>
         </p:txBody>
       </p:sp>
-      <p:pic>
-        <p:nvPicPr>
-          <p:cNvPr id="7" name="Picture 6" descr="sl_application_1775563712287.png"/>
-          <p:cNvPicPr>
-            <a:picLocks noChangeAspect="1"/>
-          </p:cNvPicPr>
-          <p:nvPr/>
-        </p:nvPicPr>
-        <p:blipFill>
-          <a:blip r:embed="rId2"/>
-          <a:stretch>
-            <a:fillRect/>
-          </a:stretch>
-        </p:blipFill>
-        <p:spPr>
-          <a:xfrm>
-            <a:off x="731520" y="2194560"/>
-            <a:ext cx="10515600" cy="2286000"/>
+      <p:sp>
+        <p:nvSpPr>
+          <p:cNvPr id="7" name="Rounded Rectangle 6"/>
+          <p:cNvSpPr/>
+          <p:nvPr/>
+        </p:nvSpPr>
+        <p:spPr>
+          <a:xfrm>
+            <a:off x="731520" y="2103120"/>
+            <a:ext cx="10698480" cy="548640"/>
+          </a:xfrm>
+          <a:prstGeom prst="roundRect">
+            <a:avLst/>
+          </a:prstGeom>
+          <a:solidFill>
+            <a:srgbClr val="0047AB"/>
+          </a:solidFill>
+          <a:ln>
+            <a:noFill/>
+          </a:ln>
+          <a:effectLst/>
+        </p:spPr>
+        <p:style>
+          <a:lnRef idx="1">
+            <a:schemeClr val="accent1"/>
+          </a:lnRef>
+          <a:fillRef idx="3">
+            <a:schemeClr val="accent1"/>
+          </a:fillRef>
+          <a:effectRef idx="2">
+            <a:schemeClr val="accent1"/>
+          </a:effectRef>
+          <a:fontRef idx="minor">
+            <a:schemeClr val="lt1"/>
+          </a:fontRef>
+        </p:style>
+        <p:txBody>
+          <a:bodyPr rtlCol="0" anchor="ctr"/>
+          <a:lstStyle/>
+          <a:p>
+            <a:pPr algn="ctr"/>
+          </a:p>
+        </p:txBody>
+      </p:sp>
+      <p:sp>
+        <p:nvSpPr>
+          <p:cNvPr id="8" name="TextBox 7"/>
+          <p:cNvSpPr txBox="1"/>
+          <p:nvPr/>
+        </p:nvSpPr>
+        <p:spPr>
+          <a:xfrm>
+            <a:off x="914400" y="2148840"/>
+            <a:ext cx="10332720" cy="457200"/>
           </a:xfrm>
           <a:prstGeom prst="rect">
             <a:avLst/>
           </a:prstGeom>
-        </p:spPr>
-      </p:pic>
-      <p:sp>
-        <p:nvSpPr>
-          <p:cNvPr id="8" name="Rounded Rectangle 7"/>
+          <a:noFill/>
+        </p:spPr>
+        <p:txBody>
+          <a:bodyPr wrap="square">
+            <a:spAutoFit/>
+          </a:bodyPr>
+          <a:lstStyle/>
+          <a:p>
+            <a:pPr algn="ctr">
+              <a:spcBef>
+                <a:spcPts val="0"/>
+              </a:spcBef>
+              <a:spcAft>
+                <a:spcPts val="400"/>
+              </a:spcAft>
+              <a:defRPr sz="1200" b="1">
+                <a:solidFill>
+                  <a:srgbClr val="FFFFFF"/>
+                </a:solidFill>
+                <a:latin typeface="맑은 고딕"/>
+              </a:defRPr>
+            </a:pPr>
+            <a:r>
+              <a:t>모든 에스엘 전장품의 공통점:  정밀한 '모터 제어(HW)'  +  '상황 판단 로직(SW)'의 결합  →  차일드 락과 동일한 설계 패러다임</a:t>
+            </a:r>
+          </a:p>
+        </p:txBody>
+      </p:sp>
+      <p:sp>
+        <p:nvSpPr>
+          <p:cNvPr id="9" name="Rounded Rectangle 8"/>
           <p:cNvSpPr/>
           <p:nvPr/>
         </p:nvSpPr>
         <p:spPr>
           <a:xfrm>
-            <a:off x="731520" y="4663440"/>
-            <a:ext cx="3474720" cy="1965960"/>
+            <a:off x="731520" y="2926080"/>
+            <a:ext cx="3474720" cy="3474720"/>
           </a:xfrm>
           <a:prstGeom prst="roundRect">
             <a:avLst/>
@@ -8029,13 +7110,13 @@
       </p:sp>
       <p:sp>
         <p:nvSpPr>
-          <p:cNvPr id="9" name="Rectangle 8"/>
+          <p:cNvPr id="10" name="Rectangle 9"/>
           <p:cNvSpPr/>
           <p:nvPr/>
         </p:nvSpPr>
         <p:spPr>
           <a:xfrm>
-            <a:off x="731520" y="4663440"/>
+            <a:off x="731520" y="2926080"/>
             <a:ext cx="3474720" cy="45720"/>
           </a:xfrm>
           <a:prstGeom prst="rect">
@@ -8073,14 +7154,14 @@
       </p:sp>
       <p:sp>
         <p:nvSpPr>
-          <p:cNvPr id="10" name="TextBox 9"/>
+          <p:cNvPr id="11" name="TextBox 10"/>
           <p:cNvSpPr txBox="1"/>
           <p:nvPr/>
         </p:nvSpPr>
         <p:spPr>
           <a:xfrm>
-            <a:off x="914400" y="4800600"/>
-            <a:ext cx="3108960" cy="1828800"/>
+            <a:off x="914400" y="3063240"/>
+            <a:ext cx="3108960" cy="3291840"/>
           </a:xfrm>
           <a:prstGeom prst="rect">
             <a:avLst/>
@@ -8100,7 +7181,7 @@
               <a:spcAft>
                 <a:spcPts val="100"/>
               </a:spcAft>
-              <a:defRPr sz="1400" b="1">
+              <a:defRPr sz="1500" b="1">
                 <a:solidFill>
                   <a:srgbClr val="0047AB"/>
                 </a:solidFill>
@@ -8109,6 +7190,86 @@
             </a:pPr>
             <a:r>
               <a:t>💡  ADB 헤드램프</a:t>
+            </a:r>
+          </a:p>
+          <a:p>
+            <a:pPr algn="l">
+              <a:spcBef>
+                <a:spcPts val="0"/>
+              </a:spcBef>
+              <a:spcAft>
+                <a:spcPts val="1000"/>
+              </a:spcAft>
+              <a:defRPr sz="900" b="0">
+                <a:solidFill>
+                  <a:srgbClr val="666677"/>
+                </a:solidFill>
+                <a:latin typeface="맑은 고딕"/>
+              </a:defRPr>
+            </a:pPr>
+            <a:r>
+              <a:t>Adaptive Driving Beam</a:t>
+            </a:r>
+          </a:p>
+          <a:p>
+            <a:pPr algn="l">
+              <a:spcBef>
+                <a:spcPts val="0"/>
+              </a:spcBef>
+              <a:spcAft>
+                <a:spcPts val="200"/>
+              </a:spcAft>
+              <a:defRPr sz="1000" b="1">
+                <a:solidFill>
+                  <a:srgbClr val="002B5C"/>
+                </a:solidFill>
+                <a:latin typeface="맑은 고딕"/>
+              </a:defRPr>
+            </a:pPr>
+            <a:r>
+              <a:t>🔧 HW 구성</a:t>
+            </a:r>
+          </a:p>
+          <a:p>
+            <a:pPr algn="l">
+              <a:spcBef>
+                <a:spcPts val="0"/>
+              </a:spcBef>
+              <a:spcAft>
+                <a:spcPts val="1000"/>
+              </a:spcAft>
+              <a:defRPr sz="1000" b="0">
+                <a:solidFill>
+                  <a:srgbClr val="333344"/>
+                </a:solidFill>
+                <a:latin typeface="맑은 고딕"/>
+              </a:defRPr>
+            </a:pPr>
+            <a:r>
+              <a:t>LED 매트릭스 구동 모터</a:t>
+            </a:r>
+            <a:br/>
+            <a:r>
+              <a:t>+ 빔 각도 조절 액추에이터</a:t>
+            </a:r>
+          </a:p>
+          <a:p>
+            <a:pPr algn="l">
+              <a:spcBef>
+                <a:spcPts val="0"/>
+              </a:spcBef>
+              <a:spcAft>
+                <a:spcPts val="200"/>
+              </a:spcAft>
+              <a:defRPr sz="1000" b="1">
+                <a:solidFill>
+                  <a:srgbClr val="0047AB"/>
+                </a:solidFill>
+                <a:latin typeface="맑은 고딕"/>
+              </a:defRPr>
+            </a:pPr>
+            <a:r>
+              <a:t>📐 히스테리시스 적용</a:t>
             </a:r>
           </a:p>
           <a:p>
@@ -8119,15 +7280,19 @@
               <a:spcAft>
                 <a:spcPts val="800"/>
               </a:spcAft>
-              <a:defRPr sz="900" b="0">
-                <a:solidFill>
-                  <a:srgbClr val="666677"/>
-                </a:solidFill>
-                <a:latin typeface="맑은 고딕"/>
-              </a:defRPr>
-            </a:pPr>
-            <a:r>
-              <a:t>Adaptive Driving Beam</a:t>
+              <a:defRPr sz="1000" b="0">
+                <a:solidFill>
+                  <a:srgbClr val="333344"/>
+                </a:solidFill>
+                <a:latin typeface="맑은 고딕"/>
+              </a:defRPr>
+            </a:pPr>
+            <a:r>
+              <a:t>히스테리시스 → 빔 패턴</a:t>
+            </a:r>
+            <a:br/>
+            <a:r>
+              <a:t>경계값 안정화 (깜빡임 방지)</a:t>
             </a:r>
           </a:p>
           <a:p>
@@ -8138,6 +7303,25 @@
               <a:spcAft>
                 <a:spcPts val="200"/>
               </a:spcAft>
+              <a:defRPr sz="1000" b="1">
+                <a:solidFill>
+                  <a:srgbClr val="FF6B35"/>
+                </a:solidFill>
+                <a:latin typeface="맑은 고딕"/>
+              </a:defRPr>
+            </a:pPr>
+            <a:r>
+              <a:t>🛡 Fail-Safe 적용</a:t>
+            </a:r>
+          </a:p>
+          <a:p>
+            <a:pPr algn="l">
+              <a:spcBef>
+                <a:spcPts val="0"/>
+              </a:spcBef>
+              <a:spcAft>
+                <a:spcPts val="400"/>
+              </a:spcAft>
               <a:defRPr sz="1000" b="0">
                 <a:solidFill>
                   <a:srgbClr val="333344"/>
@@ -8146,25 +7330,25 @@
               </a:defRPr>
             </a:pPr>
             <a:r>
-              <a:t>히스테리시스 → 빔 패턴 경계값 안정화</a:t>
+              <a:t>Fail-Safe → 센서 고장 시</a:t>
             </a:r>
             <a:br/>
             <a:r>
-              <a:t>Fail-Safe → 센서 고장 시 기본 빔 유지</a:t>
-            </a:r>
-          </a:p>
-        </p:txBody>
-      </p:sp>
-      <p:sp>
-        <p:nvSpPr>
-          <p:cNvPr id="11" name="Rounded Rectangle 10"/>
+              <a:t>기본 빔(Low Beam) 유지</a:t>
+            </a:r>
+          </a:p>
+        </p:txBody>
+      </p:sp>
+      <p:sp>
+        <p:nvSpPr>
+          <p:cNvPr id="12" name="Rounded Rectangle 11"/>
           <p:cNvSpPr/>
           <p:nvPr/>
         </p:nvSpPr>
         <p:spPr>
           <a:xfrm>
-            <a:off x="4480559" y="4663440"/>
-            <a:ext cx="3474720" cy="1965960"/>
+            <a:off x="4480559" y="2926080"/>
+            <a:ext cx="3474720" cy="3474720"/>
           </a:xfrm>
           <a:prstGeom prst="roundRect">
             <a:avLst/>
@@ -8203,13 +7387,13 @@
       </p:sp>
       <p:sp>
         <p:nvSpPr>
-          <p:cNvPr id="12" name="Rectangle 11"/>
+          <p:cNvPr id="13" name="Rectangle 12"/>
           <p:cNvSpPr/>
           <p:nvPr/>
         </p:nvSpPr>
         <p:spPr>
           <a:xfrm>
-            <a:off x="4480559" y="4663440"/>
+            <a:off x="4480559" y="2926080"/>
             <a:ext cx="3474720" cy="45720"/>
           </a:xfrm>
           <a:prstGeom prst="rect">
@@ -8247,14 +7431,14 @@
       </p:sp>
       <p:sp>
         <p:nvSpPr>
-          <p:cNvPr id="13" name="TextBox 12"/>
+          <p:cNvPr id="14" name="TextBox 13"/>
           <p:cNvSpPr txBox="1"/>
           <p:nvPr/>
         </p:nvSpPr>
         <p:spPr>
           <a:xfrm>
-            <a:off x="4663439" y="4800600"/>
-            <a:ext cx="3108960" cy="1828800"/>
+            <a:off x="4663439" y="3063240"/>
+            <a:ext cx="3108960" cy="3291840"/>
           </a:xfrm>
           <a:prstGeom prst="rect">
             <a:avLst/>
@@ -8274,7 +7458,7 @@
               <a:spcAft>
                 <a:spcPts val="100"/>
               </a:spcAft>
-              <a:defRPr sz="1400" b="1">
+              <a:defRPr sz="1500" b="1">
                 <a:solidFill>
                   <a:srgbClr val="006ED6"/>
                 </a:solidFill>
@@ -8283,6 +7467,86 @@
             </a:pPr>
             <a:r>
               <a:t>⚙️  E-Shifter</a:t>
+            </a:r>
+          </a:p>
+          <a:p>
+            <a:pPr algn="l">
+              <a:spcBef>
+                <a:spcPts val="0"/>
+              </a:spcBef>
+              <a:spcAft>
+                <a:spcPts val="1000"/>
+              </a:spcAft>
+              <a:defRPr sz="900" b="0">
+                <a:solidFill>
+                  <a:srgbClr val="666677"/>
+                </a:solidFill>
+                <a:latin typeface="맑은 고딕"/>
+              </a:defRPr>
+            </a:pPr>
+            <a:r>
+              <a:t>Electronic Gear Shifter</a:t>
+            </a:r>
+          </a:p>
+          <a:p>
+            <a:pPr algn="l">
+              <a:spcBef>
+                <a:spcPts val="0"/>
+              </a:spcBef>
+              <a:spcAft>
+                <a:spcPts val="200"/>
+              </a:spcAft>
+              <a:defRPr sz="1000" b="1">
+                <a:solidFill>
+                  <a:srgbClr val="002B5C"/>
+                </a:solidFill>
+                <a:latin typeface="맑은 고딕"/>
+              </a:defRPr>
+            </a:pPr>
+            <a:r>
+              <a:t>🔧 HW 구성</a:t>
+            </a:r>
+          </a:p>
+          <a:p>
+            <a:pPr algn="l">
+              <a:spcBef>
+                <a:spcPts val="0"/>
+              </a:spcBef>
+              <a:spcAft>
+                <a:spcPts val="1000"/>
+              </a:spcAft>
+              <a:defRPr sz="1000" b="0">
+                <a:solidFill>
+                  <a:srgbClr val="333344"/>
+                </a:solidFill>
+                <a:latin typeface="맑은 고딕"/>
+              </a:defRPr>
+            </a:pPr>
+            <a:r>
+              <a:t>전자식 변속 모터</a:t>
+            </a:r>
+            <a:br/>
+            <a:r>
+              <a:t>+ 포지션 감지 센서</a:t>
+            </a:r>
+          </a:p>
+          <a:p>
+            <a:pPr algn="l">
+              <a:spcBef>
+                <a:spcPts val="0"/>
+              </a:spcBef>
+              <a:spcAft>
+                <a:spcPts val="200"/>
+              </a:spcAft>
+              <a:defRPr sz="1000" b="1">
+                <a:solidFill>
+                  <a:srgbClr val="0047AB"/>
+                </a:solidFill>
+                <a:latin typeface="맑은 고딕"/>
+              </a:defRPr>
+            </a:pPr>
+            <a:r>
+              <a:t>📐 히스테리시스 적용</a:t>
             </a:r>
           </a:p>
           <a:p>
@@ -8293,15 +7557,19 @@
               <a:spcAft>
                 <a:spcPts val="800"/>
               </a:spcAft>
-              <a:defRPr sz="900" b="0">
-                <a:solidFill>
-                  <a:srgbClr val="666677"/>
-                </a:solidFill>
-                <a:latin typeface="맑은 고딕"/>
-              </a:defRPr>
-            </a:pPr>
-            <a:r>
-              <a:t>Electronic Gear Shifter</a:t>
+              <a:defRPr sz="1000" b="0">
+                <a:solidFill>
+                  <a:srgbClr val="333344"/>
+                </a:solidFill>
+                <a:latin typeface="맑은 고딕"/>
+              </a:defRPr>
+            </a:pPr>
+            <a:r>
+              <a:t>히스테리시스 → 변속 위치</a:t>
+            </a:r>
+            <a:br/>
+            <a:r>
+              <a:t>판단 안정성 (오변속 방지)</a:t>
             </a:r>
           </a:p>
           <a:p>
@@ -8312,6 +7580,25 @@
               <a:spcAft>
                 <a:spcPts val="200"/>
               </a:spcAft>
+              <a:defRPr sz="1000" b="1">
+                <a:solidFill>
+                  <a:srgbClr val="FF6B35"/>
+                </a:solidFill>
+                <a:latin typeface="맑은 고딕"/>
+              </a:defRPr>
+            </a:pPr>
+            <a:r>
+              <a:t>🛡 Fail-Safe 적용</a:t>
+            </a:r>
+          </a:p>
+          <a:p>
+            <a:pPr algn="l">
+              <a:spcBef>
+                <a:spcPts val="0"/>
+              </a:spcBef>
+              <a:spcAft>
+                <a:spcPts val="400"/>
+              </a:spcAft>
               <a:defRPr sz="1000" b="0">
                 <a:solidFill>
                   <a:srgbClr val="333344"/>
@@ -8320,25 +7607,25 @@
               </a:defRPr>
             </a:pPr>
             <a:r>
-              <a:t>히스테리시스 → 변속 위치 판단 안정성</a:t>
+              <a:t>Fail-Safe → 센서 고장 시</a:t>
             </a:r>
             <a:br/>
             <a:r>
-              <a:t>Fail-Safe → 오변속 방지 + P단 안전 로직</a:t>
-            </a:r>
-          </a:p>
-        </p:txBody>
-      </p:sp>
-      <p:sp>
-        <p:nvSpPr>
-          <p:cNvPr id="14" name="Rounded Rectangle 13"/>
+              <a:t>P단 강제 고정 (안전 정차)</a:t>
+            </a:r>
+          </a:p>
+        </p:txBody>
+      </p:sp>
+      <p:sp>
+        <p:nvSpPr>
+          <p:cNvPr id="15" name="Rounded Rectangle 14"/>
           <p:cNvSpPr/>
           <p:nvPr/>
         </p:nvSpPr>
         <p:spPr>
           <a:xfrm>
-            <a:off x="8229600" y="4663440"/>
-            <a:ext cx="3474720" cy="1965960"/>
+            <a:off x="8229600" y="2926080"/>
+            <a:ext cx="3474720" cy="3474720"/>
           </a:xfrm>
           <a:prstGeom prst="roundRect">
             <a:avLst/>
@@ -8377,13 +7664,13 @@
       </p:sp>
       <p:sp>
         <p:nvSpPr>
-          <p:cNvPr id="15" name="Rectangle 14"/>
+          <p:cNvPr id="16" name="Rectangle 15"/>
           <p:cNvSpPr/>
           <p:nvPr/>
         </p:nvSpPr>
         <p:spPr>
           <a:xfrm>
-            <a:off x="8229600" y="4663440"/>
+            <a:off x="8229600" y="2926080"/>
             <a:ext cx="3474720" cy="45720"/>
           </a:xfrm>
           <a:prstGeom prst="rect">
@@ -8421,14 +7708,14 @@
       </p:sp>
       <p:sp>
         <p:nvSpPr>
-          <p:cNvPr id="16" name="TextBox 15"/>
+          <p:cNvPr id="17" name="TextBox 16"/>
           <p:cNvSpPr txBox="1"/>
           <p:nvPr/>
         </p:nvSpPr>
         <p:spPr>
           <a:xfrm>
-            <a:off x="8412480" y="4800600"/>
-            <a:ext cx="3108960" cy="1828800"/>
+            <a:off x="8412480" y="3063240"/>
+            <a:ext cx="3108960" cy="3291840"/>
           </a:xfrm>
           <a:prstGeom prst="rect">
             <a:avLst/>
@@ -8448,7 +7735,7 @@
               <a:spcAft>
                 <a:spcPts val="100"/>
               </a:spcAft>
-              <a:defRPr sz="1400" b="1">
+              <a:defRPr sz="1500" b="1">
                 <a:solidFill>
                   <a:srgbClr val="002B5C"/>
                 </a:solidFill>
@@ -8457,6 +7744,86 @@
             </a:pPr>
             <a:r>
               <a:t>🪞  전동 폴딩 미러</a:t>
+            </a:r>
+          </a:p>
+          <a:p>
+            <a:pPr algn="l">
+              <a:spcBef>
+                <a:spcPts val="0"/>
+              </a:spcBef>
+              <a:spcAft>
+                <a:spcPts val="1000"/>
+              </a:spcAft>
+              <a:defRPr sz="900" b="0">
+                <a:solidFill>
+                  <a:srgbClr val="666677"/>
+                </a:solidFill>
+                <a:latin typeface="맑은 고딕"/>
+              </a:defRPr>
+            </a:pPr>
+            <a:r>
+              <a:t>Power Folding Mirror</a:t>
+            </a:r>
+          </a:p>
+          <a:p>
+            <a:pPr algn="l">
+              <a:spcBef>
+                <a:spcPts val="0"/>
+              </a:spcBef>
+              <a:spcAft>
+                <a:spcPts val="200"/>
+              </a:spcAft>
+              <a:defRPr sz="1000" b="1">
+                <a:solidFill>
+                  <a:srgbClr val="002B5C"/>
+                </a:solidFill>
+                <a:latin typeface="맑은 고딕"/>
+              </a:defRPr>
+            </a:pPr>
+            <a:r>
+              <a:t>🔧 HW 구성</a:t>
+            </a:r>
+          </a:p>
+          <a:p>
+            <a:pPr algn="l">
+              <a:spcBef>
+                <a:spcPts val="0"/>
+              </a:spcBef>
+              <a:spcAft>
+                <a:spcPts val="1000"/>
+              </a:spcAft>
+              <a:defRPr sz="1000" b="0">
+                <a:solidFill>
+                  <a:srgbClr val="333344"/>
+                </a:solidFill>
+                <a:latin typeface="맑은 고딕"/>
+              </a:defRPr>
+            </a:pPr>
+            <a:r>
+              <a:t>접힘/펼침 구동 모터</a:t>
+            </a:r>
+            <a:br/>
+            <a:r>
+              <a:t>+ 위치 센서 + 전류 감지</a:t>
+            </a:r>
+          </a:p>
+          <a:p>
+            <a:pPr algn="l">
+              <a:spcBef>
+                <a:spcPts val="0"/>
+              </a:spcBef>
+              <a:spcAft>
+                <a:spcPts val="200"/>
+              </a:spcAft>
+              <a:defRPr sz="1000" b="1">
+                <a:solidFill>
+                  <a:srgbClr val="0047AB"/>
+                </a:solidFill>
+                <a:latin typeface="맑은 고딕"/>
+              </a:defRPr>
+            </a:pPr>
+            <a:r>
+              <a:t>📐 히스테리시스 적용</a:t>
             </a:r>
           </a:p>
           <a:p>
@@ -8467,15 +7834,19 @@
               <a:spcAft>
                 <a:spcPts val="800"/>
               </a:spcAft>
-              <a:defRPr sz="900" b="0">
-                <a:solidFill>
-                  <a:srgbClr val="666677"/>
-                </a:solidFill>
-                <a:latin typeface="맑은 고딕"/>
-              </a:defRPr>
-            </a:pPr>
-            <a:r>
-              <a:t>Power Folding Mirror</a:t>
+              <a:defRPr sz="1000" b="0">
+                <a:solidFill>
+                  <a:srgbClr val="333344"/>
+                </a:solidFill>
+                <a:latin typeface="맑은 고딕"/>
+              </a:defRPr>
+            </a:pPr>
+            <a:r>
+              <a:t>히스테리시스 → 장애물 감지</a:t>
+            </a:r>
+            <a:br/>
+            <a:r>
+              <a:t>임계값 안정화 (오판 방지)</a:t>
             </a:r>
           </a:p>
           <a:p>
@@ -8486,6 +7857,25 @@
               <a:spcAft>
                 <a:spcPts val="200"/>
               </a:spcAft>
+              <a:defRPr sz="1000" b="1">
+                <a:solidFill>
+                  <a:srgbClr val="FF6B35"/>
+                </a:solidFill>
+                <a:latin typeface="맑은 고딕"/>
+              </a:defRPr>
+            </a:pPr>
+            <a:r>
+              <a:t>🛡 Fail-Safe 적용</a:t>
+            </a:r>
+          </a:p>
+          <a:p>
+            <a:pPr algn="l">
+              <a:spcBef>
+                <a:spcPts val="0"/>
+              </a:spcBef>
+              <a:spcAft>
+                <a:spcPts val="400"/>
+              </a:spcAft>
               <a:defRPr sz="1000" b="0">
                 <a:solidFill>
                   <a:srgbClr val="333344"/>
@@ -8494,18 +7884,18 @@
               </a:defRPr>
             </a:pPr>
             <a:r>
-              <a:t>히스테리시스 → 장애물 감지 임계값 안정화</a:t>
+              <a:t>Fail-Safe → 과부하/장애물 시</a:t>
             </a:r>
             <a:br/>
             <a:r>
-              <a:t>Fail-Safe → 과부하 시 모터 정지 보호</a:t>
-            </a:r>
-          </a:p>
-        </p:txBody>
-      </p:sp>
-      <p:sp>
-        <p:nvSpPr>
-          <p:cNvPr id="17" name="TextBox 16"/>
+              <a:t>모터 즉시 정지 보호</a:t>
+            </a:r>
+          </a:p>
+        </p:txBody>
+      </p:sp>
+      <p:sp>
+        <p:nvSpPr>
+          <p:cNvPr id="18" name="TextBox 17"/>
           <p:cNvSpPr txBox="1"/>
           <p:nvPr/>
         </p:nvSpPr>

</xml_diff>

<commit_message>
docs: add presentation materials for online PT session
</commit_message>
<xml_diff>
--- a/docs/SL_온라인PT_발표자료.pptx
+++ b/docs/SL_온라인PT_발표자료.pptx
@@ -4065,7 +4065,7 @@
               </a:defRPr>
             </a:pPr>
             <a:r>
-              <a:t>▎ 차일드 락의 기계적 특성과 SW 한계</a:t>
+              <a:t>▎ 차일드 락 액추에이터의 기계적 특성</a:t>
             </a:r>
           </a:p>
         </p:txBody>
@@ -4079,7 +4079,7 @@
         <p:spPr>
           <a:xfrm>
             <a:off x="731520" y="2651760"/>
-            <a:ext cx="5029200" cy="1371600"/>
+            <a:ext cx="5029200" cy="1645920"/>
           </a:xfrm>
           <a:prstGeom prst="roundRect">
             <a:avLst/>
@@ -4123,7 +4123,7 @@
         <p:spPr>
           <a:xfrm>
             <a:off x="1005840" y="2743200"/>
-            <a:ext cx="4572000" cy="1188720"/>
+            <a:ext cx="4572000" cy="1463040"/>
           </a:xfrm>
           <a:prstGeom prst="rect">
             <a:avLst/>
@@ -4151,7 +4151,7 @@
               </a:defRPr>
             </a:pPr>
             <a:r>
-              <a:t>🔧  소형 DC 모터 + 기어 트레인의 물리적 한계</a:t>
+              <a:t>🔧  소형 DC 모터 + 기어 + 링크 구조</a:t>
             </a:r>
           </a:p>
           <a:p>
@@ -4170,7 +4170,7 @@
               </a:defRPr>
             </a:pPr>
             <a:r>
-              <a:t>• 응답 지연(Response Delay): 모터 구동 → 래치 체결까지 수십 ms 소요</a:t>
+              <a:t>• 응답 지연 (~50ms): 모터 구동 → 래치 체결까지의 물리적 시간</a:t>
             </a:r>
           </a:p>
           <a:p>
@@ -4189,7 +4189,7 @@
               </a:defRPr>
             </a:pPr>
             <a:r>
-              <a:t>• 기어 백래시(Backlash): 기어 치합 유격으로 인한 위치 불확정 구간 존재</a:t>
+              <a:t>• 기어 백래시(Backlash): 기어 치합 유격으로 인한 위치 불확정 구간</a:t>
             </a:r>
           </a:p>
           <a:p>
@@ -4211,6 +4211,25 @@
               <a:t>• 관성 지연(Inertia): 모터 정지 명령 후에도 관성에 의해 회전 지속</a:t>
             </a:r>
           </a:p>
+          <a:p>
+            <a:pPr algn="l">
+              <a:spcBef>
+                <a:spcPts val="0"/>
+              </a:spcBef>
+              <a:spcAft>
+                <a:spcPts val="400"/>
+              </a:spcAft>
+              <a:defRPr sz="1100" b="0">
+                <a:solidFill>
+                  <a:srgbClr val="333344"/>
+                </a:solidFill>
+                <a:latin typeface="맑은 고딕"/>
+              </a:defRPr>
+            </a:pPr>
+            <a:r>
+              <a:t>• 온도 드리프트: 극저온/고온 환경에서 센서 출력값 변동</a:t>
+            </a:r>
+          </a:p>
         </p:txBody>
       </p:sp>
       <p:sp>
@@ -4221,14 +4240,14 @@
         </p:nvSpPr>
         <p:spPr>
           <a:xfrm>
-            <a:off x="731520" y="4206240"/>
-            <a:ext cx="5029200" cy="1463040"/>
+            <a:off x="731520" y="4480560"/>
+            <a:ext cx="5029200" cy="502920"/>
           </a:xfrm>
           <a:prstGeom prst="roundRect">
             <a:avLst/>
           </a:prstGeom>
           <a:solidFill>
-            <a:srgbClr val="FFECEC"/>
+            <a:srgbClr val="0047AB"/>
           </a:solidFill>
           <a:ln>
             <a:noFill/>
@@ -4265,8 +4284,8 @@
         </p:nvSpPr>
         <p:spPr>
           <a:xfrm>
-            <a:off x="1005840" y="4297680"/>
-            <a:ext cx="4572000" cy="1280160"/>
+            <a:off x="1005840" y="4526280"/>
+            <a:ext cx="4572000" cy="365760"/>
           </a:xfrm>
           <a:prstGeom prst="rect">
             <a:avLst/>
@@ -4278,63 +4297,6 @@
             <a:spAutoFit/>
           </a:bodyPr>
           <a:lstStyle/>
-          <a:p>
-            <a:pPr algn="l">
-              <a:spcBef>
-                <a:spcPts val="0"/>
-              </a:spcBef>
-              <a:spcAft>
-                <a:spcPts val="800"/>
-              </a:spcAft>
-              <a:defRPr sz="1300" b="1">
-                <a:solidFill>
-                  <a:srgbClr val="E53335"/>
-                </a:solidFill>
-                <a:latin typeface="맑은 고딕"/>
-              </a:defRPr>
-            </a:pPr>
-            <a:r>
-              <a:t>⚠  SW가 센서 노이즈를 그대로 전달하면?</a:t>
-            </a:r>
-          </a:p>
-          <a:p>
-            <a:pPr algn="l">
-              <a:spcBef>
-                <a:spcPts val="0"/>
-              </a:spcBef>
-              <a:spcAft>
-                <a:spcPts val="600"/>
-              </a:spcAft>
-              <a:defRPr sz="1200" b="0">
-                <a:solidFill>
-                  <a:srgbClr val="333344"/>
-                </a:solidFill>
-                <a:latin typeface="맑은 고딕"/>
-              </a:defRPr>
-            </a:pPr>
-            <a:r>
-              <a:t>센서 경계값 떨림 → 모터에 초당 수십 번 ON/OFF 명령</a:t>
-            </a:r>
-          </a:p>
-          <a:p>
-            <a:pPr algn="l">
-              <a:spcBef>
-                <a:spcPts val="0"/>
-              </a:spcBef>
-              <a:spcAft>
-                <a:spcPts val="600"/>
-              </a:spcAft>
-              <a:defRPr sz="1200" b="1">
-                <a:solidFill>
-                  <a:srgbClr val="E53335"/>
-                </a:solidFill>
-                <a:latin typeface="맑은 고딕"/>
-              </a:defRPr>
-            </a:pPr>
-            <a:r>
-              <a:t>👉 모터 소손(Burn-out) 및 기어 마모 → 치명적 HW 파손</a:t>
-            </a:r>
-          </a:p>
           <a:p>
             <a:pPr algn="l">
               <a:spcBef>
@@ -4345,106 +4307,20 @@
               </a:spcAft>
               <a:defRPr sz="1200" b="1">
                 <a:solidFill>
-                  <a:srgbClr val="E53335"/>
-                </a:solidFill>
-                <a:latin typeface="맑은 고딕"/>
-              </a:defRPr>
-            </a:pPr>
-            <a:r>
-              <a:t>👉 래치 체결 불완전 → 차일드 락 기능 상실 → 승객 안전 위협</a:t>
-            </a:r>
-          </a:p>
-        </p:txBody>
-      </p:sp>
-      <p:sp>
-        <p:nvSpPr>
-          <p:cNvPr id="12" name="Rounded Rectangle 11"/>
-          <p:cNvSpPr/>
-          <p:nvPr/>
-        </p:nvSpPr>
-        <p:spPr>
-          <a:xfrm>
-            <a:off x="731520" y="5852160"/>
-            <a:ext cx="5029200" cy="548640"/>
-          </a:xfrm>
-          <a:prstGeom prst="roundRect">
-            <a:avLst/>
-          </a:prstGeom>
-          <a:solidFill>
-            <a:srgbClr val="0047AB"/>
-          </a:solidFill>
-          <a:ln>
-            <a:noFill/>
-          </a:ln>
-          <a:effectLst/>
-        </p:spPr>
-        <p:style>
-          <a:lnRef idx="1">
-            <a:schemeClr val="accent1"/>
-          </a:lnRef>
-          <a:fillRef idx="3">
-            <a:schemeClr val="accent1"/>
-          </a:fillRef>
-          <a:effectRef idx="2">
-            <a:schemeClr val="accent1"/>
-          </a:effectRef>
-          <a:fontRef idx="minor">
-            <a:schemeClr val="lt1"/>
-          </a:fontRef>
-        </p:style>
-        <p:txBody>
-          <a:bodyPr rtlCol="0" anchor="ctr"/>
-          <a:lstStyle/>
-          <a:p>
-            <a:pPr algn="ctr"/>
-          </a:p>
-        </p:txBody>
-      </p:sp>
-      <p:sp>
-        <p:nvSpPr>
-          <p:cNvPr id="13" name="TextBox 12"/>
-          <p:cNvSpPr txBox="1"/>
-          <p:nvPr/>
-        </p:nvSpPr>
-        <p:spPr>
-          <a:xfrm>
-            <a:off x="1005840" y="5897880"/>
-            <a:ext cx="4572000" cy="411480"/>
-          </a:xfrm>
-          <a:prstGeom prst="rect">
-            <a:avLst/>
-          </a:prstGeom>
-          <a:noFill/>
-        </p:spPr>
-        <p:txBody>
-          <a:bodyPr wrap="square">
-            <a:spAutoFit/>
-          </a:bodyPr>
-          <a:lstStyle/>
-          <a:p>
-            <a:pPr algn="l">
-              <a:spcBef>
-                <a:spcPts val="0"/>
-              </a:spcBef>
-              <a:spcAft>
-                <a:spcPts val="400"/>
-              </a:spcAft>
-              <a:defRPr sz="1200" b="1">
-                <a:solidFill>
                   <a:srgbClr val="FFFFFF"/>
                 </a:solidFill>
                 <a:latin typeface="맑은 고딕"/>
               </a:defRPr>
             </a:pPr>
             <a:r>
-              <a:t>✅  결론: 모터의 물리적 한계를 보호하는 SW 설계가 필수</a:t>
-            </a:r>
-          </a:p>
-        </p:txBody>
-      </p:sp>
-      <p:sp>
-        <p:nvSpPr>
-          <p:cNvPr id="14" name="TextBox 13"/>
+              <a:t>✅  결론: HW의 물리적 한계를 이해한 SW 설계가 필수</a:t>
+            </a:r>
+          </a:p>
+        </p:txBody>
+      </p:sp>
+      <p:sp>
+        <p:nvSpPr>
+          <p:cNvPr id="12" name="TextBox 11"/>
           <p:cNvSpPr txBox="1"/>
           <p:nvPr/>
         </p:nvSpPr>
@@ -4479,21 +4355,21 @@
               </a:defRPr>
             </a:pPr>
             <a:r>
-              <a:t>▎ SW 관점에서 정의한 3가지 핵심 문제</a:t>
-            </a:r>
-          </a:p>
-        </p:txBody>
-      </p:sp>
-      <p:sp>
-        <p:nvSpPr>
-          <p:cNvPr id="15" name="Rounded Rectangle 14"/>
+              <a:t>▎ 정의한 핵심 문제 → 해결 모듈 매핑</a:t>
+            </a:r>
+          </a:p>
+        </p:txBody>
+      </p:sp>
+      <p:sp>
+        <p:nvSpPr>
+          <p:cNvPr id="13" name="Rounded Rectangle 12"/>
           <p:cNvSpPr/>
           <p:nvPr/>
         </p:nvSpPr>
         <p:spPr>
           <a:xfrm>
             <a:off x="6400800" y="2651760"/>
-            <a:ext cx="5029200" cy="1143000"/>
+            <a:ext cx="5029200" cy="1234440"/>
           </a:xfrm>
           <a:prstGeom prst="roundRect">
             <a:avLst/>
@@ -4530,14 +4406,68 @@
       </p:sp>
       <p:sp>
         <p:nvSpPr>
-          <p:cNvPr id="16" name="TextBox 15"/>
+          <p:cNvPr id="14" name="Rounded Rectangle 13"/>
+          <p:cNvSpPr/>
+          <p:nvPr/>
+        </p:nvSpPr>
+        <p:spPr>
+          <a:xfrm>
+            <a:off x="10332720" y="2697480"/>
+            <a:ext cx="822960" cy="274320"/>
+          </a:xfrm>
+          <a:prstGeom prst="roundRect">
+            <a:avLst/>
+          </a:prstGeom>
+          <a:solidFill>
+            <a:srgbClr val="006ED6"/>
+          </a:solidFill>
+          <a:ln>
+            <a:noFill/>
+          </a:ln>
+          <a:effectLst/>
+        </p:spPr>
+        <p:style>
+          <a:lnRef idx="1">
+            <a:schemeClr val="accent1"/>
+          </a:lnRef>
+          <a:fillRef idx="3">
+            <a:schemeClr val="accent1"/>
+          </a:fillRef>
+          <a:effectRef idx="2">
+            <a:schemeClr val="accent1"/>
+          </a:effectRef>
+          <a:fontRef idx="minor">
+            <a:schemeClr val="lt1"/>
+          </a:fontRef>
+        </p:style>
+        <p:txBody>
+          <a:bodyPr rtlCol="0" anchor="ctr" wrap="none"/>
+          <a:lstStyle/>
+          <a:p>
+            <a:pPr algn="ctr">
+              <a:defRPr sz="900" b="1">
+                <a:solidFill>
+                  <a:srgbClr val="FFFFFF"/>
+                </a:solidFill>
+                <a:latin typeface="맑은 고딕"/>
+              </a:defRPr>
+            </a:pPr>
+            <a:r>
+              <a:t>→ F-07</a:t>
+            </a:r>
+          </a:p>
+        </p:txBody>
+      </p:sp>
+      <p:sp>
+        <p:nvSpPr>
+          <p:cNvPr id="15" name="TextBox 14"/>
           <p:cNvSpPr txBox="1"/>
           <p:nvPr/>
         </p:nvSpPr>
         <p:spPr>
           <a:xfrm>
             <a:off x="6675120" y="2697480"/>
-            <a:ext cx="4572000" cy="1051560"/>
+            <a:ext cx="3657600" cy="1097280"/>
           </a:xfrm>
           <a:prstGeom prst="rect">
             <a:avLst/>
@@ -4565,7 +4495,7 @@
               </a:defRPr>
             </a:pPr>
             <a:r>
-              <a:t>①  경계값 떨림에 의한 오판단</a:t>
+              <a:t>①  경계값 떨림 → 모터 소손 위험</a:t>
             </a:r>
           </a:p>
           <a:p>
@@ -4584,11 +4514,11 @@
               </a:defRPr>
             </a:pPr>
             <a:r>
-              <a:t>단순 if-else 비교 → 센서 노이즈에 의한</a:t>
+              <a:t>센서 노이즈 → 초당 수십 번 ON/OFF 명령</a:t>
             </a:r>
             <a:br/>
             <a:r>
-              <a:t>ON/OFF 반복 토글 → 모터 수명 저하</a:t>
+              <a:t>→ 모터 소손(Burn-out) + 기어 마모</a:t>
             </a:r>
           </a:p>
           <a:p>
@@ -4607,21 +4537,21 @@
               </a:defRPr>
             </a:pPr>
             <a:r>
-              <a:t>→ 해결: 히스테리시스 밴드 (500ms/1000ms)</a:t>
-            </a:r>
-          </a:p>
-        </p:txBody>
-      </p:sp>
-      <p:sp>
-        <p:nvSpPr>
-          <p:cNvPr id="17" name="Rounded Rectangle 16"/>
+              <a:t>→ 해결: 시간 기반 히스테리시스 밴드 (500ms/1000ms)</a:t>
+            </a:r>
+          </a:p>
+        </p:txBody>
+      </p:sp>
+      <p:sp>
+        <p:nvSpPr>
+          <p:cNvPr id="16" name="Rounded Rectangle 15"/>
           <p:cNvSpPr/>
           <p:nvPr/>
         </p:nvSpPr>
         <p:spPr>
           <a:xfrm>
-            <a:off x="6400800" y="3931920"/>
-            <a:ext cx="5029200" cy="1143000"/>
+            <a:off x="6400800" y="4023360"/>
+            <a:ext cx="5029200" cy="1234440"/>
           </a:xfrm>
           <a:prstGeom prst="roundRect">
             <a:avLst/>
@@ -4658,14 +4588,68 @@
       </p:sp>
       <p:sp>
         <p:nvSpPr>
+          <p:cNvPr id="17" name="Rounded Rectangle 16"/>
+          <p:cNvSpPr/>
+          <p:nvPr/>
+        </p:nvSpPr>
+        <p:spPr>
+          <a:xfrm>
+            <a:off x="10332720" y="4069080"/>
+            <a:ext cx="822960" cy="274320"/>
+          </a:xfrm>
+          <a:prstGeom prst="roundRect">
+            <a:avLst/>
+          </a:prstGeom>
+          <a:solidFill>
+            <a:srgbClr val="006ED6"/>
+          </a:solidFill>
+          <a:ln>
+            <a:noFill/>
+          </a:ln>
+          <a:effectLst/>
+        </p:spPr>
+        <p:style>
+          <a:lnRef idx="1">
+            <a:schemeClr val="accent1"/>
+          </a:lnRef>
+          <a:fillRef idx="3">
+            <a:schemeClr val="accent1"/>
+          </a:fillRef>
+          <a:effectRef idx="2">
+            <a:schemeClr val="accent1"/>
+          </a:effectRef>
+          <a:fontRef idx="minor">
+            <a:schemeClr val="lt1"/>
+          </a:fontRef>
+        </p:style>
+        <p:txBody>
+          <a:bodyPr rtlCol="0" anchor="ctr" wrap="none"/>
+          <a:lstStyle/>
+          <a:p>
+            <a:pPr algn="ctr">
+              <a:defRPr sz="900" b="1">
+                <a:solidFill>
+                  <a:srgbClr val="FFFFFF"/>
+                </a:solidFill>
+                <a:latin typeface="맑은 고딕"/>
+              </a:defRPr>
+            </a:pPr>
+            <a:r>
+              <a:t>→ F-08</a:t>
+            </a:r>
+          </a:p>
+        </p:txBody>
+      </p:sp>
+      <p:sp>
+        <p:nvSpPr>
           <p:cNvPr id="18" name="TextBox 17"/>
           <p:cNvSpPr txBox="1"/>
           <p:nvPr/>
         </p:nvSpPr>
         <p:spPr>
           <a:xfrm>
-            <a:off x="6675120" y="3977640"/>
-            <a:ext cx="4572000" cy="1051560"/>
+            <a:off x="6675120" y="4069080"/>
+            <a:ext cx="3657600" cy="1097280"/>
           </a:xfrm>
           <a:prstGeom prst="rect">
             <a:avLst/>
@@ -4712,11 +4696,11 @@
               </a:defRPr>
             </a:pPr>
             <a:r>
-              <a:t>센서 고장 인지 불가 → 차일드 락 풀림 방치</a:t>
+              <a:t>고장 인지 불가 → 차일드 락 풀림 방치</a:t>
             </a:r>
             <a:br/>
             <a:r>
-              <a:t>→ 아이가 문을 열고 도로로 추락 위험</a:t>
+              <a:t>→ 아이가 문 열고 도로 추락 위험</a:t>
             </a:r>
           </a:p>
           <a:p>
@@ -4735,7 +4719,7 @@
               </a:defRPr>
             </a:pPr>
             <a:r>
-              <a:t>→ 해결: SAFE_LOCKED 강제 잠금 정책</a:t>
+              <a:t>→ 해결: SAFE_LOCKED 강제 잠금 정책 (SDD 5.2.3)</a:t>
             </a:r>
           </a:p>
         </p:txBody>
@@ -4748,8 +4732,8 @@
         </p:nvSpPr>
         <p:spPr>
           <a:xfrm>
-            <a:off x="6400800" y="5212079"/>
-            <a:ext cx="5029200" cy="1143000"/>
+            <a:off x="6400800" y="5394960"/>
+            <a:ext cx="5029200" cy="960120"/>
           </a:xfrm>
           <a:prstGeom prst="roundRect">
             <a:avLst/>
@@ -4786,14 +4770,68 @@
       </p:sp>
       <p:sp>
         <p:nvSpPr>
-          <p:cNvPr id="20" name="TextBox 19"/>
+          <p:cNvPr id="20" name="Rounded Rectangle 19"/>
+          <p:cNvSpPr/>
+          <p:nvPr/>
+        </p:nvSpPr>
+        <p:spPr>
+          <a:xfrm>
+            <a:off x="9875520" y="5440680"/>
+            <a:ext cx="1280160" cy="274320"/>
+          </a:xfrm>
+          <a:prstGeom prst="roundRect">
+            <a:avLst/>
+          </a:prstGeom>
+          <a:solidFill>
+            <a:srgbClr val="006ED6"/>
+          </a:solidFill>
+          <a:ln>
+            <a:noFill/>
+          </a:ln>
+          <a:effectLst/>
+        </p:spPr>
+        <p:style>
+          <a:lnRef idx="1">
+            <a:schemeClr val="accent1"/>
+          </a:lnRef>
+          <a:fillRef idx="3">
+            <a:schemeClr val="accent1"/>
+          </a:fillRef>
+          <a:effectRef idx="2">
+            <a:schemeClr val="accent1"/>
+          </a:effectRef>
+          <a:fontRef idx="minor">
+            <a:schemeClr val="lt1"/>
+          </a:fontRef>
+        </p:style>
+        <p:txBody>
+          <a:bodyPr rtlCol="0" anchor="ctr" wrap="none"/>
+          <a:lstStyle/>
+          <a:p>
+            <a:pPr algn="ctr">
+              <a:defRPr sz="900" b="1">
+                <a:solidFill>
+                  <a:srgbClr val="FFFFFF"/>
+                </a:solidFill>
+                <a:latin typeface="맑은 고딕"/>
+              </a:defRPr>
+            </a:pPr>
+            <a:r>
+              <a:t>→ F-07 &amp; F-08</a:t>
+            </a:r>
+          </a:p>
+        </p:txBody>
+      </p:sp>
+      <p:sp>
+        <p:nvSpPr>
+          <p:cNvPr id="21" name="TextBox 20"/>
           <p:cNvSpPr txBox="1"/>
           <p:nvPr/>
         </p:nvSpPr>
         <p:spPr>
           <a:xfrm>
-            <a:off x="6675120" y="5257799"/>
-            <a:ext cx="4572000" cy="1051560"/>
+            <a:off x="6675120" y="5440680"/>
+            <a:ext cx="3017520" cy="822960"/>
           </a:xfrm>
           <a:prstGeom prst="rect">
             <a:avLst/>
@@ -4821,7 +4859,7 @@
               </a:defRPr>
             </a:pPr>
             <a:r>
-              <a:t>③  HW-SW 통합 관점 부재</a:t>
+              <a:t>③  HW-SW 융합 관점 부재</a:t>
             </a:r>
           </a:p>
           <a:p>
@@ -4840,11 +4878,7 @@
               </a:defRPr>
             </a:pPr>
             <a:r>
-              <a:t>모터 응답 지연/관성을 무시한 SW 설계</a:t>
-            </a:r>
-            <a:br/>
-            <a:r>
-              <a:t>→ 기계적 피로 누적 → 시스템 신뢰도 하락</a:t>
+              <a:t>모터 응답 ~50ms를 무시한 SW → 기계적 피로 누적</a:t>
             </a:r>
           </a:p>
           <a:p>
@@ -4863,14 +4897,14 @@
               </a:defRPr>
             </a:pPr>
             <a:r>
-              <a:t>→ 해결: 기계공학 기반 타이머 설계</a:t>
-            </a:r>
-          </a:p>
-        </p:txBody>
-      </p:sp>
-      <p:sp>
-        <p:nvSpPr>
-          <p:cNvPr id="21" name="TextBox 20"/>
+              <a:t>→ 해결: 기계공학 기반 안전 마진 타이머 설계</a:t>
+            </a:r>
+          </a:p>
+        </p:txBody>
+      </p:sp>
+      <p:sp>
+        <p:nvSpPr>
+          <p:cNvPr id="22" name="TextBox 21"/>
           <p:cNvSpPr txBox="1"/>
           <p:nvPr/>
         </p:nvSpPr>
@@ -5326,7 +5360,7 @@
               </a:defRPr>
             </a:pPr>
             <a:r>
-              <a:t>▎ 핵심: 히스테리시스(Hysteresis) — 왜 필요한가?</a:t>
+              <a:t>▎ 핵심: 시간 기반 히스테리시스 밴드 — 왜 필요한가?</a:t>
             </a:r>
           </a:p>
         </p:txBody>
@@ -5348,7 +5382,7 @@
         <p:spPr>
           <a:xfrm>
             <a:off x="6400800" y="2606040"/>
-            <a:ext cx="5029200" cy="2011680"/>
+            <a:ext cx="5029200" cy="1828800"/>
           </a:xfrm>
           <a:prstGeom prst="rect">
             <a:avLst/>
@@ -5363,8 +5397,8 @@
         </p:nvSpPr>
         <p:spPr>
           <a:xfrm>
-            <a:off x="6400800" y="4754880"/>
-            <a:ext cx="5029200" cy="1554480"/>
+            <a:off x="6400800" y="4572000"/>
+            <a:ext cx="5029200" cy="1828800"/>
           </a:xfrm>
           <a:prstGeom prst="roundRect">
             <a:avLst/>
@@ -5407,8 +5441,8 @@
         </p:nvSpPr>
         <p:spPr>
           <a:xfrm>
-            <a:off x="6675120" y="4846320"/>
-            <a:ext cx="4572000" cy="1371600"/>
+            <a:off x="6675120" y="4617720"/>
+            <a:ext cx="4572000" cy="1737360"/>
           </a:xfrm>
           <a:prstGeom prst="rect">
             <a:avLst/>
@@ -5426,7 +5460,7 @@
                 <a:spcPts val="0"/>
               </a:spcBef>
               <a:spcAft>
-                <a:spcPts val="800"/>
+                <a:spcPts val="600"/>
               </a:spcAft>
               <a:defRPr sz="1300" b="1">
                 <a:solidFill>
@@ -5436,7 +5470,7 @@
               </a:defRPr>
             </a:pPr>
             <a:r>
-              <a:t>🔧  HW 보호 관점의 히스테리시스 설계</a:t>
+              <a:t>🔧  HW 보호 관점의 시간 기반 히스테리시스 설계</a:t>
             </a:r>
           </a:p>
           <a:p>
@@ -5455,7 +5489,7 @@
               </a:defRPr>
             </a:pPr>
             <a:r>
-              <a:t>확정 타이머 (500ms):</a:t>
+              <a:t>확정 타이머 (500ms) — 모터 응답 ~50ms의 10배 마진 확보</a:t>
             </a:r>
           </a:p>
           <a:p>
@@ -5466,7 +5500,7 @@
               <a:spcAft>
                 <a:spcPts val="100"/>
               </a:spcAft>
-              <a:defRPr sz="1100" b="0">
+              <a:defRPr sz="1000" b="0">
                 <a:solidFill>
                   <a:srgbClr val="333344"/>
                 </a:solidFill>
@@ -5483,9 +5517,9 @@
                 <a:spcPts val="0"/>
               </a:spcBef>
               <a:spcAft>
-                <a:spcPts val="800"/>
+                <a:spcPts val="600"/>
               </a:spcAft>
-              <a:defRPr sz="1100" b="0">
+              <a:defRPr sz="1000" b="0">
                 <a:solidFill>
                   <a:srgbClr val="333344"/>
                 </a:solidFill>
@@ -5512,7 +5546,7 @@
               </a:defRPr>
             </a:pPr>
             <a:r>
-              <a:t>해제 타이머 (1000ms):</a:t>
+              <a:t>해제 타이머 (1000ms) — 확정 대비 2배 비대칭 설계</a:t>
             </a:r>
           </a:p>
           <a:p>
@@ -5523,7 +5557,7 @@
               <a:spcAft>
                 <a:spcPts val="100"/>
               </a:spcAft>
-              <a:defRPr sz="1100" b="0">
+              <a:defRPr sz="1000" b="0">
                 <a:solidFill>
                   <a:srgbClr val="333344"/>
                 </a:solidFill>
@@ -5531,7 +5565,45 @@
               </a:defRPr>
             </a:pPr>
             <a:r>
-              <a:t>안전한 상태가 1초 이상 지속되어야 해제 → 모터 반복 구동 방지</a:t>
+              <a:t>안전 해제는 더 보수적으로: 1초 이상 안전 지속 확인 후 해제</a:t>
+            </a:r>
+          </a:p>
+          <a:p>
+            <a:pPr algn="l">
+              <a:spcBef>
+                <a:spcPts val="0"/>
+              </a:spcBef>
+              <a:spcAft>
+                <a:spcPts val="600"/>
+              </a:spcAft>
+              <a:defRPr sz="1000" b="1">
+                <a:solidFill>
+                  <a:srgbClr val="0047AB"/>
+                </a:solidFill>
+                <a:latin typeface="맑은 고딕"/>
+              </a:defRPr>
+            </a:pPr>
+            <a:r>
+              <a:t>→ 모터 반복 구동 방지 + 기어 마모/소손 위험 원천 차단</a:t>
+            </a:r>
+          </a:p>
+          <a:p>
+            <a:pPr algn="l">
+              <a:spcBef>
+                <a:spcPts val="0"/>
+              </a:spcBef>
+              <a:spcAft>
+                <a:spcPts val="100"/>
+              </a:spcAft>
+              <a:defRPr sz="900" b="0">
+                <a:solidFill>
+                  <a:srgbClr val="666677"/>
+                </a:solidFill>
+                <a:latin typeface="맑은 고딕"/>
+              </a:defRPr>
+            </a:pPr>
+            <a:r>
+              <a:t>💡 참고: 자동차 BLDC 모터 제어에서 히스테리시스 비교기가</a:t>
             </a:r>
           </a:p>
           <a:p>
@@ -5542,15 +5614,15 @@
               <a:spcAft>
                 <a:spcPts val="400"/>
               </a:spcAft>
-              <a:defRPr sz="1100" b="1">
-                <a:solidFill>
-                  <a:srgbClr val="0047AB"/>
-                </a:solidFill>
-                <a:latin typeface="맑은 고딕"/>
-              </a:defRPr>
-            </a:pPr>
-            <a:r>
-              <a:t>→ 기어 마모/모터 소손 위험 원천 차단</a:t>
+              <a:defRPr sz="900" b="0">
+                <a:solidFill>
+                  <a:srgbClr val="666677"/>
+                </a:solidFill>
+                <a:latin typeface="맑은 고딕"/>
+              </a:defRPr>
+            </a:pPr>
+            <a:r>
+              <a:t>   노이즈/리플에 의한 다중 출력 전환 방지에 사용됨 (동일 원리)</a:t>
             </a:r>
           </a:p>
         </p:txBody>
@@ -5954,7 +6026,7 @@
       </p:sp>
       <p:pic>
         <p:nvPicPr>
-          <p:cNvPr id="9" name="Picture 8" descr="f08_failsafe_flow_1775564713956.png"/>
+          <p:cNvPr id="9" name="Picture 8" descr="f08_flowchart_v2_1775566715608.png"/>
           <p:cNvPicPr>
             <a:picLocks noChangeAspect="1"/>
           </p:cNvPicPr>
@@ -7071,7 +7143,7 @@
         <p:spPr>
           <a:xfrm>
             <a:off x="731520" y="2926080"/>
-            <a:ext cx="3474720" cy="3474720"/>
+            <a:ext cx="3474720" cy="3566160"/>
           </a:xfrm>
           <a:prstGeom prst="roundRect">
             <a:avLst/>
@@ -7198,7 +7270,7 @@
                 <a:spcPts val="0"/>
               </a:spcBef>
               <a:spcAft>
-                <a:spcPts val="1000"/>
+                <a:spcPts val="800"/>
               </a:spcAft>
               <a:defRPr sz="900" b="0">
                 <a:solidFill>
@@ -7236,7 +7308,7 @@
                 <a:spcPts val="0"/>
               </a:spcBef>
               <a:spcAft>
-                <a:spcPts val="1000"/>
+                <a:spcPts val="800"/>
               </a:spcAft>
               <a:defRPr sz="1000" b="0">
                 <a:solidFill>
@@ -7269,7 +7341,7 @@
               </a:defRPr>
             </a:pPr>
             <a:r>
-              <a:t>📐 히스테리시스 적용</a:t>
+              <a:t>📐 시간 기반 히스테리시스 적용</a:t>
             </a:r>
           </a:p>
           <a:p>
@@ -7348,7 +7420,7 @@
         <p:spPr>
           <a:xfrm>
             <a:off x="4480559" y="2926080"/>
-            <a:ext cx="3474720" cy="3474720"/>
+            <a:ext cx="3474720" cy="3566160"/>
           </a:xfrm>
           <a:prstGeom prst="roundRect">
             <a:avLst/>
@@ -7475,7 +7547,7 @@
                 <a:spcPts val="0"/>
               </a:spcBef>
               <a:spcAft>
-                <a:spcPts val="1000"/>
+                <a:spcPts val="800"/>
               </a:spcAft>
               <a:defRPr sz="900" b="0">
                 <a:solidFill>
@@ -7513,7 +7585,7 @@
                 <a:spcPts val="0"/>
               </a:spcBef>
               <a:spcAft>
-                <a:spcPts val="1000"/>
+                <a:spcPts val="800"/>
               </a:spcAft>
               <a:defRPr sz="1000" b="0">
                 <a:solidFill>
@@ -7546,7 +7618,7 @@
               </a:defRPr>
             </a:pPr>
             <a:r>
-              <a:t>📐 히스테리시스 적용</a:t>
+              <a:t>📐 시간 기반 히스테리시스 적용</a:t>
             </a:r>
           </a:p>
           <a:p>
@@ -7625,7 +7697,7 @@
         <p:spPr>
           <a:xfrm>
             <a:off x="8229600" y="2926080"/>
-            <a:ext cx="3474720" cy="3474720"/>
+            <a:ext cx="3474720" cy="3566160"/>
           </a:xfrm>
           <a:prstGeom prst="roundRect">
             <a:avLst/>
@@ -7752,7 +7824,7 @@
                 <a:spcPts val="0"/>
               </a:spcBef>
               <a:spcAft>
-                <a:spcPts val="1000"/>
+                <a:spcPts val="800"/>
               </a:spcAft>
               <a:defRPr sz="900" b="0">
                 <a:solidFill>
@@ -7790,7 +7862,7 @@
                 <a:spcPts val="0"/>
               </a:spcBef>
               <a:spcAft>
-                <a:spcPts val="1000"/>
+                <a:spcPts val="800"/>
               </a:spcAft>
               <a:defRPr sz="1000" b="0">
                 <a:solidFill>
@@ -7823,7 +7895,7 @@
               </a:defRPr>
             </a:pPr>
             <a:r>
-              <a:t>📐 히스테리시스 적용</a:t>
+              <a:t>📐 시간 기반 히스테리시스 적용</a:t>
             </a:r>
           </a:p>
           <a:p>

</xml_diff>

<commit_message>
chore: initialize git repository and update project documentation and research files
</commit_message>
<xml_diff>
--- a/docs/SL_온라인PT_발표자료.pptx
+++ b/docs/SL_온라인PT_발표자료.pptx
@@ -1,16 +1,16 @@
 
 <file path=ppt/presentation.xml><?xml version="1.0" encoding="utf-8"?>
-<p:presentation xmlns:r="http://schemas.openxmlformats.org/officeDocument/2006/relationships" xmlns:c="http://schemas.openxmlformats.org/drawingml/2006/chart" xmlns:a="http://schemas.openxmlformats.org/drawingml/2006/main" xmlns:dgm="http://schemas.openxmlformats.org/drawingml/2006/diagram" xmlns:dsp="http://schemas.microsoft.com/office/drawing/2008/diagram" xmlns:p="http://schemas.openxmlformats.org/presentationml/2006/main" autoCompressPictures="0">
+<p:presentation xmlns:a="http://schemas.openxmlformats.org/drawingml/2006/main" xmlns:r="http://schemas.openxmlformats.org/officeDocument/2006/relationships" xmlns:p="http://schemas.openxmlformats.org/presentationml/2006/main" saveSubsetFonts="1" autoCompressPictures="0">
   <p:sldMasterIdLst>
     <p:sldMasterId id="2147483648" r:id="rId1"/>
   </p:sldMasterIdLst>
   <p:sldIdLst>
-    <p:sldId id="256" r:id="rId2"/>
-    <p:sldId id="257" r:id="rId3"/>
-    <p:sldId id="258" r:id="rId4"/>
-    <p:sldId id="259" r:id="rId5"/>
-    <p:sldId id="260" r:id="rId6"/>
-    <p:sldId id="261" r:id="rId7"/>
+    <p:sldId id="256" r:id="rId7"/>
+    <p:sldId id="257" r:id="rId8"/>
+    <p:sldId id="258" r:id="rId9"/>
+    <p:sldId id="259" r:id="rId10"/>
+    <p:sldId id="260" r:id="rId11"/>
+    <p:sldId id="261" r:id="rId12"/>
   </p:sldIdLst>
   <p:sldSz cx="12191695" cy="6858000" type="screen4x3"/>
   <p:notesSz cx="6858000" cy="9144000"/>
@@ -3084,7 +3084,7 @@
 </file>
 
 <file path=ppt/slides/slide1.xml><?xml version="1.0" encoding="utf-8"?>
-<p:sld xmlns:r="http://schemas.openxmlformats.org/officeDocument/2006/relationships" xmlns:c="http://schemas.openxmlformats.org/drawingml/2006/chart" xmlns:a="http://schemas.openxmlformats.org/drawingml/2006/main" xmlns:dgm="http://schemas.openxmlformats.org/drawingml/2006/diagram" xmlns:dsp="http://schemas.microsoft.com/office/drawing/2008/diagram" xmlns:p="http://schemas.openxmlformats.org/presentationml/2006/main">
+<p:sld xmlns:a="http://schemas.openxmlformats.org/drawingml/2006/main" xmlns:p="http://schemas.openxmlformats.org/presentationml/2006/main" xmlns:r="http://schemas.openxmlformats.org/officeDocument/2006/relationships">
   <p:cSld>
     <p:spTree>
       <p:nvGrpSpPr>
@@ -3092,14 +3092,7 @@
         <p:cNvGrpSpPr/>
         <p:nvPr/>
       </p:nvGrpSpPr>
-      <p:grpSpPr>
-        <a:xfrm>
-          <a:off x="0" y="0"/>
-          <a:ext cx="0" cy="0"/>
-          <a:chOff x="0" y="0"/>
-          <a:chExt cx="0" cy="0"/>
-        </a:xfrm>
-      </p:grpSpPr>
+      <p:grpSpPr/>
       <p:sp>
         <p:nvSpPr>
           <p:cNvPr id="2" name="Rectangle 1"/>
@@ -3234,16 +3227,60 @@
       </p:sp>
       <p:sp>
         <p:nvSpPr>
-          <p:cNvPr id="7" name="Rounded Rectangle 6"/>
+          <p:cNvPr id="5" name="Rectangle 4"/>
           <p:cNvSpPr/>
           <p:nvPr/>
         </p:nvSpPr>
         <p:spPr>
           <a:xfrm>
-            <a:off x="1097280" y="1645920"/>
-            <a:ext cx="914400" cy="274320"/>
-          </a:xfrm>
-          <a:prstGeom prst="roundRect">
+            <a:off x="9601200" y="274320"/>
+            <a:ext cx="2286000" cy="731520"/>
+          </a:xfrm>
+          <a:prstGeom prst="rect">
+            <a:avLst/>
+          </a:prstGeom>
+          <a:solidFill>
+            <a:srgbClr val="0047AB"/>
+          </a:solidFill>
+          <a:ln>
+            <a:noFill/>
+          </a:ln>
+          <a:effectLst/>
+        </p:spPr>
+        <p:style>
+          <a:lnRef idx="1">
+            <a:schemeClr val="accent1"/>
+          </a:lnRef>
+          <a:fillRef idx="3">
+            <a:schemeClr val="accent1"/>
+          </a:fillRef>
+          <a:effectRef idx="2">
+            <a:schemeClr val="accent1"/>
+          </a:effectRef>
+          <a:fontRef idx="minor">
+            <a:schemeClr val="lt1"/>
+          </a:fontRef>
+        </p:style>
+        <p:txBody>
+          <a:bodyPr rtlCol="0" anchor="ctr"/>
+          <a:lstStyle/>
+          <a:p>
+            <a:pPr algn="ctr"/>
+          </a:p>
+        </p:txBody>
+      </p:sp>
+      <p:sp>
+        <p:nvSpPr>
+          <p:cNvPr id="6" name="Rectangle 5"/>
+          <p:cNvSpPr/>
+          <p:nvPr/>
+        </p:nvSpPr>
+        <p:spPr>
+          <a:xfrm>
+            <a:off x="10058400" y="1188720"/>
+            <a:ext cx="1828800" cy="457200"/>
+          </a:xfrm>
+          <a:prstGeom prst="rect">
             <a:avLst/>
           </a:prstGeom>
           <a:solidFill>
@@ -3269,33 +3306,23 @@
           </a:fontRef>
         </p:style>
         <p:txBody>
-          <a:bodyPr rtlCol="0" anchor="ctr" wrap="none"/>
-          <a:lstStyle/>
-          <a:p>
-            <a:pPr algn="ctr">
-              <a:defRPr sz="900" b="1">
-                <a:solidFill>
-                  <a:srgbClr val="FFFFFF"/>
-                </a:solidFill>
-                <a:latin typeface="맑은 고딕"/>
-              </a:defRPr>
-            </a:pPr>
-            <a:r>
-              <a:t>ASIL-B</a:t>
-            </a:r>
-          </a:p>
-        </p:txBody>
-      </p:sp>
-      <p:sp>
-        <p:nvSpPr>
-          <p:cNvPr id="8" name="Rounded Rectangle 7"/>
+          <a:bodyPr rtlCol="0" anchor="ctr"/>
+          <a:lstStyle/>
+          <a:p>
+            <a:pPr algn="ctr"/>
+          </a:p>
+        </p:txBody>
+      </p:sp>
+      <p:sp>
+        <p:nvSpPr>
+          <p:cNvPr id="7" name="Rounded Rectangle 6"/>
           <p:cNvSpPr/>
           <p:nvPr/>
         </p:nvSpPr>
         <p:spPr>
           <a:xfrm>
-            <a:off x="2194560" y="1645920"/>
-            <a:ext cx="1188720" cy="274320"/>
+            <a:off x="1097280" y="1645920"/>
+            <a:ext cx="914400" cy="274320"/>
           </a:xfrm>
           <a:prstGeom prst="roundRect">
             <a:avLst/>
@@ -3335,21 +3362,21 @@
               </a:defRPr>
             </a:pPr>
             <a:r>
-              <a:t>ISO 26262</a:t>
-            </a:r>
-          </a:p>
-        </p:txBody>
-      </p:sp>
-      <p:sp>
-        <p:nvSpPr>
-          <p:cNvPr id="9" name="Rounded Rectangle 8"/>
+              <a:t>ASIL-B</a:t>
+            </a:r>
+          </a:p>
+        </p:txBody>
+      </p:sp>
+      <p:sp>
+        <p:nvSpPr>
+          <p:cNvPr id="8" name="Rounded Rectangle 7"/>
           <p:cNvSpPr/>
           <p:nvPr/>
         </p:nvSpPr>
         <p:spPr>
           <a:xfrm>
-            <a:off x="3566160" y="1645920"/>
-            <a:ext cx="1371600" cy="274320"/>
+            <a:off x="2194560" y="1645920"/>
+            <a:ext cx="1188720" cy="274320"/>
           </a:xfrm>
           <a:prstGeom prst="roundRect">
             <a:avLst/>
@@ -3389,84 +3416,23 @@
               </a:defRPr>
             </a:pPr>
             <a:r>
-              <a:t>MISRA C:2012</a:t>
-            </a:r>
-          </a:p>
-        </p:txBody>
-      </p:sp>
-      <p:sp>
-        <p:nvSpPr>
-          <p:cNvPr id="10" name="TextBox 9"/>
-          <p:cNvSpPr txBox="1"/>
-          <p:nvPr/>
-        </p:nvSpPr>
-        <p:spPr>
-          <a:xfrm>
-            <a:off x="1097280" y="2286000"/>
-            <a:ext cx="9144000" cy="2286000"/>
-          </a:xfrm>
-          <a:prstGeom prst="rect">
-            <a:avLst/>
-          </a:prstGeom>
-          <a:noFill/>
-        </p:spPr>
-        <p:txBody>
-          <a:bodyPr wrap="square">
-            <a:spAutoFit/>
-          </a:bodyPr>
-          <a:lstStyle/>
-          <a:p>
-            <a:pPr algn="l">
-              <a:spcBef>
-                <a:spcPts val="0"/>
-              </a:spcBef>
-              <a:spcAft>
-                <a:spcPts val="200"/>
-              </a:spcAft>
-              <a:defRPr sz="2000" b="0">
-                <a:solidFill>
-                  <a:srgbClr val="CCE5FF"/>
-                </a:solidFill>
-                <a:latin typeface="맑은 고딕"/>
-              </a:defRPr>
-            </a:pPr>
-            <a:r>
-              <a:t>기계공학의 메커니즘 위에</a:t>
-            </a:r>
-          </a:p>
-          <a:p>
-            <a:pPr algn="l">
-              <a:spcBef>
-                <a:spcPts val="0"/>
-              </a:spcBef>
-              <a:spcAft>
-                <a:spcPts val="1600"/>
-              </a:spcAft>
-              <a:defRPr sz="3600" b="1">
-                <a:solidFill>
-                  <a:srgbClr val="FFFFFF"/>
-                </a:solidFill>
-                <a:latin typeface="맑은 고딕"/>
-              </a:defRPr>
-            </a:pPr>
-            <a:r>
-              <a:t>ASIL-B 등급의 SW 안전을 설계하다.</a:t>
-            </a:r>
-          </a:p>
-        </p:txBody>
-      </p:sp>
-      <p:sp>
-        <p:nvSpPr>
-          <p:cNvPr id="11" name="Rectangle 10"/>
+              <a:t>ISO 26262</a:t>
+            </a:r>
+          </a:p>
+        </p:txBody>
+      </p:sp>
+      <p:sp>
+        <p:nvSpPr>
+          <p:cNvPr id="9" name="Rounded Rectangle 8"/>
           <p:cNvSpPr/>
           <p:nvPr/>
         </p:nvSpPr>
         <p:spPr>
           <a:xfrm>
-            <a:off x="1097280" y="4206240"/>
-            <a:ext cx="3657600" cy="2743"/>
-          </a:xfrm>
-          <a:prstGeom prst="rect">
+            <a:off x="3566160" y="1645920"/>
+            <a:ext cx="1371600" cy="274320"/>
+          </a:xfrm>
+          <a:prstGeom prst="roundRect">
             <a:avLst/>
           </a:prstGeom>
           <a:solidFill>
@@ -3492,23 +3458,33 @@
           </a:fontRef>
         </p:style>
         <p:txBody>
-          <a:bodyPr rtlCol="0" anchor="ctr"/>
-          <a:lstStyle/>
-          <a:p>
-            <a:pPr algn="ctr"/>
-          </a:p>
-        </p:txBody>
-      </p:sp>
-      <p:sp>
-        <p:nvSpPr>
-          <p:cNvPr id="12" name="TextBox 11"/>
+          <a:bodyPr rtlCol="0" anchor="ctr" wrap="none"/>
+          <a:lstStyle/>
+          <a:p>
+            <a:pPr algn="ctr">
+              <a:defRPr sz="900" b="1">
+                <a:solidFill>
+                  <a:srgbClr val="FFFFFF"/>
+                </a:solidFill>
+                <a:latin typeface="맑은 고딕"/>
+              </a:defRPr>
+            </a:pPr>
+            <a:r>
+              <a:t>MISRA C:2012</a:t>
+            </a:r>
+          </a:p>
+        </p:txBody>
+      </p:sp>
+      <p:sp>
+        <p:nvSpPr>
+          <p:cNvPr id="10" name="TextBox 9"/>
           <p:cNvSpPr txBox="1"/>
           <p:nvPr/>
         </p:nvSpPr>
         <p:spPr>
           <a:xfrm>
-            <a:off x="1097280" y="4389120"/>
-            <a:ext cx="9144000" cy="628650"/>
+            <a:off x="1097280" y="2286000"/>
+            <a:ext cx="9144000" cy="2286000"/>
           </a:xfrm>
           <a:prstGeom prst="rect">
             <a:avLst/>
@@ -3521,7 +3497,112 @@
           </a:bodyPr>
           <a:lstStyle/>
           <a:p>
-            <a:pPr lvl="0" algn="l">
+            <a:pPr algn="l">
+              <a:spcBef>
+                <a:spcPts val="0"/>
+              </a:spcBef>
+              <a:spcAft>
+                <a:spcPts val="200"/>
+              </a:spcAft>
+              <a:defRPr sz="2000" b="0">
+                <a:solidFill>
+                  <a:srgbClr val="CCE5FF"/>
+                </a:solidFill>
+                <a:latin typeface="맑은 고딕"/>
+              </a:defRPr>
+            </a:pPr>
+            <a:r>
+              <a:t>기계공학의 메커니즘 위에</a:t>
+            </a:r>
+          </a:p>
+          <a:p>
+            <a:pPr algn="l">
+              <a:spcBef>
+                <a:spcPts val="0"/>
+              </a:spcBef>
+              <a:spcAft>
+                <a:spcPts val="1600"/>
+              </a:spcAft>
+              <a:defRPr sz="3600" b="1">
+                <a:solidFill>
+                  <a:srgbClr val="FFFFFF"/>
+                </a:solidFill>
+                <a:latin typeface="맑은 고딕"/>
+              </a:defRPr>
+            </a:pPr>
+            <a:r>
+              <a:t>ASIL-B 수준의 안전 목표를 가정한 SW를 설계하다.</a:t>
+            </a:r>
+          </a:p>
+        </p:txBody>
+      </p:sp>
+      <p:sp>
+        <p:nvSpPr>
+          <p:cNvPr id="11" name="Rectangle 10"/>
+          <p:cNvSpPr/>
+          <p:nvPr/>
+        </p:nvSpPr>
+        <p:spPr>
+          <a:xfrm>
+            <a:off x="1097280" y="4206240"/>
+            <a:ext cx="3657600" cy="2743"/>
+          </a:xfrm>
+          <a:prstGeom prst="rect">
+            <a:avLst/>
+          </a:prstGeom>
+          <a:solidFill>
+            <a:srgbClr val="006ED6"/>
+          </a:solidFill>
+          <a:ln>
+            <a:noFill/>
+          </a:ln>
+          <a:effectLst/>
+        </p:spPr>
+        <p:style>
+          <a:lnRef idx="1">
+            <a:schemeClr val="accent1"/>
+          </a:lnRef>
+          <a:fillRef idx="3">
+            <a:schemeClr val="accent1"/>
+          </a:fillRef>
+          <a:effectRef idx="2">
+            <a:schemeClr val="accent1"/>
+          </a:effectRef>
+          <a:fontRef idx="minor">
+            <a:schemeClr val="lt1"/>
+          </a:fontRef>
+        </p:style>
+        <p:txBody>
+          <a:bodyPr rtlCol="0" anchor="ctr"/>
+          <a:lstStyle/>
+          <a:p>
+            <a:pPr algn="ctr"/>
+          </a:p>
+        </p:txBody>
+      </p:sp>
+      <p:sp>
+        <p:nvSpPr>
+          <p:cNvPr id="12" name="TextBox 11"/>
+          <p:cNvSpPr txBox="1"/>
+          <p:nvPr/>
+        </p:nvSpPr>
+        <p:spPr>
+          <a:xfrm>
+            <a:off x="1097280" y="4389120"/>
+            <a:ext cx="9144000" cy="1097280"/>
+          </a:xfrm>
+          <a:prstGeom prst="rect">
+            <a:avLst/>
+          </a:prstGeom>
+          <a:noFill/>
+        </p:spPr>
+        <p:txBody>
+          <a:bodyPr wrap="square">
+            <a:spAutoFit/>
+          </a:bodyPr>
+          <a:lstStyle/>
+          <a:p>
+            <a:pPr algn="l">
               <a:spcBef>
                 <a:spcPts val="0"/>
               </a:spcBef>
@@ -3530,19 +3611,17 @@
               </a:spcAft>
               <a:defRPr sz="1600" b="0">
                 <a:solidFill>
-                  <a:srgbClr val="cce5ff"/>
-                </a:solidFill>
-                <a:latin typeface="맑은 고딕"/>
-              </a:defRPr>
-            </a:pPr>
-            <a:r>
-              <a:rPr lang="ko-KR" altLang="en-US"/>
+                  <a:srgbClr val="CCE5FF"/>
+                </a:solidFill>
+                <a:latin typeface="맑은 고딕"/>
+              </a:defRPr>
+            </a:pPr>
+            <a:r>
               <a:t>하드웨어와 소프트웨어의 경계를 허무는 융합형 문제 해결사</a:t>
             </a:r>
-            <a:endParaRPr lang="ko-KR" altLang="en-US"/>
-          </a:p>
-          <a:p>
-            <a:pPr lvl="0" algn="l">
+          </a:p>
+          <a:p>
+            <a:pPr algn="l">
               <a:spcBef>
                 <a:spcPts val="0"/>
               </a:spcBef>
@@ -3557,18 +3636,8 @@
               </a:defRPr>
             </a:pPr>
             <a:r>
-              <a:rPr lang="ko-KR" altLang="en-US">
-                <a:solidFill>
-                  <a:schemeClr val="lt1"/>
-                </a:solidFill>
-              </a:rPr>
               <a:t>차량 도어 기구학 + 센서 물리 모델 + Fail-Safe SW 설계</a:t>
             </a:r>
-            <a:endParaRPr lang="ko-KR" altLang="en-US">
-              <a:solidFill>
-                <a:schemeClr val="lt1"/>
-              </a:solidFill>
-            </a:endParaRPr>
           </a:p>
         </p:txBody>
       </p:sp>
@@ -3625,7 +3694,7 @@
         <p:spPr>
           <a:xfrm>
             <a:off x="1097280" y="6217920"/>
-            <a:ext cx="10058400" cy="257174"/>
+            <a:ext cx="10058400" cy="548640"/>
           </a:xfrm>
           <a:prstGeom prst="rect">
             <a:avLst/>
@@ -3638,7 +3707,7 @@
           </a:bodyPr>
           <a:lstStyle/>
           <a:p>
-            <a:pPr lvl="0" algn="l">
+            <a:pPr algn="l">
               <a:spcBef>
                 <a:spcPts val="0"/>
               </a:spcBef>
@@ -3653,18 +3722,8 @@
               </a:defRPr>
             </a:pPr>
             <a:r>
-              <a:rPr lang="ko-KR" altLang="en-US">
-                <a:solidFill>
-                  <a:schemeClr val="lt1"/>
-                </a:solidFill>
-              </a:rPr>
               <a:t>지원 직무: 연구개발(R&amp;D)  ·  차량 SW 제어 로직 개발  ·  전장 부품 안전 설계</a:t>
             </a:r>
-            <a:endParaRPr lang="ko-KR" altLang="en-US">
-              <a:solidFill>
-                <a:schemeClr val="lt1"/>
-              </a:solidFill>
-            </a:endParaRPr>
           </a:p>
         </p:txBody>
       </p:sp>
@@ -3713,7 +3772,7 @@
 </file>
 
 <file path=ppt/slides/slide2.xml><?xml version="1.0" encoding="utf-8"?>
-<p:sld xmlns:r="http://schemas.openxmlformats.org/officeDocument/2006/relationships" xmlns:c="http://schemas.openxmlformats.org/drawingml/2006/chart" xmlns:a="http://schemas.openxmlformats.org/drawingml/2006/main" xmlns:dgm="http://schemas.openxmlformats.org/drawingml/2006/diagram" xmlns:dsp="http://schemas.microsoft.com/office/drawing/2008/diagram" xmlns:p="http://schemas.openxmlformats.org/presentationml/2006/main">
+<p:sld xmlns:a="http://schemas.openxmlformats.org/drawingml/2006/main" xmlns:p="http://schemas.openxmlformats.org/presentationml/2006/main" xmlns:r="http://schemas.openxmlformats.org/officeDocument/2006/relationships">
   <p:cSld>
     <p:spTree>
       <p:nvGrpSpPr>
@@ -3721,14 +3780,7 @@
         <p:cNvGrpSpPr/>
         <p:nvPr/>
       </p:nvGrpSpPr>
-      <p:grpSpPr>
-        <a:xfrm>
-          <a:off x="0" y="0"/>
-          <a:ext cx="0" cy="0"/>
-          <a:chOff x="0" y="0"/>
-          <a:chExt cx="0" cy="0"/>
-        </a:xfrm>
-      </p:grpSpPr>
+      <p:grpSpPr/>
       <p:sp>
         <p:nvSpPr>
           <p:cNvPr id="2" name="Rectangle 1"/>
@@ -3927,7 +3979,7 @@
               </a:defRPr>
             </a:pPr>
             <a:r>
-              <a:t>HW와 SW의 유기적 통합의 괴리를 '문제'로 정의하다.</a:t>
+              <a:t>센서의 불확실성이 액추에이터를 위협하는 구조를 '문제'로 정의하다.</a:t>
             </a:r>
           </a:p>
         </p:txBody>
@@ -4013,7 +4065,7 @@
               </a:defRPr>
             </a:pPr>
             <a:r>
-              <a:t>▎ 차일드 락 액추에이터의 기계적 특성</a:t>
+              <a:t>▎ 위험 인지 센서의 한계</a:t>
             </a:r>
           </a:p>
         </p:txBody>
@@ -4026,8 +4078,193 @@
         </p:nvSpPr>
         <p:spPr>
           <a:xfrm>
-            <a:off x="731520" y="2651760"/>
-            <a:ext cx="5029200" cy="1645920"/>
+            <a:off x="731520" y="2560320"/>
+            <a:ext cx="5029200" cy="1097280"/>
+          </a:xfrm>
+          <a:prstGeom prst="roundRect">
+            <a:avLst/>
+          </a:prstGeom>
+          <a:solidFill>
+            <a:srgbClr val="FFF8E1"/>
+          </a:solidFill>
+          <a:ln>
+            <a:noFill/>
+          </a:ln>
+          <a:effectLst/>
+        </p:spPr>
+        <p:style>
+          <a:lnRef idx="1">
+            <a:schemeClr val="accent1"/>
+          </a:lnRef>
+          <a:fillRef idx="3">
+            <a:schemeClr val="accent1"/>
+          </a:fillRef>
+          <a:effectRef idx="2">
+            <a:schemeClr val="accent1"/>
+          </a:effectRef>
+          <a:fontRef idx="minor">
+            <a:schemeClr val="lt1"/>
+          </a:fontRef>
+        </p:style>
+        <p:txBody>
+          <a:bodyPr rtlCol="0" anchor="ctr"/>
+          <a:lstStyle/>
+          <a:p>
+            <a:pPr algn="ctr"/>
+          </a:p>
+        </p:txBody>
+      </p:sp>
+      <p:sp>
+        <p:nvSpPr>
+          <p:cNvPr id="9" name="TextBox 8"/>
+          <p:cNvSpPr txBox="1"/>
+          <p:nvPr/>
+        </p:nvSpPr>
+        <p:spPr>
+          <a:xfrm>
+            <a:off x="1005840" y="2606040"/>
+            <a:ext cx="4572000" cy="1005840"/>
+          </a:xfrm>
+          <a:prstGeom prst="rect">
+            <a:avLst/>
+          </a:prstGeom>
+          <a:noFill/>
+        </p:spPr>
+        <p:txBody>
+          <a:bodyPr wrap="square">
+            <a:spAutoFit/>
+          </a:bodyPr>
+          <a:lstStyle/>
+          <a:p>
+            <a:pPr algn="l">
+              <a:spcBef>
+                <a:spcPts val="0"/>
+              </a:spcBef>
+              <a:spcAft>
+                <a:spcPts val="600"/>
+              </a:spcAft>
+              <a:defRPr sz="1300" b="1">
+                <a:solidFill>
+                  <a:srgbClr val="FF6B35"/>
+                </a:solidFill>
+                <a:latin typeface="맑은 고딕"/>
+              </a:defRPr>
+            </a:pPr>
+            <a:r>
+              <a:t>📡  후방 접근 감지 센서</a:t>
+            </a:r>
+          </a:p>
+          <a:p>
+            <a:pPr algn="l">
+              <a:spcBef>
+                <a:spcPts val="0"/>
+              </a:spcBef>
+              <a:spcAft>
+                <a:spcPts val="300"/>
+              </a:spcAft>
+              <a:defRPr sz="1100" b="0">
+                <a:solidFill>
+                  <a:srgbClr val="333344"/>
+                </a:solidFill>
+                <a:latin typeface="맑은 고딕"/>
+              </a:defRPr>
+            </a:pPr>
+            <a:r>
+              <a:t>• 노이즈 / 경계값 흔들림: 실제 접근 없이도 위험 판정이 토글됨</a:t>
+            </a:r>
+          </a:p>
+          <a:p>
+            <a:pPr algn="l">
+              <a:spcBef>
+                <a:spcPts val="0"/>
+              </a:spcBef>
+              <a:spcAft>
+                <a:spcPts val="300"/>
+              </a:spcAft>
+              <a:defRPr sz="1100" b="0">
+                <a:solidFill>
+                  <a:srgbClr val="333344"/>
+                </a:solidFill>
+                <a:latin typeface="맑은 고딕"/>
+              </a:defRPr>
+            </a:pPr>
+            <a:r>
+              <a:t>• 온도 드리프트: 극저온/고온 환경에서 센서 출력값 변동</a:t>
+            </a:r>
+          </a:p>
+          <a:p>
+            <a:pPr algn="l">
+              <a:spcBef>
+                <a:spcPts val="0"/>
+              </a:spcBef>
+              <a:spcAft>
+                <a:spcPts val="400"/>
+              </a:spcAft>
+              <a:defRPr sz="1100" b="0">
+                <a:solidFill>
+                  <a:srgbClr val="333344"/>
+                </a:solidFill>
+                <a:latin typeface="맑은 고딕"/>
+              </a:defRPr>
+            </a:pPr>
+            <a:r>
+              <a:t>• 센서 고장 시 신뢰도 저하: 고장 인지 불가 상태 발생 가능</a:t>
+            </a:r>
+          </a:p>
+        </p:txBody>
+      </p:sp>
+      <p:sp>
+        <p:nvSpPr>
+          <p:cNvPr id="10" name="TextBox 9"/>
+          <p:cNvSpPr txBox="1"/>
+          <p:nvPr/>
+        </p:nvSpPr>
+        <p:spPr>
+          <a:xfrm>
+            <a:off x="731520" y="3794760"/>
+            <a:ext cx="5029200" cy="457200"/>
+          </a:xfrm>
+          <a:prstGeom prst="rect">
+            <a:avLst/>
+          </a:prstGeom>
+          <a:noFill/>
+        </p:spPr>
+        <p:txBody>
+          <a:bodyPr wrap="square">
+            <a:spAutoFit/>
+          </a:bodyPr>
+          <a:lstStyle/>
+          <a:p>
+            <a:pPr algn="l">
+              <a:spcBef>
+                <a:spcPts val="0"/>
+              </a:spcBef>
+              <a:spcAft>
+                <a:spcPts val="400"/>
+              </a:spcAft>
+              <a:defRPr sz="1500" b="1">
+                <a:solidFill>
+                  <a:srgbClr val="002B5C"/>
+                </a:solidFill>
+                <a:latin typeface="맑은 고딕"/>
+              </a:defRPr>
+            </a:pPr>
+            <a:r>
+              <a:t>▎ 차일드 락 액추에이터의 한계</a:t>
+            </a:r>
+          </a:p>
+        </p:txBody>
+      </p:sp>
+      <p:sp>
+        <p:nvSpPr>
+          <p:cNvPr id="11" name="Rounded Rectangle 10"/>
+          <p:cNvSpPr/>
+          <p:nvPr/>
+        </p:nvSpPr>
+        <p:spPr>
+          <a:xfrm>
+            <a:off x="731520" y="4206240"/>
+            <a:ext cx="5029200" cy="1234440"/>
           </a:xfrm>
           <a:prstGeom prst="roundRect">
             <a:avLst/>
@@ -4064,14 +4301,14 @@
       </p:sp>
       <p:sp>
         <p:nvSpPr>
-          <p:cNvPr id="9" name="TextBox 8"/>
+          <p:cNvPr id="12" name="TextBox 11"/>
           <p:cNvSpPr txBox="1"/>
           <p:nvPr/>
         </p:nvSpPr>
         <p:spPr>
           <a:xfrm>
-            <a:off x="1005840" y="2743200"/>
-            <a:ext cx="4572000" cy="1369695"/>
+            <a:off x="1005840" y="4251960"/>
+            <a:ext cx="4572000" cy="1143000"/>
           </a:xfrm>
           <a:prstGeom prst="rect">
             <a:avLst/>
@@ -4084,28 +4321,83 @@
           </a:bodyPr>
           <a:lstStyle/>
           <a:p>
-            <a:pPr lvl="0" algn="l">
-              <a:spcBef>
-                <a:spcPts val="0"/>
-              </a:spcBef>
-              <a:spcAft>
-                <a:spcPts val="800"/>
+            <a:pPr algn="l">
+              <a:spcBef>
+                <a:spcPts val="0"/>
+              </a:spcBef>
+              <a:spcAft>
+                <a:spcPts val="600"/>
               </a:spcAft>
               <a:defRPr sz="1300" b="1">
                 <a:solidFill>
-                  <a:srgbClr val="0047ab"/>
-                </a:solidFill>
-                <a:latin typeface="맑은 고딕"/>
-              </a:defRPr>
-            </a:pPr>
-            <a:r>
-              <a:rPr lang="ko-KR" altLang="en-US"/>
+                  <a:srgbClr val="0047AB"/>
+                </a:solidFill>
+                <a:latin typeface="맑은 고딕"/>
+              </a:defRPr>
+            </a:pPr>
+            <a:r>
               <a:t>🔧  소형 DC 모터 + 기어 + 링크 구조</a:t>
             </a:r>
-            <a:endParaRPr lang="ko-KR" altLang="en-US"/>
-          </a:p>
-          <a:p>
-            <a:pPr lvl="0" algn="l">
+          </a:p>
+          <a:p>
+            <a:pPr algn="l">
+              <a:spcBef>
+                <a:spcPts val="0"/>
+              </a:spcBef>
+              <a:spcAft>
+                <a:spcPts val="300"/>
+              </a:spcAft>
+              <a:defRPr sz="1100" b="0">
+                <a:solidFill>
+                  <a:srgbClr val="333344"/>
+                </a:solidFill>
+                <a:latin typeface="맑은 고딕"/>
+              </a:defRPr>
+            </a:pPr>
+            <a:r>
+              <a:t>• 응답 지연 (수십 ms 수준): 모터 구동 → 래치 체결까지의 물리적 시간</a:t>
+            </a:r>
+          </a:p>
+          <a:p>
+            <a:pPr algn="l">
+              <a:spcBef>
+                <a:spcPts val="0"/>
+              </a:spcBef>
+              <a:spcAft>
+                <a:spcPts val="300"/>
+              </a:spcAft>
+              <a:defRPr sz="1100" b="0">
+                <a:solidFill>
+                  <a:srgbClr val="333344"/>
+                </a:solidFill>
+                <a:latin typeface="맑은 고딕"/>
+              </a:defRPr>
+            </a:pPr>
+            <a:r>
+              <a:t>• 기어 백래시(Backlash): 기어 치합 유격으로 인한 위치 불확정 구간</a:t>
+            </a:r>
+          </a:p>
+          <a:p>
+            <a:pPr algn="l">
+              <a:spcBef>
+                <a:spcPts val="0"/>
+              </a:spcBef>
+              <a:spcAft>
+                <a:spcPts val="300"/>
+              </a:spcAft>
+              <a:defRPr sz="1100" b="0">
+                <a:solidFill>
+                  <a:srgbClr val="333344"/>
+                </a:solidFill>
+                <a:latin typeface="맑은 고딕"/>
+              </a:defRPr>
+            </a:pPr>
+            <a:r>
+              <a:t>• 정착 시간(Settling Time): 모터 정지 명령 후 잔류 응답이 사라지기까지의 시간</a:t>
+            </a:r>
+          </a:p>
+          <a:p>
+            <a:pPr algn="l">
               <a:spcBef>
                 <a:spcPts val="0"/>
               </a:spcBef>
@@ -4120,85 +4412,20 @@
               </a:defRPr>
             </a:pPr>
             <a:r>
-              <a:rPr lang="ko-KR" altLang="en-US"/>
-              <a:t>• 응답 지연 (수십 ms 수준): 모터 구동 → 래치 체결까지의 물리적 시간</a:t>
-            </a:r>
-            <a:endParaRPr lang="ko-KR" altLang="en-US"/>
-          </a:p>
-          <a:p>
-            <a:pPr lvl="0" algn="l">
-              <a:spcBef>
-                <a:spcPts val="0"/>
-              </a:spcBef>
-              <a:spcAft>
-                <a:spcPts val="400"/>
-              </a:spcAft>
-              <a:defRPr sz="1100" b="0">
-                <a:solidFill>
-                  <a:srgbClr val="333344"/>
-                </a:solidFill>
-                <a:latin typeface="맑은 고딕"/>
-              </a:defRPr>
-            </a:pPr>
-            <a:r>
-              <a:rPr lang="ko-KR" altLang="en-US"/>
-              <a:t>• 기어 백래시(Backlash): 기어 치합 유격으로 인한 위치 불확정 구간</a:t>
-            </a:r>
-            <a:endParaRPr lang="ko-KR" altLang="en-US"/>
-          </a:p>
-          <a:p>
-            <a:pPr lvl="0" algn="l">
-              <a:spcBef>
-                <a:spcPts val="0"/>
-              </a:spcBef>
-              <a:spcAft>
-                <a:spcPts val="400"/>
-              </a:spcAft>
-              <a:defRPr sz="1100" b="0">
-                <a:solidFill>
-                  <a:srgbClr val="333344"/>
-                </a:solidFill>
-                <a:latin typeface="맑은 고딕"/>
-              </a:defRPr>
-            </a:pPr>
-            <a:r>
-              <a:rPr lang="ko-KR" altLang="en-US"/>
-              <a:t>• 관성 지연(Inertia): 모터 정지 명령 후에도 관성에 의해 회전 지속</a:t>
-            </a:r>
-            <a:endParaRPr lang="ko-KR" altLang="en-US"/>
-          </a:p>
-          <a:p>
-            <a:pPr lvl="0" algn="l">
-              <a:spcBef>
-                <a:spcPts val="0"/>
-              </a:spcBef>
-              <a:spcAft>
-                <a:spcPts val="400"/>
-              </a:spcAft>
-              <a:defRPr sz="1100" b="0">
-                <a:solidFill>
-                  <a:srgbClr val="333344"/>
-                </a:solidFill>
-                <a:latin typeface="맑은 고딕"/>
-              </a:defRPr>
-            </a:pPr>
-            <a:r>
-              <a:rPr lang="ko-KR" altLang="en-US"/>
-              <a:t>• 온도 드리프트: 극저온/고온 환경에서 센서 출력값 변동</a:t>
-            </a:r>
-            <a:endParaRPr lang="ko-KR" altLang="en-US"/>
-          </a:p>
-        </p:txBody>
-      </p:sp>
-      <p:sp>
-        <p:nvSpPr>
-          <p:cNvPr id="10" name="Rounded Rectangle 9"/>
+              <a:t>• 반복 구동 내구: 잦은 ON/OFF는 모터 발열·전류 피크 누적·기어 피로를 유발</a:t>
+            </a:r>
+          </a:p>
+        </p:txBody>
+      </p:sp>
+      <p:sp>
+        <p:nvSpPr>
+          <p:cNvPr id="13" name="Rounded Rectangle 12"/>
           <p:cNvSpPr/>
           <p:nvPr/>
         </p:nvSpPr>
         <p:spPr>
           <a:xfrm>
-            <a:off x="731520" y="4480560"/>
+            <a:off x="731520" y="5577840"/>
             <a:ext cx="5029200" cy="502920"/>
           </a:xfrm>
           <a:prstGeom prst="roundRect">
@@ -4236,13 +4463,13 @@
       </p:sp>
       <p:sp>
         <p:nvSpPr>
-          <p:cNvPr id="11" name="TextBox 10"/>
+          <p:cNvPr id="14" name="TextBox 13"/>
           <p:cNvSpPr txBox="1"/>
           <p:nvPr/>
         </p:nvSpPr>
         <p:spPr>
           <a:xfrm>
-            <a:off x="1005840" y="4526280"/>
+            <a:off x="1005840" y="5623560"/>
             <a:ext cx="4572000" cy="365760"/>
           </a:xfrm>
           <a:prstGeom prst="rect">
@@ -4278,7 +4505,7 @@
       </p:sp>
       <p:sp>
         <p:nvSpPr>
-          <p:cNvPr id="12" name="TextBox 11"/>
+          <p:cNvPr id="15" name="TextBox 14"/>
           <p:cNvSpPr txBox="1"/>
           <p:nvPr/>
         </p:nvSpPr>
@@ -4313,21 +4540,126 @@
               </a:defRPr>
             </a:pPr>
             <a:r>
-              <a:t>▎ 정의한 핵심 문제 → 해결 모듈 매핑</a:t>
-            </a:r>
-          </a:p>
-        </p:txBody>
-      </p:sp>
-      <p:sp>
-        <p:nvSpPr>
-          <p:cNvPr id="13" name="Rounded Rectangle 12"/>
+              <a:t>▎ 핵심 문제 정의 → 해결 모듈 매핑</a:t>
+            </a:r>
+          </a:p>
+        </p:txBody>
+      </p:sp>
+      <p:sp>
+        <p:nvSpPr>
+          <p:cNvPr id="16" name="Rounded Rectangle 15"/>
           <p:cNvSpPr/>
           <p:nvPr/>
         </p:nvSpPr>
         <p:spPr>
           <a:xfrm>
-            <a:off x="6400800" y="2651760"/>
-            <a:ext cx="5029200" cy="1234440"/>
+            <a:off x="6400800" y="2560320"/>
+            <a:ext cx="5029200" cy="548640"/>
+          </a:xfrm>
+          <a:prstGeom prst="roundRect">
+            <a:avLst/>
+          </a:prstGeom>
+          <a:solidFill>
+            <a:srgbClr val="002B5C"/>
+          </a:solidFill>
+          <a:ln>
+            <a:noFill/>
+          </a:ln>
+          <a:effectLst/>
+        </p:spPr>
+        <p:style>
+          <a:lnRef idx="1">
+            <a:schemeClr val="accent1"/>
+          </a:lnRef>
+          <a:fillRef idx="3">
+            <a:schemeClr val="accent1"/>
+          </a:fillRef>
+          <a:effectRef idx="2">
+            <a:schemeClr val="accent1"/>
+          </a:effectRef>
+          <a:fontRef idx="minor">
+            <a:schemeClr val="lt1"/>
+          </a:fontRef>
+        </p:style>
+        <p:txBody>
+          <a:bodyPr rtlCol="0" anchor="ctr"/>
+          <a:lstStyle/>
+          <a:p>
+            <a:pPr algn="ctr"/>
+          </a:p>
+        </p:txBody>
+      </p:sp>
+      <p:sp>
+        <p:nvSpPr>
+          <p:cNvPr id="17" name="TextBox 16"/>
+          <p:cNvSpPr txBox="1"/>
+          <p:nvPr/>
+        </p:nvSpPr>
+        <p:spPr>
+          <a:xfrm>
+            <a:off x="6583680" y="2587752"/>
+            <a:ext cx="4663440" cy="502920"/>
+          </a:xfrm>
+          <a:prstGeom prst="rect">
+            <a:avLst/>
+          </a:prstGeom>
+          <a:noFill/>
+        </p:spPr>
+        <p:txBody>
+          <a:bodyPr wrap="square">
+            <a:spAutoFit/>
+          </a:bodyPr>
+          <a:lstStyle/>
+          <a:p>
+            <a:pPr algn="l">
+              <a:spcBef>
+                <a:spcPts val="0"/>
+              </a:spcBef>
+              <a:spcAft>
+                <a:spcPts val="100"/>
+              </a:spcAft>
+              <a:defRPr sz="1100" b="1">
+                <a:solidFill>
+                  <a:srgbClr val="FFFFFF"/>
+                </a:solidFill>
+                <a:latin typeface="맑은 고딕"/>
+              </a:defRPr>
+            </a:pPr>
+            <a:r>
+              <a:t>⚡ 핵심 문제: 센서의 불확실한 입력을 액추에이터에 그대로 전달하면,</a:t>
+            </a:r>
+          </a:p>
+          <a:p>
+            <a:pPr algn="l">
+              <a:spcBef>
+                <a:spcPts val="0"/>
+              </a:spcBef>
+              <a:spcAft>
+                <a:spcPts val="400"/>
+              </a:spcAft>
+              <a:defRPr sz="1100" b="1">
+                <a:solidFill>
+                  <a:srgbClr val="CCE5FF"/>
+                </a:solidFill>
+                <a:latin typeface="맑은 고딕"/>
+              </a:defRPr>
+            </a:pPr>
+            <a:r>
+              <a:t>   안전성과 내구성을 동시에 해칠 수 있다.</a:t>
+            </a:r>
+          </a:p>
+        </p:txBody>
+      </p:sp>
+      <p:sp>
+        <p:nvSpPr>
+          <p:cNvPr id="18" name="Rounded Rectangle 17"/>
+          <p:cNvSpPr/>
+          <p:nvPr/>
+        </p:nvSpPr>
+        <p:spPr>
+          <a:xfrm>
+            <a:off x="6400800" y="3246120"/>
+            <a:ext cx="5029200" cy="1097280"/>
           </a:xfrm>
           <a:prstGeom prst="roundRect">
             <a:avLst/>
@@ -4364,13 +4696,13 @@
       </p:sp>
       <p:sp>
         <p:nvSpPr>
-          <p:cNvPr id="14" name="Rounded Rectangle 13"/>
+          <p:cNvPr id="19" name="Rounded Rectangle 18"/>
           <p:cNvSpPr/>
           <p:nvPr/>
         </p:nvSpPr>
         <p:spPr>
           <a:xfrm>
-            <a:off x="10332720" y="2697480"/>
+            <a:off x="10332720" y="3291840"/>
             <a:ext cx="822960" cy="274320"/>
           </a:xfrm>
           <a:prstGeom prst="roundRect">
@@ -4418,14 +4750,14 @@
       </p:sp>
       <p:sp>
         <p:nvSpPr>
-          <p:cNvPr id="15" name="TextBox 14"/>
+          <p:cNvPr id="20" name="TextBox 19"/>
           <p:cNvSpPr txBox="1"/>
           <p:nvPr/>
         </p:nvSpPr>
         <p:spPr>
           <a:xfrm>
-            <a:off x="6675120" y="2697480"/>
-            <a:ext cx="3657600" cy="843915"/>
+            <a:off x="6675120" y="3291840"/>
+            <a:ext cx="3657600" cy="1005840"/>
           </a:xfrm>
           <a:prstGeom prst="rect">
             <a:avLst/>
@@ -4438,7 +4770,7 @@
           </a:bodyPr>
           <a:lstStyle/>
           <a:p>
-            <a:pPr lvl="0" algn="l">
+            <a:pPr algn="l">
               <a:spcBef>
                 <a:spcPts val="0"/>
               </a:spcBef>
@@ -4447,19 +4779,17 @@
               </a:spcAft>
               <a:defRPr sz="1300" b="1">
                 <a:solidFill>
-                  <a:srgbClr val="ff6b35"/>
-                </a:solidFill>
-                <a:latin typeface="맑은 고딕"/>
-              </a:defRPr>
-            </a:pPr>
-            <a:r>
-              <a:rPr lang="ko-KR" altLang="en-US"/>
-              <a:t>①  경계값 떨림 → 모터 내구 리스크 위험</a:t>
-            </a:r>
-            <a:endParaRPr lang="ko-KR" altLang="en-US"/>
-          </a:p>
-          <a:p>
-            <a:pPr lvl="0" algn="l">
+                  <a:srgbClr val="FF6B35"/>
+                </a:solidFill>
+                <a:latin typeface="맑은 고딕"/>
+              </a:defRPr>
+            </a:pPr>
+            <a:r>
+              <a:t>증상 ①  경계값 떨림 → 모터 내구 리스크</a:t>
+            </a:r>
+          </a:p>
+          <a:p>
+            <a:pPr algn="l">
               <a:spcBef>
                 <a:spcPts val="0"/>
               </a:spcBef>
@@ -4474,20 +4804,11 @@
               </a:defRPr>
             </a:pPr>
             <a:r>
-              <a:rPr lang="ko-KR" altLang="en-US"/>
-              <a:t>센서 노이즈 → 초당 수십 번 ON/OFF 명령</a:t>
-            </a:r>
-            <a:br>
-              <a:rPr lang="ko-KR" altLang="en-US"/>
-            </a:br>
-            <a:r>
-              <a:rPr lang="ko-KR" altLang="en-US"/>
-              <a:t>→ 모터 소손(Burn-out) + 기어 마모</a:t>
-            </a:r>
-            <a:endParaRPr lang="ko-KR" altLang="en-US"/>
-          </a:p>
-          <a:p>
-            <a:pPr lvl="0" algn="l">
+              <a:t>반복 명령 토글은 모터 발열과 기계 피로를 유발할 수 있음</a:t>
+            </a:r>
+          </a:p>
+          <a:p>
+            <a:pPr algn="l">
               <a:spcBef>
                 <a:spcPts val="0"/>
               </a:spcBef>
@@ -4496,29 +4817,27 @@
               </a:spcAft>
               <a:defRPr sz="1000" b="1">
                 <a:solidFill>
-                  <a:srgbClr val="ff6b35"/>
-                </a:solidFill>
-                <a:latin typeface="맑은 고딕"/>
-              </a:defRPr>
-            </a:pPr>
-            <a:r>
-              <a:rPr lang="ko-KR" altLang="en-US"/>
+                  <a:srgbClr val="FF6B35"/>
+                </a:solidFill>
+                <a:latin typeface="맑은 고딕"/>
+              </a:defRPr>
+            </a:pPr>
+            <a:r>
               <a:t>→ 해결: 시간 기반 히스테리시스 밴드 (500ms/1000ms)</a:t>
             </a:r>
-            <a:endParaRPr lang="ko-KR" altLang="en-US"/>
-          </a:p>
-        </p:txBody>
-      </p:sp>
-      <p:sp>
-        <p:nvSpPr>
-          <p:cNvPr id="16" name="Rounded Rectangle 15"/>
+          </a:p>
+        </p:txBody>
+      </p:sp>
+      <p:sp>
+        <p:nvSpPr>
+          <p:cNvPr id="21" name="Rounded Rectangle 20"/>
           <p:cNvSpPr/>
           <p:nvPr/>
         </p:nvSpPr>
         <p:spPr>
           <a:xfrm>
-            <a:off x="6400800" y="4023360"/>
-            <a:ext cx="5029200" cy="1234440"/>
+            <a:off x="6400800" y="4480560"/>
+            <a:ext cx="5029200" cy="1097280"/>
           </a:xfrm>
           <a:prstGeom prst="roundRect">
             <a:avLst/>
@@ -4555,13 +4874,13 @@
       </p:sp>
       <p:sp>
         <p:nvSpPr>
-          <p:cNvPr id="17" name="Rounded Rectangle 16"/>
+          <p:cNvPr id="22" name="Rounded Rectangle 21"/>
           <p:cNvSpPr/>
           <p:nvPr/>
         </p:nvSpPr>
         <p:spPr>
           <a:xfrm>
-            <a:off x="10332720" y="4069080"/>
+            <a:off x="10332720" y="4526280"/>
             <a:ext cx="822960" cy="274320"/>
           </a:xfrm>
           <a:prstGeom prst="roundRect">
@@ -4609,14 +4928,14 @@
       </p:sp>
       <p:sp>
         <p:nvSpPr>
-          <p:cNvPr id="18" name="TextBox 17"/>
+          <p:cNvPr id="23" name="TextBox 22"/>
           <p:cNvSpPr txBox="1"/>
           <p:nvPr/>
         </p:nvSpPr>
         <p:spPr>
           <a:xfrm>
-            <a:off x="6675120" y="4069080"/>
-            <a:ext cx="3657600" cy="1097280"/>
+            <a:off x="6675120" y="4526280"/>
+            <a:ext cx="3657600" cy="1005840"/>
           </a:xfrm>
           <a:prstGeom prst="rect">
             <a:avLst/>
@@ -4644,7 +4963,7 @@
               </a:defRPr>
             </a:pPr>
             <a:r>
-              <a:t>②  센서 고장 시 방치 (No Fail-Safe)</a:t>
+              <a:t>증상 ②  센서 고장 시 안전 상태 미정의</a:t>
             </a:r>
           </a:p>
           <a:p>
@@ -4663,11 +4982,7 @@
               </a:defRPr>
             </a:pPr>
             <a:r>
-              <a:t>고장 인지 불가 → 차일드 락 풀림 방치</a:t>
-            </a:r>
-            <a:br/>
-            <a:r>
-              <a:t>→ 아이가 문 열고 도로 추락 위험</a:t>
+              <a:t>고장 인지 불가 → 차일드 락 풀림 방치 → 치명적 사고 위험</a:t>
             </a:r>
           </a:p>
           <a:p>
@@ -4693,20 +5008,20 @@
       </p:sp>
       <p:sp>
         <p:nvSpPr>
-          <p:cNvPr id="19" name="Rounded Rectangle 18"/>
+          <p:cNvPr id="24" name="Rounded Rectangle 23"/>
           <p:cNvSpPr/>
           <p:nvPr/>
         </p:nvSpPr>
         <p:spPr>
           <a:xfrm>
-            <a:off x="6400800" y="5394960"/>
-            <a:ext cx="5029200" cy="960120"/>
+            <a:off x="6400800" y="5715000"/>
+            <a:ext cx="5029200" cy="502920"/>
           </a:xfrm>
           <a:prstGeom prst="roundRect">
             <a:avLst/>
           </a:prstGeom>
           <a:solidFill>
-            <a:srgbClr val="E8F2FF"/>
+            <a:srgbClr val="E8F5E9"/>
           </a:solidFill>
           <a:ln>
             <a:noFill/>
@@ -4737,68 +5052,14 @@
       </p:sp>
       <p:sp>
         <p:nvSpPr>
-          <p:cNvPr id="20" name="Rounded Rectangle 19"/>
-          <p:cNvSpPr/>
-          <p:nvPr/>
-        </p:nvSpPr>
-        <p:spPr>
-          <a:xfrm>
-            <a:off x="9875520" y="5440680"/>
-            <a:ext cx="1280160" cy="274320"/>
-          </a:xfrm>
-          <a:prstGeom prst="roundRect">
-            <a:avLst/>
-          </a:prstGeom>
-          <a:solidFill>
-            <a:srgbClr val="006ED6"/>
-          </a:solidFill>
-          <a:ln>
-            <a:noFill/>
-          </a:ln>
-          <a:effectLst/>
-        </p:spPr>
-        <p:style>
-          <a:lnRef idx="1">
-            <a:schemeClr val="accent1"/>
-          </a:lnRef>
-          <a:fillRef idx="3">
-            <a:schemeClr val="accent1"/>
-          </a:fillRef>
-          <a:effectRef idx="2">
-            <a:schemeClr val="accent1"/>
-          </a:effectRef>
-          <a:fontRef idx="minor">
-            <a:schemeClr val="lt1"/>
-          </a:fontRef>
-        </p:style>
-        <p:txBody>
-          <a:bodyPr rtlCol="0" anchor="ctr" wrap="none"/>
-          <a:lstStyle/>
-          <a:p>
-            <a:pPr algn="ctr">
-              <a:defRPr sz="900" b="1">
-                <a:solidFill>
-                  <a:srgbClr val="FFFFFF"/>
-                </a:solidFill>
-                <a:latin typeface="맑은 고딕"/>
-              </a:defRPr>
-            </a:pPr>
-            <a:r>
-              <a:t>→ F-07 &amp; F-08</a:t>
-            </a:r>
-          </a:p>
-        </p:txBody>
-      </p:sp>
-      <p:sp>
-        <p:nvSpPr>
-          <p:cNvPr id="21" name="TextBox 20"/>
+          <p:cNvPr id="25" name="TextBox 24"/>
           <p:cNvSpPr txBox="1"/>
           <p:nvPr/>
         </p:nvSpPr>
         <p:spPr>
           <a:xfrm>
-            <a:off x="6675120" y="5440680"/>
-            <a:ext cx="3017520" cy="843915"/>
+            <a:off x="6675120" y="5742432"/>
+            <a:ext cx="4572000" cy="457200"/>
           </a:xfrm>
           <a:prstGeom prst="rect">
             <a:avLst/>
@@ -4811,73 +5072,29 @@
           </a:bodyPr>
           <a:lstStyle/>
           <a:p>
-            <a:pPr lvl="0" algn="l">
+            <a:pPr algn="l">
               <a:spcBef>
                 <a:spcPts val="0"/>
               </a:spcBef>
               <a:spcAft>
                 <a:spcPts val="400"/>
               </a:spcAft>
-              <a:defRPr sz="1300" b="1">
-                <a:solidFill>
-                  <a:srgbClr val="0047ab"/>
-                </a:solidFill>
-                <a:latin typeface="맑은 고딕"/>
-              </a:defRPr>
-            </a:pPr>
-            <a:r>
-              <a:rPr lang="ko-KR" altLang="en-US"/>
-              <a:t>③  HW-SW 융합 관점 부재</a:t>
-            </a:r>
-            <a:endParaRPr lang="ko-KR" altLang="en-US"/>
-          </a:p>
-          <a:p>
-            <a:pPr lvl="0" algn="l">
-              <a:spcBef>
-                <a:spcPts val="0"/>
-              </a:spcBef>
-              <a:spcAft>
-                <a:spcPts val="400"/>
-              </a:spcAft>
-              <a:defRPr sz="1000" b="0">
-                <a:solidFill>
-                  <a:srgbClr val="333344"/>
-                </a:solidFill>
-                <a:latin typeface="맑은 고딕"/>
-              </a:defRPr>
-            </a:pPr>
-            <a:r>
-              <a:rPr lang="ko-KR" altLang="en-US"/>
-              <a:t>모터 응답 수십 ms 수준을 무시한 SW → 기계적 피로 누적</a:t>
-            </a:r>
-            <a:endParaRPr lang="ko-KR" altLang="en-US"/>
-          </a:p>
-          <a:p>
-            <a:pPr lvl="0" algn="l">
-              <a:spcBef>
-                <a:spcPts val="0"/>
-              </a:spcBef>
-              <a:spcAft>
-                <a:spcPts val="400"/>
-              </a:spcAft>
-              <a:defRPr sz="1000" b="1">
-                <a:solidFill>
-                  <a:srgbClr val="0047ab"/>
-                </a:solidFill>
-                <a:latin typeface="맑은 고딕"/>
-              </a:defRPr>
-            </a:pPr>
-            <a:r>
-              <a:rPr lang="ko-KR" altLang="en-US"/>
-              <a:t>→ 해결: 기계공학 기반 안전 마진 타이머 설계</a:t>
-            </a:r>
-            <a:endParaRPr lang="ko-KR" altLang="en-US"/>
-          </a:p>
-        </p:txBody>
-      </p:sp>
-      <p:sp>
-        <p:nvSpPr>
-          <p:cNvPr id="22" name="TextBox 21"/>
+              <a:defRPr sz="1100" b="1">
+                <a:solidFill>
+                  <a:srgbClr val="2E7D32"/>
+                </a:solidFill>
+                <a:latin typeface="맑은 고딕"/>
+              </a:defRPr>
+            </a:pPr>
+            <a:r>
+              <a:t>💡 인사이트: HW 물리 특성과 SW 상태 로직을 함께 설계해야 한다</a:t>
+            </a:r>
+          </a:p>
+        </p:txBody>
+      </p:sp>
+      <p:sp>
+        <p:nvSpPr>
+          <p:cNvPr id="26" name="TextBox 25"/>
           <p:cNvSpPr txBox="1"/>
           <p:nvPr/>
         </p:nvSpPr>
@@ -4920,7 +5137,7 @@
 </file>
 
 <file path=ppt/slides/slide3.xml><?xml version="1.0" encoding="utf-8"?>
-<p:sld xmlns:r="http://schemas.openxmlformats.org/officeDocument/2006/relationships" xmlns:c="http://schemas.openxmlformats.org/drawingml/2006/chart" xmlns:a="http://schemas.openxmlformats.org/drawingml/2006/main" xmlns:dgm="http://schemas.openxmlformats.org/drawingml/2006/diagram" xmlns:dsp="http://schemas.microsoft.com/office/drawing/2008/diagram" xmlns:p="http://schemas.openxmlformats.org/presentationml/2006/main">
+<p:sld xmlns:a="http://schemas.openxmlformats.org/drawingml/2006/main" xmlns:p="http://schemas.openxmlformats.org/presentationml/2006/main" xmlns:r="http://schemas.openxmlformats.org/officeDocument/2006/relationships">
   <p:cSld>
     <p:spTree>
       <p:nvGrpSpPr>
@@ -4928,14 +5145,7 @@
         <p:cNvGrpSpPr/>
         <p:nvPr/>
       </p:nvGrpSpPr>
-      <p:grpSpPr>
-        <a:xfrm>
-          <a:off x="0" y="0"/>
-          <a:ext cx="0" cy="0"/>
-          <a:chOff x="0" y="0"/>
-          <a:chExt cx="0" cy="0"/>
-        </a:xfrm>
-      </p:grpSpPr>
+      <p:grpSpPr/>
       <p:sp>
         <p:nvSpPr>
           <p:cNvPr id="2" name="Rectangle 1"/>
@@ -5422,7 +5632,7 @@
         <p:spPr>
           <a:xfrm>
             <a:off x="6675120" y="4617720"/>
-            <a:ext cx="4572000" cy="1819275"/>
+            <a:ext cx="4572000" cy="1737360"/>
           </a:xfrm>
           <a:prstGeom prst="rect">
             <a:avLst/>
@@ -5435,7 +5645,7 @@
           </a:bodyPr>
           <a:lstStyle/>
           <a:p>
-            <a:pPr lvl="0" algn="l">
+            <a:pPr algn="l">
               <a:spcBef>
                 <a:spcPts val="0"/>
               </a:spcBef>
@@ -5444,19 +5654,17 @@
               </a:spcAft>
               <a:defRPr sz="1300" b="1">
                 <a:solidFill>
-                  <a:srgbClr val="0047ab"/>
-                </a:solidFill>
-                <a:latin typeface="맑은 고딕"/>
-              </a:defRPr>
-            </a:pPr>
-            <a:r>
-              <a:rPr lang="ko-KR" altLang="en-US"/>
+                  <a:srgbClr val="0047AB"/>
+                </a:solidFill>
+                <a:latin typeface="맑은 고딕"/>
+              </a:defRPr>
+            </a:pPr>
+            <a:r>
               <a:t>🔧  HW 보호 관점의 시간 기반 히스테리시스 설계</a:t>
             </a:r>
-            <a:endParaRPr lang="ko-KR" altLang="en-US"/>
-          </a:p>
-          <a:p>
-            <a:pPr lvl="0" algn="l">
+          </a:p>
+          <a:p>
+            <a:pPr algn="l">
               <a:spcBef>
                 <a:spcPts val="0"/>
               </a:spcBef>
@@ -5465,19 +5673,17 @@
               </a:spcAft>
               <a:defRPr sz="1100" b="1">
                 <a:solidFill>
-                  <a:srgbClr val="002b5c"/>
-                </a:solidFill>
-                <a:latin typeface="맑은 고딕"/>
-              </a:defRPr>
-            </a:pPr>
-            <a:r>
-              <a:rPr lang="ko-KR" altLang="en-US"/>
-              <a:t>확정 타이머 (500ms) — 모터 응답 수십 ms 수준의 10배 마진 확보</a:t>
-            </a:r>
-            <a:endParaRPr lang="ko-KR" altLang="en-US"/>
-          </a:p>
-          <a:p>
-            <a:pPr lvl="0" algn="l">
+                  <a:srgbClr val="002B5C"/>
+                </a:solidFill>
+                <a:latin typeface="맑은 고딕"/>
+              </a:defRPr>
+            </a:pPr>
+            <a:r>
+              <a:t>확정 타이머 (500ms) — 3가지 설계 근거</a:t>
+            </a:r>
+          </a:p>
+          <a:p>
+            <a:pPr algn="l">
               <a:spcBef>
                 <a:spcPts val="0"/>
               </a:spcBef>
@@ -5492,13 +5698,30 @@
               </a:defRPr>
             </a:pPr>
             <a:r>
-              <a:rPr lang="ko-KR" altLang="en-US"/>
-              <a:t>센서 값이 튀더라도 모터가 물리적으로 반응할 수 있는</a:t>
-            </a:r>
-            <a:endParaRPr lang="ko-KR" altLang="en-US"/>
-          </a:p>
-          <a:p>
-            <a:pPr lvl="0" algn="l">
+              <a:t>① 센서 노이즈 억제: 짧은 스파이크성 오판 제거</a:t>
+            </a:r>
+          </a:p>
+          <a:p>
+            <a:pPr algn="l">
+              <a:spcBef>
+                <a:spcPts val="0"/>
+              </a:spcBef>
+              <a:spcAft>
+                <a:spcPts val="100"/>
+              </a:spcAft>
+              <a:defRPr sz="1000" b="0">
+                <a:solidFill>
+                  <a:srgbClr val="333344"/>
+                </a:solidFill>
+                <a:latin typeface="맑은 고딕"/>
+              </a:defRPr>
+            </a:pPr>
+            <a:r>
+              <a:t>② 액추에이터 보호: 불필요한 반복 구동 명령 방지</a:t>
+            </a:r>
+          </a:p>
+          <a:p>
+            <a:pPr algn="l">
               <a:spcBef>
                 <a:spcPts val="0"/>
               </a:spcBef>
@@ -5513,13 +5736,11 @@
               </a:defRPr>
             </a:pPr>
             <a:r>
-              <a:rPr lang="ko-KR" altLang="en-US"/>
-              <a:t>충분한 안정화 시간을 SW가 확보 → 기계적 피로도 극적 감소</a:t>
-            </a:r>
-            <a:endParaRPr lang="ko-KR" altLang="en-US"/>
-          </a:p>
-          <a:p>
-            <a:pPr lvl="0" algn="l">
+              <a:t>③ 안전 반응 여유: 위험 판단→잠금 완료까지 최소 시간 확보</a:t>
+            </a:r>
+          </a:p>
+          <a:p>
+            <a:pPr algn="l">
               <a:spcBef>
                 <a:spcPts val="0"/>
               </a:spcBef>
@@ -5528,19 +5749,17 @@
               </a:spcAft>
               <a:defRPr sz="1100" b="1">
                 <a:solidFill>
-                  <a:srgbClr val="002b5c"/>
-                </a:solidFill>
-                <a:latin typeface="맑은 고딕"/>
-              </a:defRPr>
-            </a:pPr>
-            <a:r>
-              <a:rPr lang="ko-KR" altLang="en-US"/>
+                  <a:srgbClr val="002B5C"/>
+                </a:solidFill>
+                <a:latin typeface="맑은 고딕"/>
+              </a:defRPr>
+            </a:pPr>
+            <a:r>
               <a:t>해제 타이머 (1000ms) — 확정 대비 2배 비대칭 설계</a:t>
             </a:r>
-            <a:endParaRPr lang="ko-KR" altLang="en-US"/>
-          </a:p>
-          <a:p>
-            <a:pPr lvl="0" algn="l">
+          </a:p>
+          <a:p>
+            <a:pPr algn="l">
               <a:spcBef>
                 <a:spcPts val="0"/>
               </a:spcBef>
@@ -5555,13 +5774,11 @@
               </a:defRPr>
             </a:pPr>
             <a:r>
-              <a:rPr lang="ko-KR" altLang="en-US"/>
               <a:t>안전 해제는 더 보수적으로: 1초 이상 안전 지속 확인 후 해제</a:t>
             </a:r>
-            <a:endParaRPr lang="ko-KR" altLang="en-US"/>
-          </a:p>
-          <a:p>
-            <a:pPr lvl="0" algn="l">
+          </a:p>
+          <a:p>
+            <a:pPr algn="l">
               <a:spcBef>
                 <a:spcPts val="0"/>
               </a:spcBef>
@@ -5570,19 +5787,17 @@
               </a:spcAft>
               <a:defRPr sz="1000" b="1">
                 <a:solidFill>
-                  <a:srgbClr val="0047ab"/>
-                </a:solidFill>
-                <a:latin typeface="맑은 고딕"/>
-              </a:defRPr>
-            </a:pPr>
-            <a:r>
-              <a:rPr lang="ko-KR" altLang="en-US"/>
-              <a:t>→ 모터 반복 구동 방지 + 기어 마모/소손 위험 원천 차단</a:t>
-            </a:r>
-            <a:endParaRPr lang="ko-KR" altLang="en-US"/>
-          </a:p>
-          <a:p>
-            <a:pPr lvl="0" algn="l">
+                  <a:srgbClr val="0047AB"/>
+                </a:solidFill>
+                <a:latin typeface="맑은 고딕"/>
+              </a:defRPr>
+            </a:pPr>
+            <a:r>
+              <a:t>→ 모터 반복 구동 방지 + 기어 마모 위험을 크게 저감</a:t>
+            </a:r>
+          </a:p>
+          <a:p>
+            <a:pPr algn="l">
               <a:spcBef>
                 <a:spcPts val="0"/>
               </a:spcBef>
@@ -5597,21 +5812,11 @@
               </a:defRPr>
             </a:pPr>
             <a:r>
-              <a:rPr lang="ko-KR" altLang="en-US">
-                <a:solidFill>
-                  <a:schemeClr val="dk1"/>
-                </a:solidFill>
-              </a:rPr>
-              <a:t>💡 참고: 자동차 BLDC 모터 제어에서 히스테리시스 비교기가</a:t>
-            </a:r>
-            <a:endParaRPr lang="ko-KR" altLang="en-US">
-              <a:solidFill>
-                <a:schemeClr val="dk1"/>
-              </a:solidFill>
-            </a:endParaRPr>
-          </a:p>
-          <a:p>
-            <a:pPr lvl="0" algn="l">
+              <a:t>💡 BLDC 히스테리시스 비교기와 원리는 유사하나,</a:t>
+            </a:r>
+          </a:p>
+          <a:p>
+            <a:pPr algn="l">
               <a:spcBef>
                 <a:spcPts val="0"/>
               </a:spcBef>
@@ -5626,18 +5831,8 @@
               </a:defRPr>
             </a:pPr>
             <a:r>
-              <a:rPr lang="ko-KR" altLang="en-US">
-                <a:solidFill>
-                  <a:schemeClr val="dk1"/>
-                </a:solidFill>
-              </a:rPr>
-              <a:t>   노이즈/리플에 의한 다중 출력 전환 방지에 사용됨 (동일 원리)</a:t>
-            </a:r>
-            <a:endParaRPr lang="ko-KR" altLang="en-US">
-              <a:solidFill>
-                <a:schemeClr val="dk1"/>
-              </a:solidFill>
-            </a:endParaRPr>
+              <a:t>   본 설계는 애플리케이션 SW 레벨에서 시간을 이용해 구현</a:t>
+            </a:r>
           </a:p>
         </p:txBody>
       </p:sp>
@@ -5928,7 +6123,7 @@
               </a:defRPr>
             </a:pPr>
             <a:r>
-              <a:t>ASIL-B 등급의 Fail-Safe 시스템을 구축해</a:t>
+              <a:t>ASIL-B 수준의 안전 목표를 가정한 Fail-Safe를 설계해</a:t>
             </a:r>
           </a:p>
           <a:p>
@@ -5947,7 +6142,7 @@
               </a:defRPr>
             </a:pPr>
             <a:r>
-              <a:t>무결점 안전을 확보하다.</a:t>
+              <a:t>안전측 중심의 Fail-Safe를 구현하다.</a:t>
             </a:r>
           </a:p>
         </p:txBody>
@@ -6099,7 +6294,7 @@
               </a:defRPr>
             </a:pPr>
             <a:r>
-              <a:t>▎ SAFE_LOCKED 정책 — 물리적으로 가장 안전한 상태</a:t>
+              <a:t>▎ SAFE_LOCKED 정책 — 본 기능의 Safe State</a:t>
             </a:r>
           </a:p>
         </p:txBody>
@@ -6232,17 +6427,36 @@
                 <a:spcPts val="0"/>
               </a:spcBef>
               <a:spcAft>
+                <a:spcPts val="200"/>
+              </a:spcAft>
+              <a:defRPr sz="1200" b="1">
+                <a:solidFill>
+                  <a:srgbClr val="002B5C"/>
+                </a:solidFill>
+                <a:latin typeface="맑은 고딕"/>
+              </a:defRPr>
+            </a:pPr>
+            <a:r>
+              <a:t>→ 본 기능 관점의 safe state는 잠금 유지</a:t>
+            </a:r>
+          </a:p>
+          <a:p>
+            <a:pPr algn="l">
+              <a:spcBef>
+                <a:spcPts val="0"/>
+              </a:spcBef>
+              <a:spcAft>
                 <a:spcPts val="400"/>
               </a:spcAft>
-              <a:defRPr sz="1200" b="1">
-                <a:solidFill>
-                  <a:srgbClr val="002B5C"/>
-                </a:solidFill>
-                <a:latin typeface="맑은 고딕"/>
-              </a:defRPr>
-            </a:pPr>
-            <a:r>
-              <a:t>→ 따라서 고장 시 "무조건 잠금 유지"가 기계적으로 가장 안전</a:t>
+              <a:defRPr sz="1000" b="0">
+                <a:solidFill>
+                  <a:srgbClr val="666677"/>
+                </a:solidFill>
+                <a:latin typeface="맑은 고딕"/>
+              </a:defRPr>
+            </a:pPr>
+            <a:r>
+              <a:t>   (crash unlock 등 상위 안전 로직은 별도 고려)</a:t>
             </a:r>
           </a:p>
         </p:txBody>
@@ -6256,7 +6470,7 @@
         <p:spPr>
           <a:xfrm>
             <a:off x="6400800" y="4206240"/>
-            <a:ext cx="5029200" cy="1463040"/>
+            <a:ext cx="5029200" cy="1645920"/>
           </a:xfrm>
           <a:prstGeom prst="roundRect">
             <a:avLst/>
@@ -6300,7 +6514,7 @@
         <p:spPr>
           <a:xfrm>
             <a:off x="6675120" y="4297680"/>
-            <a:ext cx="4572000" cy="1280160"/>
+            <a:ext cx="4572000" cy="1463040"/>
           </a:xfrm>
           <a:prstGeom prst="rect">
             <a:avLst/>
@@ -6366,7 +6580,7 @@
               </a:defRPr>
             </a:pPr>
             <a:r>
-              <a:t>② 모터를 "잠금 위치"로 구동 → 래치 체결 확보</a:t>
+              <a:t>② 잠금 방향 1회 구동 후 상태 래치 (무한 구동 방지)</a:t>
             </a:r>
           </a:p>
           <a:p>
@@ -6385,7 +6599,7 @@
               </a:defRPr>
             </a:pPr>
             <a:r>
-              <a:t>③ HMI 경고음 + 메시지로 운전자 즉시 인지</a:t>
+              <a:t>③ 위치/전류/타임아웃으로 구동 완료 여부 확인</a:t>
             </a:r>
           </a:p>
           <a:p>
@@ -6404,7 +6618,7 @@
               </a:defRPr>
             </a:pPr>
             <a:r>
-              <a:t>④ 이벤트 로그/DTC 저장 → 사후 분석 대비</a:t>
+              <a:t>④ HMI 경고음 + 메시지로 운전자 즉시 인지</a:t>
             </a:r>
           </a:p>
           <a:p>
@@ -6415,6 +6629,25 @@
               <a:spcAft>
                 <a:spcPts val="400"/>
               </a:spcAft>
+              <a:defRPr sz="1100" b="0">
+                <a:solidFill>
+                  <a:srgbClr val="333344"/>
+                </a:solidFill>
+                <a:latin typeface="맑은 고딕"/>
+              </a:defRPr>
+            </a:pPr>
+            <a:r>
+              <a:t>⑤ 이벤트 로그/DTC 저장 → 사후 분석 대비</a:t>
+            </a:r>
+          </a:p>
+          <a:p>
+            <a:pPr algn="l">
+              <a:spcBef>
+                <a:spcPts val="0"/>
+              </a:spcBef>
+              <a:spcAft>
+                <a:spcPts val="400"/>
+              </a:spcAft>
               <a:defRPr sz="1100" b="1">
                 <a:solidFill>
                   <a:srgbClr val="0047AB"/>
@@ -6423,7 +6656,7 @@
               </a:defRPr>
             </a:pPr>
             <a:r>
-              <a:t>→ 통신 단절/센서 고장 시에도 승객 안전 100% 확보</a:t>
+              <a:t>→ 정의된 고장 시나리오에서 위험을 안전측으로 저감</a:t>
             </a:r>
           </a:p>
         </p:txBody>
@@ -6436,7 +6669,7 @@
         </p:nvSpPr>
         <p:spPr>
           <a:xfrm>
-            <a:off x="6400800" y="5852160"/>
+            <a:off x="6400800" y="6035040"/>
             <a:ext cx="1554480" cy="640080"/>
           </a:xfrm>
           <a:prstGeom prst="roundRect">
@@ -6482,7 +6715,7 @@
         </p:nvSpPr>
         <p:spPr>
           <a:xfrm>
-            <a:off x="6492240" y="5870448"/>
+            <a:off x="6492240" y="6053328"/>
             <a:ext cx="1371600" cy="548640"/>
           </a:xfrm>
           <a:prstGeom prst="rect">
@@ -6547,7 +6780,7 @@
         </p:nvSpPr>
         <p:spPr>
           <a:xfrm>
-            <a:off x="8138160" y="5852160"/>
+            <a:off x="8138160" y="6035040"/>
             <a:ext cx="1554480" cy="640080"/>
           </a:xfrm>
           <a:prstGeom prst="roundRect">
@@ -6593,7 +6826,7 @@
         </p:nvSpPr>
         <p:spPr>
           <a:xfrm>
-            <a:off x="8229600" y="5870448"/>
+            <a:off x="8229600" y="6053328"/>
             <a:ext cx="1371600" cy="548640"/>
           </a:xfrm>
           <a:prstGeom prst="rect">
@@ -6641,7 +6874,7 @@
               </a:defRPr>
             </a:pPr>
             <a:r>
-              <a:t>ASIL-B 등급</a:t>
+              <a:t>ASIL-B 수준</a:t>
             </a:r>
             <a:br/>
             <a:r>
@@ -6658,7 +6891,7 @@
         </p:nvSpPr>
         <p:spPr>
           <a:xfrm>
-            <a:off x="9875520" y="5852160"/>
+            <a:off x="9875520" y="6035040"/>
             <a:ext cx="1554480" cy="640080"/>
           </a:xfrm>
           <a:prstGeom prst="roundRect">
@@ -6704,7 +6937,7 @@
         </p:nvSpPr>
         <p:spPr>
           <a:xfrm>
-            <a:off x="9966960" y="5870448"/>
+            <a:off x="9966960" y="6053328"/>
             <a:ext cx="1371600" cy="548640"/>
           </a:xfrm>
           <a:prstGeom prst="rect">
@@ -7693,11 +7926,15 @@
               </a:defRPr>
             </a:pPr>
             <a:r>
-              <a:t>Fail-Safe → 센서 고장 시</a:t>
+              <a:t>Fail-Safe → 센서 이상 시</a:t>
             </a:r>
             <a:br/>
             <a:r>
-              <a:t>P단 강제 고정 (안전 정차)</a:t>
+              <a:t>변속 금지 및 안전 상태 유지</a:t>
+            </a:r>
+            <a:br/>
+            <a:r>
+              <a:t>(정차 조건 충족 시에만 P단 허용)</a:t>
             </a:r>
           </a:p>
         </p:txBody>
@@ -8024,7 +8261,7 @@
 </file>
 
 <file path=ppt/slides/slide6.xml><?xml version="1.0" encoding="utf-8"?>
-<p:sld xmlns:r="http://schemas.openxmlformats.org/officeDocument/2006/relationships" xmlns:c="http://schemas.openxmlformats.org/drawingml/2006/chart" xmlns:a="http://schemas.openxmlformats.org/drawingml/2006/main" xmlns:dgm="http://schemas.openxmlformats.org/drawingml/2006/diagram" xmlns:dsp="http://schemas.microsoft.com/office/drawing/2008/diagram" xmlns:p="http://schemas.openxmlformats.org/presentationml/2006/main">
+<p:sld xmlns:a="http://schemas.openxmlformats.org/drawingml/2006/main" xmlns:p="http://schemas.openxmlformats.org/presentationml/2006/main" xmlns:r="http://schemas.openxmlformats.org/officeDocument/2006/relationships">
   <p:cSld>
     <p:spTree>
       <p:nvGrpSpPr>
@@ -8032,14 +8269,7 @@
         <p:cNvGrpSpPr/>
         <p:nvPr/>
       </p:nvGrpSpPr>
-      <p:grpSpPr>
-        <a:xfrm>
-          <a:off x="0" y="0"/>
-          <a:ext cx="0" cy="0"/>
-          <a:chOff x="0" y="0"/>
-          <a:chExt cx="0" cy="0"/>
-        </a:xfrm>
-      </p:grpSpPr>
+      <p:grpSpPr/>
       <p:sp>
         <p:nvSpPr>
           <p:cNvPr id="2" name="Rectangle 1"/>
@@ -8174,94 +8404,58 @@
       </p:sp>
       <p:sp>
         <p:nvSpPr>
-          <p:cNvPr id="7" name="TextBox 6"/>
-          <p:cNvSpPr txBox="1"/>
-          <p:nvPr/>
-        </p:nvSpPr>
-        <p:spPr>
-          <a:xfrm>
-            <a:off x="1371600" y="1828800"/>
-            <a:ext cx="9144000" cy="2743200"/>
+          <p:cNvPr id="5" name="Rectangle 4"/>
+          <p:cNvSpPr/>
+          <p:nvPr/>
+        </p:nvSpPr>
+        <p:spPr>
+          <a:xfrm>
+            <a:off x="9144000" y="5029200"/>
+            <a:ext cx="2743200" cy="914400"/>
           </a:xfrm>
           <a:prstGeom prst="rect">
             <a:avLst/>
           </a:prstGeom>
-          <a:noFill/>
-        </p:spPr>
-        <p:txBody>
-          <a:bodyPr wrap="square">
-            <a:spAutoFit/>
-          </a:bodyPr>
-          <a:lstStyle/>
-          <a:p>
-            <a:pPr algn="l">
-              <a:spcBef>
-                <a:spcPts val="0"/>
-              </a:spcBef>
-              <a:spcAft>
-                <a:spcPts val="400"/>
-              </a:spcAft>
-              <a:defRPr sz="1800" b="0">
-                <a:solidFill>
-                  <a:srgbClr val="CCE5FF"/>
-                </a:solidFill>
-                <a:latin typeface="맑은 고딕"/>
-              </a:defRPr>
-            </a:pPr>
-            <a:r>
-              <a:t>기계공학의 뼈대 위에</a:t>
-            </a:r>
-          </a:p>
-          <a:p>
-            <a:pPr algn="l">
-              <a:spcBef>
-                <a:spcPts val="0"/>
-              </a:spcBef>
-              <a:spcAft>
-                <a:spcPts val="800"/>
-              </a:spcAft>
-              <a:defRPr sz="1800" b="0">
-                <a:solidFill>
-                  <a:srgbClr val="CCE5FF"/>
-                </a:solidFill>
-                <a:latin typeface="맑은 고딕"/>
-              </a:defRPr>
-            </a:pPr>
-            <a:r>
-              <a:t>똑똑한 SW의 두뇌를 탑재하는</a:t>
-            </a:r>
-          </a:p>
-          <a:p>
-            <a:pPr algn="l">
-              <a:spcBef>
-                <a:spcPts val="0"/>
-              </a:spcBef>
-              <a:spcAft>
-                <a:spcPts val="3000"/>
-              </a:spcAft>
-              <a:defRPr sz="3600" b="1">
-                <a:solidFill>
-                  <a:srgbClr val="FFFFFF"/>
-                </a:solidFill>
-                <a:latin typeface="맑은 고딕"/>
-              </a:defRPr>
-            </a:pPr>
-            <a:r>
-              <a:t>에스엘의 미래 파트너.</a:t>
-            </a:r>
-          </a:p>
-        </p:txBody>
-      </p:sp>
-      <p:sp>
-        <p:nvSpPr>
-          <p:cNvPr id="8" name="Rectangle 7"/>
+          <a:solidFill>
+            <a:srgbClr val="0047AB"/>
+          </a:solidFill>
+          <a:ln>
+            <a:noFill/>
+          </a:ln>
+          <a:effectLst/>
+        </p:spPr>
+        <p:style>
+          <a:lnRef idx="1">
+            <a:schemeClr val="accent1"/>
+          </a:lnRef>
+          <a:fillRef idx="3">
+            <a:schemeClr val="accent1"/>
+          </a:fillRef>
+          <a:effectRef idx="2">
+            <a:schemeClr val="accent1"/>
+          </a:effectRef>
+          <a:fontRef idx="minor">
+            <a:schemeClr val="lt1"/>
+          </a:fontRef>
+        </p:style>
+        <p:txBody>
+          <a:bodyPr rtlCol="0" anchor="ctr"/>
+          <a:lstStyle/>
+          <a:p>
+            <a:pPr algn="ctr"/>
+          </a:p>
+        </p:txBody>
+      </p:sp>
+      <p:sp>
+        <p:nvSpPr>
+          <p:cNvPr id="6" name="Rectangle 5"/>
           <p:cNvSpPr/>
           <p:nvPr/>
         </p:nvSpPr>
         <p:spPr>
           <a:xfrm>
-            <a:off x="1371600" y="4206240"/>
-            <a:ext cx="3200400" cy="2743"/>
+            <a:off x="9601200" y="6126480"/>
+            <a:ext cx="2286000" cy="548640"/>
           </a:xfrm>
           <a:prstGeom prst="rect">
             <a:avLst/>
@@ -8298,13 +8492,236 @@
       </p:sp>
       <p:sp>
         <p:nvSpPr>
-          <p:cNvPr id="9" name="Rounded Rectangle 8"/>
+          <p:cNvPr id="7" name="TextBox 6"/>
+          <p:cNvSpPr txBox="1"/>
+          <p:nvPr/>
+        </p:nvSpPr>
+        <p:spPr>
+          <a:xfrm>
+            <a:off x="1371600" y="1371600"/>
+            <a:ext cx="9144000" cy="2286000"/>
+          </a:xfrm>
+          <a:prstGeom prst="rect">
+            <a:avLst/>
+          </a:prstGeom>
+          <a:noFill/>
+        </p:spPr>
+        <p:txBody>
+          <a:bodyPr wrap="square">
+            <a:spAutoFit/>
+          </a:bodyPr>
+          <a:lstStyle/>
+          <a:p>
+            <a:pPr algn="l">
+              <a:spcBef>
+                <a:spcPts val="0"/>
+              </a:spcBef>
+              <a:spcAft>
+                <a:spcPts val="400"/>
+              </a:spcAft>
+              <a:defRPr sz="1800" b="0">
+                <a:solidFill>
+                  <a:srgbClr val="CCE5FF"/>
+                </a:solidFill>
+                <a:latin typeface="맑은 고딕"/>
+              </a:defRPr>
+            </a:pPr>
+            <a:r>
+              <a:t>기계공학의 뼈대 위에</a:t>
+            </a:r>
+          </a:p>
+          <a:p>
+            <a:pPr algn="l">
+              <a:spcBef>
+                <a:spcPts val="0"/>
+              </a:spcBef>
+              <a:spcAft>
+                <a:spcPts val="800"/>
+              </a:spcAft>
+              <a:defRPr sz="1800" b="0">
+                <a:solidFill>
+                  <a:srgbClr val="CCE5FF"/>
+                </a:solidFill>
+                <a:latin typeface="맑은 고딕"/>
+              </a:defRPr>
+            </a:pPr>
+            <a:r>
+              <a:t>똑똑한 SW의 두뇌를 탑재하는</a:t>
+            </a:r>
+          </a:p>
+          <a:p>
+            <a:pPr algn="l">
+              <a:spcBef>
+                <a:spcPts val="0"/>
+              </a:spcBef>
+              <a:spcAft>
+                <a:spcPts val="2000"/>
+              </a:spcAft>
+              <a:defRPr sz="3600" b="1">
+                <a:solidFill>
+                  <a:srgbClr val="FFFFFF"/>
+                </a:solidFill>
+                <a:latin typeface="맑은 고딕"/>
+              </a:defRPr>
+            </a:pPr>
+            <a:r>
+              <a:t>에스엘의 미래 파트너.</a:t>
+            </a:r>
+          </a:p>
+        </p:txBody>
+      </p:sp>
+      <p:sp>
+        <p:nvSpPr>
+          <p:cNvPr id="8" name="Rectangle 7"/>
           <p:cNvSpPr/>
           <p:nvPr/>
         </p:nvSpPr>
         <p:spPr>
           <a:xfrm>
-            <a:off x="1371600" y="4480560"/>
+            <a:off x="1371600" y="3383280"/>
+            <a:ext cx="3200400" cy="2743"/>
+          </a:xfrm>
+          <a:prstGeom prst="rect">
+            <a:avLst/>
+          </a:prstGeom>
+          <a:solidFill>
+            <a:srgbClr val="006ED6"/>
+          </a:solidFill>
+          <a:ln>
+            <a:noFill/>
+          </a:ln>
+          <a:effectLst/>
+        </p:spPr>
+        <p:style>
+          <a:lnRef idx="1">
+            <a:schemeClr val="accent1"/>
+          </a:lnRef>
+          <a:fillRef idx="3">
+            <a:schemeClr val="accent1"/>
+          </a:fillRef>
+          <a:effectRef idx="2">
+            <a:schemeClr val="accent1"/>
+          </a:effectRef>
+          <a:fontRef idx="minor">
+            <a:schemeClr val="lt1"/>
+          </a:fontRef>
+        </p:style>
+        <p:txBody>
+          <a:bodyPr rtlCol="0" anchor="ctr"/>
+          <a:lstStyle/>
+          <a:p>
+            <a:pPr algn="ctr"/>
+          </a:p>
+        </p:txBody>
+      </p:sp>
+      <p:sp>
+        <p:nvSpPr>
+          <p:cNvPr id="9" name="TextBox 8"/>
+          <p:cNvSpPr txBox="1"/>
+          <p:nvPr/>
+        </p:nvSpPr>
+        <p:spPr>
+          <a:xfrm>
+            <a:off x="1371600" y="3520440"/>
+            <a:ext cx="9144000" cy="1463040"/>
+          </a:xfrm>
+          <a:prstGeom prst="rect">
+            <a:avLst/>
+          </a:prstGeom>
+          <a:noFill/>
+        </p:spPr>
+        <p:txBody>
+          <a:bodyPr wrap="square">
+            <a:spAutoFit/>
+          </a:bodyPr>
+          <a:lstStyle/>
+          <a:p>
+            <a:pPr algn="l">
+              <a:spcBef>
+                <a:spcPts val="0"/>
+              </a:spcBef>
+              <a:spcAft>
+                <a:spcPts val="800"/>
+              </a:spcAft>
+              <a:defRPr sz="1300" b="1">
+                <a:solidFill>
+                  <a:srgbClr val="CCE5FF"/>
+                </a:solidFill>
+                <a:latin typeface="맑은 고딕"/>
+              </a:defRPr>
+            </a:pPr>
+            <a:r>
+              <a:t>▎ 이 프로젝트에서 얻은 핵심 인사이트</a:t>
+            </a:r>
+          </a:p>
+          <a:p>
+            <a:pPr algn="l">
+              <a:spcBef>
+                <a:spcPts val="0"/>
+              </a:spcBef>
+              <a:spcAft>
+                <a:spcPts val="400"/>
+              </a:spcAft>
+              <a:defRPr sz="1100" b="0">
+                <a:solidFill>
+                  <a:srgbClr val="FFFFFF"/>
+                </a:solidFill>
+                <a:latin typeface="맑은 고딕"/>
+              </a:defRPr>
+            </a:pPr>
+            <a:r>
+              <a:t>"센서를 믿는 것이 아니라, 센서의 한계를 전제로 상태기계를 설계하는 법을 배웠습니다."</a:t>
+            </a:r>
+          </a:p>
+          <a:p>
+            <a:pPr algn="l">
+              <a:spcBef>
+                <a:spcPts val="0"/>
+              </a:spcBef>
+              <a:spcAft>
+                <a:spcPts val="400"/>
+              </a:spcAft>
+              <a:defRPr sz="1100" b="0">
+                <a:solidFill>
+                  <a:srgbClr val="FFFFFF"/>
+                </a:solidFill>
+                <a:latin typeface="맑은 고딕"/>
+              </a:defRPr>
+            </a:pPr>
+            <a:r>
+              <a:t>"기계 응답 시간과 마모 메커니즘을 이해해야 SW 타이머도 의미 있게 설계할 수 있다는 점을 배웠습니다."</a:t>
+            </a:r>
+          </a:p>
+          <a:p>
+            <a:pPr algn="l">
+              <a:spcBef>
+                <a:spcPts val="0"/>
+              </a:spcBef>
+              <a:spcAft>
+                <a:spcPts val="400"/>
+              </a:spcAft>
+              <a:defRPr sz="1100" b="0">
+                <a:solidFill>
+                  <a:srgbClr val="FFFFFF"/>
+                </a:solidFill>
+                <a:latin typeface="맑은 고딕"/>
+              </a:defRPr>
+            </a:pPr>
+            <a:r>
+              <a:t>"Fail-Safe는 오류를 없애는 것이 아니라, 오류가 나도 안전측으로 전이시키는 설계라는 점을 체득했습니다."</a:t>
+            </a:r>
+          </a:p>
+        </p:txBody>
+      </p:sp>
+      <p:sp>
+        <p:nvSpPr>
+          <p:cNvPr id="10" name="Rounded Rectangle 9"/>
+          <p:cNvSpPr/>
+          <p:nvPr/>
+        </p:nvSpPr>
+        <p:spPr>
+          <a:xfrm>
+            <a:off x="1371600" y="5120640"/>
             <a:ext cx="1828800" cy="274320"/>
           </a:xfrm>
           <a:prstGeom prst="roundRect">
@@ -8352,13 +8769,13 @@
       </p:sp>
       <p:sp>
         <p:nvSpPr>
-          <p:cNvPr id="10" name="Rounded Rectangle 9"/>
+          <p:cNvPr id="11" name="Rounded Rectangle 10"/>
           <p:cNvSpPr/>
           <p:nvPr/>
         </p:nvSpPr>
         <p:spPr>
           <a:xfrm>
-            <a:off x="3383280" y="4480560"/>
+            <a:off x="3383280" y="5120640"/>
             <a:ext cx="1828800" cy="274320"/>
           </a:xfrm>
           <a:prstGeom prst="roundRect">
@@ -8406,13 +8823,13 @@
       </p:sp>
       <p:sp>
         <p:nvSpPr>
-          <p:cNvPr id="11" name="Rounded Rectangle 10"/>
+          <p:cNvPr id="12" name="Rounded Rectangle 11"/>
           <p:cNvSpPr/>
           <p:nvPr/>
         </p:nvSpPr>
         <p:spPr>
           <a:xfrm>
-            <a:off x="5394960" y="4480560"/>
+            <a:off x="5394960" y="5120640"/>
             <a:ext cx="1828800" cy="274320"/>
           </a:xfrm>
           <a:prstGeom prst="roundRect">
@@ -8460,13 +8877,13 @@
       </p:sp>
       <p:sp>
         <p:nvSpPr>
-          <p:cNvPr id="12" name="Rounded Rectangle 11"/>
+          <p:cNvPr id="13" name="Rounded Rectangle 12"/>
           <p:cNvSpPr/>
           <p:nvPr/>
         </p:nvSpPr>
         <p:spPr>
           <a:xfrm>
-            <a:off x="7406640" y="4480560"/>
+            <a:off x="7406640" y="5120640"/>
             <a:ext cx="1828800" cy="274320"/>
           </a:xfrm>
           <a:prstGeom prst="roundRect">
@@ -8514,13 +8931,13 @@
       </p:sp>
       <p:sp>
         <p:nvSpPr>
-          <p:cNvPr id="13" name="Rounded Rectangle 12"/>
+          <p:cNvPr id="14" name="Rounded Rectangle 13"/>
           <p:cNvSpPr/>
           <p:nvPr/>
         </p:nvSpPr>
         <p:spPr>
           <a:xfrm>
-            <a:off x="9418320" y="4480560"/>
+            <a:off x="9418320" y="5120640"/>
             <a:ext cx="1828800" cy="274320"/>
           </a:xfrm>
           <a:prstGeom prst="roundRect">
@@ -8568,13 +8985,13 @@
       </p:sp>
       <p:sp>
         <p:nvSpPr>
-          <p:cNvPr id="14" name="TextBox 13"/>
+          <p:cNvPr id="15" name="TextBox 14"/>
           <p:cNvSpPr txBox="1"/>
           <p:nvPr/>
         </p:nvSpPr>
         <p:spPr>
           <a:xfrm>
-            <a:off x="1371600" y="5120640"/>
+            <a:off x="1371600" y="5623560"/>
             <a:ext cx="9144000" cy="914400"/>
           </a:xfrm>
           <a:prstGeom prst="rect">
@@ -8604,6 +9021,42 @@
             </a:pPr>
             <a:r>
               <a:t>경청해 주셔서 감사합니다.</a:t>
+            </a:r>
+          </a:p>
+        </p:txBody>
+      </p:sp>
+      <p:sp>
+        <p:nvSpPr>
+          <p:cNvPr id="16" name="TextBox 15"/>
+          <p:cNvSpPr txBox="1"/>
+          <p:nvPr/>
+        </p:nvSpPr>
+        <p:spPr>
+          <a:xfrm>
+            <a:off x="11430000" y="6446520"/>
+            <a:ext cx="640080" cy="320040"/>
+          </a:xfrm>
+          <a:prstGeom prst="rect">
+            <a:avLst/>
+          </a:prstGeom>
+          <a:noFill/>
+        </p:spPr>
+        <p:txBody>
+          <a:bodyPr wrap="square">
+            <a:spAutoFit/>
+          </a:bodyPr>
+          <a:lstStyle/>
+          <a:p>
+            <a:pPr algn="r">
+              <a:defRPr sz="900" b="0">
+                <a:solidFill>
+                  <a:srgbClr val="666677"/>
+                </a:solidFill>
+                <a:latin typeface="맑은 고딕"/>
+              </a:defRPr>
+            </a:pPr>
+            <a:r>
+              <a:t>6 / 6</a:t>
             </a:r>
           </a:p>
         </p:txBody>
@@ -8617,41 +9070,41 @@
 </file>
 
 <file path=ppt/theme/theme1.xml><?xml version="1.0" encoding="utf-8"?>
-<a:theme xmlns:r="http://schemas.openxmlformats.org/officeDocument/2006/relationships" xmlns:c="http://schemas.openxmlformats.org/drawingml/2006/chart" xmlns:dgm="http://schemas.openxmlformats.org/drawingml/2006/diagram" xmlns:dsp="http://schemas.microsoft.com/office/drawing/2008/diagram" xmlns:a="http://schemas.openxmlformats.org/drawingml/2006/main" xmlns:pic="http://schemas.openxmlformats.org/drawingml/2006/picture" xmlns:wp="http://schemas.openxmlformats.org/drawingml/2006/wordprocessingDrawing" xmlns:xdr="http://schemas.openxmlformats.org/drawingml/2006/spreadsheetDrawing" xmlns:lc="http://schemas.openxmlformats.org/drawingml/2006/lockedCanvas" xmlns:p="http://schemas.openxmlformats.org/presentationml/2006/main" name="Office Theme">
+<a:theme xmlns:a="http://schemas.openxmlformats.org/drawingml/2006/main" name="Office Theme">
   <a:themeElements>
     <a:clrScheme name="Office">
       <a:dk1>
         <a:sysClr val="windowText" lastClr="000000"/>
       </a:dk1>
       <a:lt1>
-        <a:sysClr val="window" lastClr="ffffff"/>
+        <a:sysClr val="window" lastClr="FFFFFF"/>
       </a:lt1>
       <a:dk2>
-        <a:srgbClr val="1f497d"/>
+        <a:srgbClr val="1F497D"/>
       </a:dk2>
       <a:lt2>
-        <a:srgbClr val="eeece1"/>
+        <a:srgbClr val="EEECE1"/>
       </a:lt2>
       <a:accent1>
-        <a:srgbClr val="4f81bd"/>
+        <a:srgbClr val="4F81BD"/>
       </a:accent1>
       <a:accent2>
-        <a:srgbClr val="c0504d"/>
+        <a:srgbClr val="C0504D"/>
       </a:accent2>
       <a:accent3>
-        <a:srgbClr val="9bbb59"/>
+        <a:srgbClr val="9BBB59"/>
       </a:accent3>
       <a:accent4>
-        <a:srgbClr val="8064a2"/>
+        <a:srgbClr val="8064A2"/>
       </a:accent4>
       <a:accent5>
-        <a:srgbClr val="4bacc6"/>
+        <a:srgbClr val="4BACC6"/>
       </a:accent5>
       <a:accent6>
-        <a:srgbClr val="f79646"/>
+        <a:srgbClr val="F79646"/>
       </a:accent6>
       <a:hlink>
-        <a:srgbClr val="0000ff"/>
+        <a:srgbClr val="0000FF"/>
       </a:hlink>
       <a:folHlink>
         <a:srgbClr val="800080"/>
@@ -8662,9 +9115,9 @@
         <a:latin typeface="Calibri"/>
         <a:ea typeface=""/>
         <a:cs typeface=""/>
-        <a:font script="Jpan" typeface="MS PGothic"/>
+        <a:font script="Jpan" typeface="ＭＳ Ｐゴシック"/>
         <a:font script="Hang" typeface="맑은 고딕"/>
-        <a:font script="Hans" typeface="SimSun"/>
+        <a:font script="Hans" typeface="宋体"/>
         <a:font script="Hant" typeface="新細明體"/>
         <a:font script="Arab" typeface="Times New Roman"/>
         <a:font script="Hebr" typeface="Times New Roman"/>
@@ -8697,9 +9150,9 @@
         <a:latin typeface="Calibri"/>
         <a:ea typeface=""/>
         <a:cs typeface=""/>
-        <a:font script="Jpan" typeface="MS PGothic"/>
+        <a:font script="Jpan" typeface="ＭＳ Ｐゴシック"/>
         <a:font script="Hang" typeface="맑은 고딕"/>
-        <a:font script="Hans" typeface="SimSun"/>
+        <a:font script="Hans" typeface="宋体"/>
         <a:font script="Hant" typeface="新細明體"/>
         <a:font script="Arab" typeface="Arial"/>
         <a:font script="Hebr" typeface="Arial"/>
@@ -8931,11 +9384,7 @@
         </a:fontRef>
       </a:style>
     </a:lnDef>
-    <a:txDef>
-      <a:spPr/>
-      <a:bodyPr/>
-      <a:lstStyle/>
-    </a:txDef>
   </a:objectDefaults>
+  <a:extraClrSchemeLst/>
 </a:theme>
 </file>
</xml_diff>